<commit_message>
Deck: what L solves and does not, two-track roadmap slide (18 slides)
Co-Authored-By: Claude Sonnet 5.5 <noreply@anthropic.com>
Claude-Session: https://claude.ai/code/session_013SV3SfseaABNzbLHJy34eL
</commit_message>
<xml_diff>
--- a/docs/L_pitch_draft.pptx
+++ b/docs/L_pitch_draft.pptx
@@ -21,9 +21,11 @@
     <p:sldId id="269" r:id="rId15"/>
     <p:sldId id="270" r:id="rId16"/>
     <p:sldId id="271" r:id="rId17"/>
+    <p:sldId id="272" r:id="rId18"/>
+    <p:sldId id="273" r:id="rId19"/>
   </p:sldIdLst>
   <p:notesMasterIdLst>
-    <p:notesMasterId r:id="rId18"/>
+    <p:notesMasterId r:id="rId20"/>
   </p:notesMasterIdLst>
   <p:sldSz cx="9144000" cy="5143500"/>
   <p:notesSz cx="5143500" cy="9144000"/>
@@ -122,18 +124,18 @@
   <p:extLst>
     <p:ext uri="{521415D9-36F7-43E2-AB2F-B90AF26B5E84}">
       <p14:sectionLst xmlns:p14="http://schemas.microsoft.com/office/powerpoint/2010/main">
-        <p14:section name="Open" id="{bfc07ff8-ad4b-de3f-8a64-b2dde4fbc8fd}">
+        <p14:section name="Open" id="{2020365c-0ae3-34aa-913e-74444ef698de}">
           <p14:sldIdLst>
             <p14:sldId id="256"/>
           </p14:sldIdLst>
         </p14:section>
-        <p14:section name="Why" id="{032574ad-e771-26d0-95df-138122d573ca}">
+        <p14:section name="Why" id="{1b147422-f91c-b7b5-9436-7df7600e48b5}">
           <p14:sldIdLst>
             <p14:sldId id="257"/>
             <p14:sldId id="258"/>
           </p14:sldIdLst>
         </p14:section>
-        <p14:section name="Results" id="{a02bf8bc-7d42-4f1b-9647-6ca4ab40d260}">
+        <p14:section name="Results" id="{c17449ae-f85a-74d6-d213-de6d5af3f4df}">
           <p14:sldIdLst>
             <p14:sldId id="259"/>
             <p14:sldId id="260"/>
@@ -144,22 +146,24 @@
             <p14:sldId id="265"/>
           </p14:sldIdLst>
         </p14:section>
-        <p14:section name="Build" id="{63c43a44-5cf8-8091-e2f2-163dcba7ec3c}">
+        <p14:section name="Build" id="{9e8fddcb-83ae-7ce0-f4f3-4f594dc4d349}">
           <p14:sldIdLst>
             <p14:sldId id="266"/>
             <p14:sldId id="267"/>
           </p14:sldIdLst>
         </p14:section>
-        <p14:section name="Honest" id="{464a9561-8ee5-baf6-f14f-b2c097d6adac}">
+        <p14:section name="Honest" id="{2d829c2f-225d-7168-7808-9b68cd68324e}">
           <p14:sldIdLst>
             <p14:sldId id="268"/>
             <p14:sldId id="269"/>
+            <p14:sldId id="270"/>
           </p14:sldIdLst>
         </p14:section>
-        <p14:section name="Next" id="{4141a7c8-6ec6-9f1e-c1fc-16e8c3b39bb6}">
+        <p14:section name="Next" id="{159c12d9-4a4a-71ff-917d-ccf5c56edc7d}">
           <p14:sldIdLst>
-            <p14:sldId id="270"/>
             <p14:sldId id="271"/>
+            <p14:sldId id="272"/>
+            <p14:sldId id="273"/>
           </p14:sldIdLst>
         </p14:section>
       </p14:sectionLst>
@@ -3296,7 +3300,7 @@
           <a:p>
             <a:r>
               <a:rPr lang="en-US" dirty="0"/>
-              <a:t>Because the memory is counts, two chips that learned different classes can be merged by adding their counters, or one chip hands its memory to another that keeps learning. Merge gives 93, 81 and 64 percent; hand-over gives 96, 83 and 72. This is weight transfer without a server.</a:t>
+              <a:t>One chip works alone; sharing is an option. Because the memory is counts, two chips that learned different classes can be merged by adding their counters, or one chip hands its memory to another that keeps learning. Merge gives 93, 81 and 64 percent; hand-over gives 96, 83 and 72. A normal network cannot merge two separately trained copies like this. A GPU cluster joins many GPUs for size and speed, which is a different thing.</a:t>
             </a:r>
             <a:endParaRPr lang="en-US" dirty="0"/>
           </a:p>
@@ -3560,7 +3564,7 @@
           <a:p>
             <a:r>
               <a:rPr lang="en-US" dirty="0"/>
-              <a:t>This is the slide I want you to remember. Nothing has run on hardware. Staged clothing is about 82 percent, five points under its one-pass number, and I tried many fixes. A trained CNN is still ahead on clothing by about two points. The tests are small and the noise is simulated; the two-sense data is paired by class, not real audio-visual recordings. The second look costs about 2.8 times the memory, and a few steps still run on the host.</a:t>
+              <a:t>Be clear about scope. L solves a small part of the AI problem: devices that must keep learning in the field without retraining on a server and without being thrown away. That is simulated, and the energy figure is an estimate. L does not solve what is driving GPU and memory prices today, which is large language models and image generators in data centres. It also cannot run existing models: it is a dedicated chip for its own model. And nothing is measured on hardware yet.</a:t>
             </a:r>
             <a:endParaRPr lang="en-US" dirty="0"/>
           </a:p>
@@ -3648,7 +3652,7 @@
           <a:p>
             <a:r>
               <a:rPr lang="en-US" dirty="0"/>
-              <a:t>We are not the first continual-learning chip. Hyperdimensional-computing accelerators and event-driven spiking chips such as Loihi 2, TrueNorth and SpiNNaker exist. What we add is the combination: dreams from small counters so no examples are stored, a night that ends by itself, consolidation that scales with the data, and a design with no multiplier or matrix that is bit-exact from raw senses to the decision.</a:t>
+              <a:t>This is the slide I want you to remember. Nothing has run on hardware. Staged clothing is about 82 percent, five points under its one-pass number, and I tried many fixes. A trained CNN is still ahead on clothing by about two points. The tests are small and the noise is simulated; the two-sense data is paired by class, not real audio-visual recordings. The second look costs about 2.8 times the memory, and a few steps still run on the host.</a:t>
             </a:r>
             <a:endParaRPr lang="en-US" dirty="0"/>
           </a:p>
@@ -3736,7 +3740,7 @@
           <a:p>
             <a:r>
               <a:rPr lang="en-US" dirty="0"/>
-              <a:t>What comes next. The model and RTL are done and verified in simulation. The next milestone is the real Tang Nano board, which gives the first measured numbers. Then harder tests: a larger vocabulary, real recorded noise and a harder image set. Later, a matrix-free chip for the L language model, and external memory for sound and the second look. No fabrication is planned yet.</a:t>
+              <a:t>We are not the first continual-learning chip. Hyperdimensional-computing accelerators and event-driven spiking chips such as Loihi 2, TrueNorth and SpiNNaker exist. What we add is the combination: dreams from small counters so no examples are stored, a night that ends by itself, consolidation that scales with the data, and a design with no multiplier or matrix that is bit-exact from raw senses to the decision.</a:t>
             </a:r>
             <a:endParaRPr lang="en-US" dirty="0"/>
           </a:p>
@@ -3824,7 +3828,7 @@
           <a:p>
             <a:r>
               <a:rPr lang="en-US" dirty="0"/>
-              <a:t>To close: L is a chip design that keeps learning after it ships. It keeps what it knew, shares what it learned, and needs no multiplier. It is weaker than a trained network in a few places, and I have told you where. Thank you, I am happy to take questions.</a:t>
+              <a:t>What comes next. The model and RTL are done and verified in simulation. The next milestone is the real Tang Nano board, which gives the first measured numbers. Then harder tests: a larger vocabulary, real recorded noise and a harder image set. Later, a matrix-free chip for the L language model, and external memory for sound and the second look. No fabrication is planned yet.</a:t>
             </a:r>
             <a:endParaRPr lang="en-US" dirty="0"/>
           </a:p>
@@ -3848,6 +3852,182 @@
             <a:fld id="{F7021451-1387-4CA6-816F-3879F97B5CBC}" type="slidenum">
               <a:rPr lang="en-US"/>
               <a:t>16</a:t>
+            </a:fld>
+            <a:endParaRPr lang="en-US"/>
+          </a:p>
+        </p:txBody>
+      </p:sp>
+    </p:spTree>
+    <p:extLst>
+      <p:ext uri="{BB962C8B-B14F-4D97-AF65-F5344CB8AC3E}">
+        <p14:creationId xmlns:p14="http://schemas.microsoft.com/office/powerpoint/2010/main" val="1024086991"/>
+      </p:ext>
+    </p:extLst>
+  </p:cSld>
+  <p:clrMapOvr>
+    <a:masterClrMapping/>
+  </p:clrMapOvr>
+</p:notes>
+</file>
+
+<file path=ppt/notesSlides/notesSlide17.xml><?xml version="1.0" encoding="utf-8"?>
+<p:notes xmlns:a="http://schemas.openxmlformats.org/drawingml/2006/main" xmlns:r="http://schemas.openxmlformats.org/officeDocument/2006/relationships" xmlns:p="http://schemas.openxmlformats.org/presentationml/2006/main">
+  <p:cSld>
+    <p:spTree>
+      <p:nvGrpSpPr>
+        <p:cNvPr id="1" name=""/>
+        <p:cNvGrpSpPr/>
+        <p:nvPr/>
+      </p:nvGrpSpPr>
+      <p:grpSpPr>
+        <a:xfrm>
+          <a:off x="0" y="0"/>
+          <a:ext cx="0" cy="0"/>
+          <a:chOff x="0" y="0"/>
+          <a:chExt cx="0" cy="0"/>
+        </a:xfrm>
+      </p:grpSpPr>
+      <p:sp>
+        <p:nvSpPr>
+          <p:cNvPr id="2" name="Slide Image Placeholder 1"/>
+          <p:cNvSpPr>
+            <a:spLocks noGrp="1" noRot="1" noChangeAspect="1"/>
+          </p:cNvSpPr>
+          <p:nvPr>
+            <p:ph type="sldImg"/>
+          </p:nvPr>
+        </p:nvSpPr>
+        <p:spPr/>
+      </p:sp>
+      <p:sp>
+        <p:nvSpPr>
+          <p:cNvPr id="3" name="Notes Placeholder 2"/>
+          <p:cNvSpPr>
+            <a:spLocks noGrp="1"/>
+          </p:cNvSpPr>
+          <p:nvPr>
+            <p:ph type="body" idx="1"/>
+          </p:nvPr>
+        </p:nvSpPr>
+        <p:spPr/>
+        <p:txBody>
+          <a:bodyPr/>
+          <a:lstStyle/>
+          <a:p>
+            <a:r>
+              <a:rPr lang="en-US" dirty="0"/>
+              <a:t>We plan to approach the bigger problem on two tracks. Track one is the L chip, which is done in simulation and next goes to a real board. Track two is the L AI model for language, which has small-scale evidence only, so it goes through gates: first measure the model, then compare against a fused GPU implementation and stop if the GPU is already close, then check that a matrix-free version keeps its quality. Only then a simulator and an FPGA. Later we study memory: whether the constant-size state and event-driven reads can move work from scarce high-bandwidth memory to cheaper DRAM or on-chip memory. That is a question to study, not a claim.</a:t>
+            </a:r>
+            <a:endParaRPr lang="en-US" dirty="0"/>
+          </a:p>
+        </p:txBody>
+      </p:sp>
+      <p:sp>
+        <p:nvSpPr>
+          <p:cNvPr id="4" name="Slide Number Placeholder 3"/>
+          <p:cNvSpPr>
+            <a:spLocks noGrp="1"/>
+          </p:cNvSpPr>
+          <p:nvPr>
+            <p:ph type="sldNum" sz="quarter" idx="10"/>
+          </p:nvPr>
+        </p:nvSpPr>
+        <p:spPr/>
+        <p:txBody>
+          <a:bodyPr/>
+          <a:lstStyle/>
+          <a:p>
+            <a:fld id="{F7021451-1387-4CA6-816F-3879F97B5CBC}" type="slidenum">
+              <a:rPr lang="en-US"/>
+              <a:t>17</a:t>
+            </a:fld>
+            <a:endParaRPr lang="en-US"/>
+          </a:p>
+        </p:txBody>
+      </p:sp>
+    </p:spTree>
+    <p:extLst>
+      <p:ext uri="{BB962C8B-B14F-4D97-AF65-F5344CB8AC3E}">
+        <p14:creationId xmlns:p14="http://schemas.microsoft.com/office/powerpoint/2010/main" val="1024086991"/>
+      </p:ext>
+    </p:extLst>
+  </p:cSld>
+  <p:clrMapOvr>
+    <a:masterClrMapping/>
+  </p:clrMapOvr>
+</p:notes>
+</file>
+
+<file path=ppt/notesSlides/notesSlide18.xml><?xml version="1.0" encoding="utf-8"?>
+<p:notes xmlns:a="http://schemas.openxmlformats.org/drawingml/2006/main" xmlns:r="http://schemas.openxmlformats.org/officeDocument/2006/relationships" xmlns:p="http://schemas.openxmlformats.org/presentationml/2006/main">
+  <p:cSld>
+    <p:spTree>
+      <p:nvGrpSpPr>
+        <p:cNvPr id="1" name=""/>
+        <p:cNvGrpSpPr/>
+        <p:nvPr/>
+      </p:nvGrpSpPr>
+      <p:grpSpPr>
+        <a:xfrm>
+          <a:off x="0" y="0"/>
+          <a:ext cx="0" cy="0"/>
+          <a:chOff x="0" y="0"/>
+          <a:chExt cx="0" cy="0"/>
+        </a:xfrm>
+      </p:grpSpPr>
+      <p:sp>
+        <p:nvSpPr>
+          <p:cNvPr id="2" name="Slide Image Placeholder 1"/>
+          <p:cNvSpPr>
+            <a:spLocks noGrp="1" noRot="1" noChangeAspect="1"/>
+          </p:cNvSpPr>
+          <p:nvPr>
+            <p:ph type="sldImg"/>
+          </p:nvPr>
+        </p:nvSpPr>
+        <p:spPr/>
+      </p:sp>
+      <p:sp>
+        <p:nvSpPr>
+          <p:cNvPr id="3" name="Notes Placeholder 2"/>
+          <p:cNvSpPr>
+            <a:spLocks noGrp="1"/>
+          </p:cNvSpPr>
+          <p:nvPr>
+            <p:ph type="body" idx="1"/>
+          </p:nvPr>
+        </p:nvSpPr>
+        <p:spPr/>
+        <p:txBody>
+          <a:bodyPr/>
+          <a:lstStyle/>
+          <a:p>
+            <a:r>
+              <a:rPr lang="en-US" dirty="0"/>
+              <a:t>To close: L is a chip design that keeps learning after it ships. It keeps what it knew, shares what it learned, and needs no multiplier. It is weaker than a trained network in a few places, and I have told you where. Thank you, I am happy to take questions.</a:t>
+            </a:r>
+            <a:endParaRPr lang="en-US" dirty="0"/>
+          </a:p>
+        </p:txBody>
+      </p:sp>
+      <p:sp>
+        <p:nvSpPr>
+          <p:cNvPr id="4" name="Slide Number Placeholder 3"/>
+          <p:cNvSpPr>
+            <a:spLocks noGrp="1"/>
+          </p:cNvSpPr>
+          <p:nvPr>
+            <p:ph type="sldNum" sz="quarter" idx="10"/>
+          </p:nvPr>
+        </p:nvSpPr>
+        <p:spPr/>
+        <p:txBody>
+          <a:bodyPr/>
+          <a:lstStyle/>
+          <a:p>
+            <a:fld id="{F7021451-1387-4CA6-816F-3879F97B5CBC}" type="slidenum">
+              <a:rPr lang="en-US"/>
+              <a:t>18</a:t>
             </a:fld>
             <a:endParaRPr lang="en-US"/>
           </a:p>
@@ -5352,7 +5532,7 @@
                 <a:ea typeface="Cambria" pitchFamily="34" charset="-122"/>
                 <a:cs typeface="Cambria" pitchFamily="34" charset="-120"/>
               </a:rPr>
-              <a:t>Knowledge moves between chips</a:t>
+              <a:t>Two chips can share what they learned</a:t>
             </a:r>
             <a:endParaRPr lang="en-US" sz="3000" dirty="0"/>
           </a:p>
@@ -5449,7 +5629,7 @@
         <p:spPr>
           <a:xfrm>
             <a:off x="6126480" y="1783080"/>
-            <a:ext cx="2377440" cy="2560320"/>
+            <a:ext cx="2377440" cy="2651760"/>
           </a:xfrm>
           <a:prstGeom prst="rect">
             <a:avLst/>
@@ -5465,7 +5645,7 @@
               <a:buNone/>
             </a:pPr>
             <a:r>
-              <a:rPr lang="en-US" sz="1300" dirty="0">
+              <a:rPr lang="en-US" sz="1200" dirty="0">
                 <a:solidFill>
                   <a:schemeClr val="tx1"/>
                 </a:solidFill>
@@ -5473,9 +5653,9 @@
                 <a:ea typeface="Calibri" pitchFamily="34" charset="-122"/>
                 <a:cs typeface="Calibri" pitchFamily="34" charset="-120"/>
               </a:rPr>
-              <a:t>Because memory is counts, two chips that learned different classes merge by adding counters. No retraining on a server. The board demo design reached 91.4% on all ten digits after one night (PC-side emulator).</a:t>
-            </a:r>
-            <a:endParaRPr lang="en-US" sz="1300" dirty="0"/>
+              <a:t>One chip works alone; this is an option. Because memory is counts, two chips that learned different classes merge by adding counters, with no retraining. A trained network cannot merge this way. The board demo design reached 91.4% on all ten digits after one night (PC-side emulator).</a:t>
+            </a:r>
+            <a:endParaRPr lang="en-US" sz="1200" dirty="0"/>
           </a:p>
         </p:txBody>
       </p:sp>
@@ -6709,7 +6889,7 @@
                 <a:ea typeface="Cambria" pitchFamily="34" charset="-122"/>
                 <a:cs typeface="Cambria" pitchFamily="34" charset="-120"/>
               </a:rPr>
-              <a:t>Where it is level, and where it is weaker</a:t>
+              <a:t>What L solves, and what it does not</a:t>
             </a:r>
             <a:endParaRPr lang="en-US" sz="3000" dirty="0"/>
           </a:p>
@@ -6717,14 +6897,68 @@
       </p:sp>
       <p:sp>
         <p:nvSpPr>
-          <p:cNvPr id="3" name="Text 1"/>
+          <p:cNvPr id="3" name="card"/>
+          <p:cNvSpPr/>
+          <p:nvPr/>
+        </p:nvSpPr>
+        <p:spPr>
+          <a:xfrm>
+            <a:off x="457200" y="1280160"/>
+            <a:ext cx="4023360" cy="3291840"/>
+          </a:xfrm>
+          <a:prstGeom prst="roundRect">
+            <a:avLst>
+              <a:gd name="adj" fmla="val 2778"/>
+            </a:avLst>
+          </a:prstGeom>
+          <a:solidFill>
+            <a:schemeClr val="bg2"/>
+          </a:solidFill>
+          <a:ln w="12700">
+            <a:solidFill>
+              <a:schemeClr val="bg2"/>
+            </a:solidFill>
+            <a:prstDash val="solid"/>
+          </a:ln>
+        </p:spPr>
+      </p:sp>
+      <p:sp>
+        <p:nvSpPr>
+          <p:cNvPr id="4" name="card"/>
+          <p:cNvSpPr/>
+          <p:nvPr/>
+        </p:nvSpPr>
+        <p:spPr>
+          <a:xfrm>
+            <a:off x="4663440" y="1280160"/>
+            <a:ext cx="4023360" cy="3291840"/>
+          </a:xfrm>
+          <a:prstGeom prst="roundRect">
+            <a:avLst>
+              <a:gd name="adj" fmla="val 2778"/>
+            </a:avLst>
+          </a:prstGeom>
+          <a:solidFill>
+            <a:schemeClr val="bg2"/>
+          </a:solidFill>
+          <a:ln w="12700">
+            <a:solidFill>
+              <a:schemeClr val="bg2"/>
+            </a:solidFill>
+            <a:prstDash val="solid"/>
+          </a:ln>
+        </p:spPr>
+      </p:sp>
+      <p:sp>
+        <p:nvSpPr>
+          <p:cNvPr id="5" name="Text 3"/>
           <p:cNvSpPr txBox="1"/>
           <p:nvPr/>
         </p:nvSpPr>
         <p:spPr>
           <a:xfrm>
-            <a:off x="457200" y="1280160"/>
-            <a:ext cx="8229600" cy="3291840"/>
+            <a:off x="640080" y="1417320"/>
+            <a:ext cx="3657600" cy="365760"/>
           </a:xfrm>
           <a:prstGeom prst="rect">
             <a:avLst/>
@@ -6736,15 +6970,54 @@
           <a:bodyPr wrap="square" lIns="0" tIns="0" rIns="0" bIns="0" rtlCol="0" anchor="t"/>
           <a:lstStyle/>
           <a:p>
+            <a:pPr indent="0" marL="0">
+              <a:buNone/>
+            </a:pPr>
+            <a:r>
+              <a:rPr lang="en-US" sz="2000" b="1" dirty="0">
+                <a:solidFill>
+                  <a:schemeClr val="accent3"/>
+                </a:solidFill>
+                <a:latin typeface="Cambria" pitchFamily="34" charset="0"/>
+                <a:ea typeface="Cambria" pitchFamily="34" charset="-122"/>
+                <a:cs typeface="Cambria" pitchFamily="34" charset="-120"/>
+              </a:rPr>
+              <a:t>What L solves</a:t>
+            </a:r>
+            <a:endParaRPr lang="en-US" sz="2000" dirty="0"/>
+          </a:p>
+        </p:txBody>
+      </p:sp>
+      <p:sp>
+        <p:nvSpPr>
+          <p:cNvPr id="6" name="Text 4"/>
+          <p:cNvSpPr txBox="1"/>
+          <p:nvPr/>
+        </p:nvSpPr>
+        <p:spPr>
+          <a:xfrm>
+            <a:off x="640080" y="1874520"/>
+            <a:ext cx="3657600" cy="2560320"/>
+          </a:xfrm>
+          <a:prstGeom prst="rect">
+            <a:avLst/>
+          </a:prstGeom>
+          <a:noFill/>
+          <a:ln/>
+        </p:spPr>
+        <p:txBody>
+          <a:bodyPr wrap="square" lIns="0" tIns="0" rIns="0" bIns="0" rtlCol="0" anchor="t"/>
+          <a:lstStyle/>
+          <a:p>
             <a:pPr marL="342900" indent="-342900">
               <a:spcAft>
-                <a:spcPts val="900"/>
+                <a:spcPts val="600"/>
               </a:spcAft>
               <a:buSzPct val="100000"/>
               <a:buChar char="•"/>
             </a:pPr>
             <a:r>
-              <a:rPr lang="en-US" sz="1600" dirty="0">
+              <a:rPr lang="en-US" sz="1300" dirty="0">
                 <a:solidFill>
                   <a:schemeClr val="tx1"/>
                 </a:solidFill>
@@ -6752,20 +7025,20 @@
                 <a:ea typeface="Calibri" pitchFamily="34" charset="-122"/>
                 <a:cs typeface="Calibri" pitchFamily="34" charset="-120"/>
               </a:rPr>
-              <a:t>Nothing is measured on hardware yet: every chip number is simulated</a:t>
-            </a:r>
-            <a:endParaRPr lang="en-US" sz="1600" dirty="0"/>
+              <a:t>Small AI on devices that must keep learning: no retraining on a server, no hardware thrown away to update it (SIMULATED)</a:t>
+            </a:r>
+            <a:endParaRPr lang="en-US" sz="1300" dirty="0"/>
           </a:p>
           <a:p>
             <a:pPr marL="342900" indent="-342900">
               <a:spcAft>
-                <a:spcPts val="900"/>
+                <a:spcPts val="600"/>
               </a:spcAft>
               <a:buSzPct val="100000"/>
               <a:buChar char="•"/>
             </a:pPr>
             <a:r>
-              <a:rPr lang="en-US" sz="1600" dirty="0">
+              <a:rPr lang="en-US" sz="1300" dirty="0">
                 <a:solidFill>
                   <a:schemeClr val="tx1"/>
                 </a:solidFill>
@@ -6773,20 +7046,99 @@
                 <a:ea typeface="Calibri" pitchFamily="34" charset="-122"/>
                 <a:cs typeface="Calibri" pitchFamily="34" charset="-120"/>
               </a:rPr>
-              <a:t>Staged clothing about 82%, 5 points below its one pass; many ideas tried</a:t>
-            </a:r>
-            <a:endParaRPr lang="en-US" sz="1600" dirty="0"/>
-          </a:p>
+              <a:t>No stored examples, 84 KB of memory for images, no multiplier</a:t>
+            </a:r>
+            <a:endParaRPr lang="en-US" sz="1300" dirty="0"/>
+          </a:p>
+          <a:p>
+            <a:pPr marL="342900" indent="-342900">
+              <a:buSzPct val="100000"/>
+              <a:buChar char="•"/>
+            </a:pPr>
+            <a:r>
+              <a:rPr lang="en-US" sz="1300" dirty="0">
+                <a:solidFill>
+                  <a:schemeClr val="tx1"/>
+                </a:solidFill>
+                <a:latin typeface="Calibri" pitchFamily="34" charset="0"/>
+                <a:ea typeface="Calibri" pitchFamily="34" charset="-122"/>
+                <a:cs typeface="Calibri" pitchFamily="34" charset="-120"/>
+              </a:rPr>
+              <a:t>About 74x less energy per decision than an 8-bit network, counting operations needed (ESTIMATED)</a:t>
+            </a:r>
+            <a:endParaRPr lang="en-US" sz="1300" dirty="0"/>
+          </a:p>
+        </p:txBody>
+      </p:sp>
+      <p:sp>
+        <p:nvSpPr>
+          <p:cNvPr id="7" name="Text 5"/>
+          <p:cNvSpPr txBox="1"/>
+          <p:nvPr/>
+        </p:nvSpPr>
+        <p:spPr>
+          <a:xfrm>
+            <a:off x="4846320" y="1417320"/>
+            <a:ext cx="3657600" cy="365760"/>
+          </a:xfrm>
+          <a:prstGeom prst="rect">
+            <a:avLst/>
+          </a:prstGeom>
+          <a:noFill/>
+          <a:ln/>
+        </p:spPr>
+        <p:txBody>
+          <a:bodyPr wrap="square" lIns="0" tIns="0" rIns="0" bIns="0" rtlCol="0" anchor="t"/>
+          <a:lstStyle/>
+          <a:p>
+            <a:pPr indent="0" marL="0">
+              <a:buNone/>
+            </a:pPr>
+            <a:r>
+              <a:rPr lang="en-US" sz="2000" b="1" dirty="0">
+                <a:solidFill>
+                  <a:schemeClr val="accent4"/>
+                </a:solidFill>
+                <a:latin typeface="Cambria" pitchFamily="34" charset="0"/>
+                <a:ea typeface="Cambria" pitchFamily="34" charset="-122"/>
+                <a:cs typeface="Cambria" pitchFamily="34" charset="-120"/>
+              </a:rPr>
+              <a:t>What L does not solve</a:t>
+            </a:r>
+            <a:endParaRPr lang="en-US" sz="2000" dirty="0"/>
+          </a:p>
+        </p:txBody>
+      </p:sp>
+      <p:sp>
+        <p:nvSpPr>
+          <p:cNvPr id="8" name="Text 6"/>
+          <p:cNvSpPr txBox="1"/>
+          <p:nvPr/>
+        </p:nvSpPr>
+        <p:spPr>
+          <a:xfrm>
+            <a:off x="4846320" y="1874520"/>
+            <a:ext cx="3657600" cy="2560320"/>
+          </a:xfrm>
+          <a:prstGeom prst="rect">
+            <a:avLst/>
+          </a:prstGeom>
+          <a:noFill/>
+          <a:ln/>
+        </p:spPr>
+        <p:txBody>
+          <a:bodyPr wrap="square" lIns="0" tIns="0" rIns="0" bIns="0" rtlCol="0" anchor="t"/>
+          <a:lstStyle/>
           <a:p>
             <a:pPr marL="342900" indent="-342900">
               <a:spcAft>
-                <a:spcPts val="900"/>
+                <a:spcPts val="600"/>
               </a:spcAft>
               <a:buSzPct val="100000"/>
               <a:buChar char="•"/>
             </a:pPr>
             <a:r>
-              <a:rPr lang="en-US" sz="1600" dirty="0">
+              <a:rPr lang="en-US" sz="1300" dirty="0">
                 <a:solidFill>
                   <a:schemeClr val="tx1"/>
                 </a:solidFill>
@@ -6794,20 +7146,20 @@
                 <a:ea typeface="Calibri" pitchFamily="34" charset="-122"/>
                 <a:cs typeface="Calibri" pitchFamily="34" charset="-120"/>
               </a:rPr>
-              <a:t>A trained CNN is ahead by about 2 points on clothing when all data is available</a:t>
-            </a:r>
-            <a:endParaRPr lang="en-US" sz="1600" dirty="0"/>
+              <a:t>The cost of large language models and image generators: GPU and memory prices, data-centre heat and water</a:t>
+            </a:r>
+            <a:endParaRPr lang="en-US" sz="1300" dirty="0"/>
           </a:p>
           <a:p>
             <a:pPr marL="342900" indent="-342900">
               <a:spcAft>
-                <a:spcPts val="900"/>
+                <a:spcPts val="600"/>
               </a:spcAft>
               <a:buSzPct val="100000"/>
               <a:buChar char="•"/>
             </a:pPr>
             <a:r>
-              <a:rPr lang="en-US" sz="1600" dirty="0">
+              <a:rPr lang="en-US" sz="1300" dirty="0">
                 <a:solidFill>
                   <a:schemeClr val="tx1"/>
                 </a:solidFill>
@@ -6815,20 +7167,17 @@
                 <a:ea typeface="Calibri" pitchFamily="34" charset="-122"/>
                 <a:cs typeface="Calibri" pitchFamily="34" charset="-120"/>
               </a:rPr>
-              <a:t>Small tests: digits, clothing, 20 classes, up to 35 words; noise is simulated; two-sense data is paired by class</a:t>
-            </a:r>
-            <a:endParaRPr lang="en-US" sz="1600" dirty="0"/>
+              <a:t>It cannot run existing models (CNNs, transformers, LLMs): it is a dedicated chip for its own brain-style model</a:t>
+            </a:r>
+            <a:endParaRPr lang="en-US" sz="1300" dirty="0"/>
           </a:p>
           <a:p>
             <a:pPr marL="342900" indent="-342900">
-              <a:spcAft>
-                <a:spcPts val="900"/>
-              </a:spcAft>
               <a:buSzPct val="100000"/>
               <a:buChar char="•"/>
             </a:pPr>
             <a:r>
-              <a:rPr lang="en-US" sz="1600" dirty="0">
+              <a:rPr lang="en-US" sz="1300" dirty="0">
                 <a:solidFill>
                   <a:schemeClr val="tx1"/>
                 </a:solidFill>
@@ -6836,9 +7185,9 @@
                 <a:ea typeface="Calibri" pitchFamily="34" charset="-122"/>
                 <a:cs typeface="Calibri" pitchFamily="34" charset="-120"/>
               </a:rPr>
-              <a:t>Second look costs about 2.8x memory; a few steps still run on the host</a:t>
-            </a:r>
-            <a:endParaRPr lang="en-US" sz="1600" dirty="0"/>
+              <a:t>Nothing is measured on hardware yet</a:t>
+            </a:r>
+            <a:endParaRPr lang="en-US" sz="1300" dirty="0"/>
           </a:p>
         </p:txBody>
       </p:sp>
@@ -6947,7 +7296,7 @@
                 <a:ea typeface="Cambria" pitchFamily="34" charset="-122"/>
                 <a:cs typeface="Cambria" pitchFamily="34" charset="-120"/>
               </a:rPr>
-              <a:t>Not the first, and clear about what is new</a:t>
+              <a:t>Where it is level, and where it is weaker</a:t>
             </a:r>
             <a:endParaRPr lang="en-US" sz="3000" dirty="0"/>
           </a:p>
@@ -6955,68 +7304,14 @@
       </p:sp>
       <p:sp>
         <p:nvSpPr>
-          <p:cNvPr id="3" name="card"/>
-          <p:cNvSpPr/>
+          <p:cNvPr id="3" name="Text 1"/>
+          <p:cNvSpPr txBox="1"/>
           <p:nvPr/>
         </p:nvSpPr>
         <p:spPr>
           <a:xfrm>
             <a:off x="457200" y="1280160"/>
-            <a:ext cx="4023360" cy="3200400"/>
-          </a:xfrm>
-          <a:prstGeom prst="roundRect">
-            <a:avLst>
-              <a:gd name="adj" fmla="val 2857"/>
-            </a:avLst>
-          </a:prstGeom>
-          <a:solidFill>
-            <a:schemeClr val="bg2"/>
-          </a:solidFill>
-          <a:ln w="12700">
-            <a:solidFill>
-              <a:schemeClr val="bg2"/>
-            </a:solidFill>
-            <a:prstDash val="solid"/>
-          </a:ln>
-        </p:spPr>
-      </p:sp>
-      <p:sp>
-        <p:nvSpPr>
-          <p:cNvPr id="4" name="card"/>
-          <p:cNvSpPr/>
-          <p:nvPr/>
-        </p:nvSpPr>
-        <p:spPr>
-          <a:xfrm>
-            <a:off x="4663440" y="1280160"/>
-            <a:ext cx="4023360" cy="3200400"/>
-          </a:xfrm>
-          <a:prstGeom prst="roundRect">
-            <a:avLst>
-              <a:gd name="adj" fmla="val 2857"/>
-            </a:avLst>
-          </a:prstGeom>
-          <a:solidFill>
-            <a:schemeClr val="bg2"/>
-          </a:solidFill>
-          <a:ln w="12700">
-            <a:solidFill>
-              <a:schemeClr val="bg2"/>
-            </a:solidFill>
-            <a:prstDash val="solid"/>
-          </a:ln>
-        </p:spPr>
-      </p:sp>
-      <p:sp>
-        <p:nvSpPr>
-          <p:cNvPr id="5" name="Text 3"/>
-          <p:cNvSpPr txBox="1"/>
-          <p:nvPr/>
-        </p:nvSpPr>
-        <p:spPr>
-          <a:xfrm>
-            <a:off x="640080" y="1417320"/>
-            <a:ext cx="3657600" cy="365760"/>
+            <a:ext cx="8229600" cy="3291840"/>
           </a:xfrm>
           <a:prstGeom prst="rect">
             <a:avLst/>
@@ -7028,54 +7323,15 @@
           <a:bodyPr wrap="square" lIns="0" tIns="0" rIns="0" bIns="0" rtlCol="0" anchor="t"/>
           <a:lstStyle/>
           <a:p>
-            <a:pPr indent="0" marL="0">
-              <a:buNone/>
-            </a:pPr>
-            <a:r>
-              <a:rPr lang="en-US" sz="2000" b="1" dirty="0">
-                <a:solidFill>
-                  <a:schemeClr val="accent6"/>
-                </a:solidFill>
-                <a:latin typeface="Cambria" pitchFamily="34" charset="0"/>
-                <a:ea typeface="Cambria" pitchFamily="34" charset="-122"/>
-                <a:cs typeface="Cambria" pitchFamily="34" charset="-120"/>
-              </a:rPr>
-              <a:t>Already exists</a:t>
-            </a:r>
-            <a:endParaRPr lang="en-US" sz="2000" dirty="0"/>
-          </a:p>
-        </p:txBody>
-      </p:sp>
-      <p:sp>
-        <p:nvSpPr>
-          <p:cNvPr id="6" name="Text 4"/>
-          <p:cNvSpPr txBox="1"/>
-          <p:nvPr/>
-        </p:nvSpPr>
-        <p:spPr>
-          <a:xfrm>
-            <a:off x="640080" y="1920240"/>
-            <a:ext cx="3657600" cy="2377440"/>
-          </a:xfrm>
-          <a:prstGeom prst="rect">
-            <a:avLst/>
-          </a:prstGeom>
-          <a:noFill/>
-          <a:ln/>
-        </p:spPr>
-        <p:txBody>
-          <a:bodyPr wrap="square" lIns="0" tIns="0" rIns="0" bIns="0" rtlCol="0" anchor="t"/>
-          <a:lstStyle/>
-          <a:p>
             <a:pPr marL="342900" indent="-342900">
               <a:spcAft>
-                <a:spcPts val="600"/>
+                <a:spcPts val="900"/>
               </a:spcAft>
               <a:buSzPct val="100000"/>
               <a:buChar char="•"/>
             </a:pPr>
             <a:r>
-              <a:rPr lang="en-US" sz="1500" dirty="0">
+              <a:rPr lang="en-US" sz="1600" dirty="0">
                 <a:solidFill>
                   <a:schemeClr val="tx1"/>
                 </a:solidFill>
@@ -7083,20 +7339,20 @@
                 <a:ea typeface="Calibri" pitchFamily="34" charset="-122"/>
                 <a:cs typeface="Calibri" pitchFamily="34" charset="-120"/>
               </a:rPr>
-              <a:t>Hyperdimensional-computing accelerators</a:t>
-            </a:r>
-            <a:endParaRPr lang="en-US" sz="1500" dirty="0"/>
+              <a:t>Nothing is measured on hardware yet: every chip number is simulated</a:t>
+            </a:r>
+            <a:endParaRPr lang="en-US" sz="1600" dirty="0"/>
           </a:p>
           <a:p>
             <a:pPr marL="342900" indent="-342900">
               <a:spcAft>
-                <a:spcPts val="600"/>
+                <a:spcPts val="900"/>
               </a:spcAft>
               <a:buSzPct val="100000"/>
               <a:buChar char="•"/>
             </a:pPr>
             <a:r>
-              <a:rPr lang="en-US" sz="1500" dirty="0">
+              <a:rPr lang="en-US" sz="1600" dirty="0">
                 <a:solidFill>
                   <a:schemeClr val="tx1"/>
                 </a:solidFill>
@@ -7104,17 +7360,20 @@
                 <a:ea typeface="Calibri" pitchFamily="34" charset="-122"/>
                 <a:cs typeface="Calibri" pitchFamily="34" charset="-120"/>
               </a:rPr>
-              <a:t>Intel Loihi 2, TrueNorth, SpiNNaker (event-driven spiking chips)</a:t>
-            </a:r>
-            <a:endParaRPr lang="en-US" sz="1500" dirty="0"/>
+              <a:t>Staged clothing about 82%, 5 points below its one pass; many ideas tried</a:t>
+            </a:r>
+            <a:endParaRPr lang="en-US" sz="1600" dirty="0"/>
           </a:p>
           <a:p>
             <a:pPr marL="342900" indent="-342900">
+              <a:spcAft>
+                <a:spcPts val="900"/>
+              </a:spcAft>
               <a:buSzPct val="100000"/>
               <a:buChar char="•"/>
             </a:pPr>
             <a:r>
-              <a:rPr lang="en-US" sz="1500" dirty="0">
+              <a:rPr lang="en-US" sz="1600" dirty="0">
                 <a:solidFill>
                   <a:schemeClr val="tx1"/>
                 </a:solidFill>
@@ -7122,81 +7381,20 @@
                 <a:ea typeface="Calibri" pitchFamily="34" charset="-122"/>
                 <a:cs typeface="Calibri" pitchFamily="34" charset="-120"/>
               </a:rPr>
-              <a:t>Replay-based continual learning</a:t>
-            </a:r>
-            <a:endParaRPr lang="en-US" sz="1500" dirty="0"/>
-          </a:p>
-        </p:txBody>
-      </p:sp>
-      <p:sp>
-        <p:nvSpPr>
-          <p:cNvPr id="7" name="Text 5"/>
-          <p:cNvSpPr txBox="1"/>
-          <p:nvPr/>
-        </p:nvSpPr>
-        <p:spPr>
-          <a:xfrm>
-            <a:off x="4846320" y="1417320"/>
-            <a:ext cx="3657600" cy="365760"/>
-          </a:xfrm>
-          <a:prstGeom prst="rect">
-            <a:avLst/>
-          </a:prstGeom>
-          <a:noFill/>
-          <a:ln/>
-        </p:spPr>
-        <p:txBody>
-          <a:bodyPr wrap="square" lIns="0" tIns="0" rIns="0" bIns="0" rtlCol="0" anchor="t"/>
-          <a:lstStyle/>
-          <a:p>
-            <a:pPr indent="0" marL="0">
-              <a:buNone/>
-            </a:pPr>
-            <a:r>
-              <a:rPr lang="en-US" sz="2000" b="1" dirty="0">
-                <a:solidFill>
-                  <a:schemeClr val="accent2"/>
-                </a:solidFill>
-                <a:latin typeface="Cambria" pitchFamily="34" charset="0"/>
-                <a:ea typeface="Cambria" pitchFamily="34" charset="-122"/>
-                <a:cs typeface="Cambria" pitchFamily="34" charset="-120"/>
-              </a:rPr>
-              <a:t>What we add</a:t>
-            </a:r>
-            <a:endParaRPr lang="en-US" sz="2000" dirty="0"/>
-          </a:p>
-        </p:txBody>
-      </p:sp>
-      <p:sp>
-        <p:nvSpPr>
-          <p:cNvPr id="8" name="Text 6"/>
-          <p:cNvSpPr txBox="1"/>
-          <p:nvPr/>
-        </p:nvSpPr>
-        <p:spPr>
-          <a:xfrm>
-            <a:off x="4846320" y="1920240"/>
-            <a:ext cx="3657600" cy="2377440"/>
-          </a:xfrm>
-          <a:prstGeom prst="rect">
-            <a:avLst/>
-          </a:prstGeom>
-          <a:noFill/>
-          <a:ln/>
-        </p:spPr>
-        <p:txBody>
-          <a:bodyPr wrap="square" lIns="0" tIns="0" rIns="0" bIns="0" rtlCol="0" anchor="t"/>
-          <a:lstStyle/>
+              <a:t>A trained CNN is ahead by about 2 points on clothing when all data is available</a:t>
+            </a:r>
+            <a:endParaRPr lang="en-US" sz="1600" dirty="0"/>
+          </a:p>
           <a:p>
             <a:pPr marL="342900" indent="-342900">
               <a:spcAft>
-                <a:spcPts val="600"/>
+                <a:spcPts val="900"/>
               </a:spcAft>
               <a:buSzPct val="100000"/>
               <a:buChar char="•"/>
             </a:pPr>
             <a:r>
-              <a:rPr lang="en-US" sz="1400" dirty="0">
+              <a:rPr lang="en-US" sz="1600" dirty="0">
                 <a:solidFill>
                   <a:schemeClr val="tx1"/>
                 </a:solidFill>
@@ -7204,20 +7402,20 @@
                 <a:ea typeface="Calibri" pitchFamily="34" charset="-122"/>
                 <a:cs typeface="Calibri" pitchFamily="34" charset="-120"/>
               </a:rPr>
-              <a:t>Dreams from 10-bit counters, no stored examples</a:t>
-            </a:r>
-            <a:endParaRPr lang="en-US" sz="1400" dirty="0"/>
+              <a:t>Small tests: digits, clothing, 20 classes, up to 35 words; noise is simulated; two-sense data is paired by class</a:t>
+            </a:r>
+            <a:endParaRPr lang="en-US" sz="1600" dirty="0"/>
           </a:p>
           <a:p>
             <a:pPr marL="342900" indent="-342900">
               <a:spcAft>
-                <a:spcPts val="600"/>
+                <a:spcPts val="900"/>
               </a:spcAft>
               <a:buSzPct val="100000"/>
               <a:buChar char="•"/>
             </a:pPr>
             <a:r>
-              <a:rPr lang="en-US" sz="1400" dirty="0">
+              <a:rPr lang="en-US" sz="1600" dirty="0">
                 <a:solidFill>
                   <a:schemeClr val="tx1"/>
                 </a:solidFill>
@@ -7225,27 +7423,9 @@
                 <a:ea typeface="Calibri" pitchFamily="34" charset="-122"/>
                 <a:cs typeface="Calibri" pitchFamily="34" charset="-120"/>
               </a:rPr>
-              <a:t>A night that ends by itself; consolidation that scales with the data</a:t>
-            </a:r>
-            <a:endParaRPr lang="en-US" sz="1400" dirty="0"/>
-          </a:p>
-          <a:p>
-            <a:pPr marL="342900" indent="-342900">
-              <a:buSzPct val="100000"/>
-              <a:buChar char="•"/>
-            </a:pPr>
-            <a:r>
-              <a:rPr lang="en-US" sz="1400" dirty="0">
-                <a:solidFill>
-                  <a:schemeClr val="tx1"/>
-                </a:solidFill>
-                <a:latin typeface="Calibri" pitchFamily="34" charset="0"/>
-                <a:ea typeface="Calibri" pitchFamily="34" charset="-122"/>
-                <a:cs typeface="Calibri" pitchFamily="34" charset="-120"/>
-              </a:rPr>
-              <a:t>No multiplier or matrix, bit-exact from raw senses to decision, with grouping and thresholds on the chip</a:t>
-            </a:r>
-            <a:endParaRPr lang="en-US" sz="1400" dirty="0"/>
+              <a:t>Second look costs about 2.8x memory; a few steps still run on the host</a:t>
+            </a:r>
+            <a:endParaRPr lang="en-US" sz="1600" dirty="0"/>
           </a:p>
         </p:txBody>
       </p:sp>
@@ -7354,7 +7534,7 @@
                 <a:ea typeface="Cambria" pitchFamily="34" charset="-122"/>
                 <a:cs typeface="Cambria" pitchFamily="34" charset="-120"/>
               </a:rPr>
-              <a:t>What comes next</a:t>
+              <a:t>Not the first, and clear about what is new</a:t>
             </a:r>
             <a:endParaRPr lang="en-US" sz="3000" dirty="0"/>
           </a:p>
@@ -7368,12 +7548,12 @@
         </p:nvSpPr>
         <p:spPr>
           <a:xfrm>
-            <a:off x="457200" y="1371600"/>
-            <a:ext cx="1965960" cy="2651760"/>
+            <a:off x="457200" y="1280160"/>
+            <a:ext cx="4023360" cy="3200400"/>
           </a:xfrm>
           <a:prstGeom prst="roundRect">
             <a:avLst>
-              <a:gd name="adj" fmla="val 4651"/>
+              <a:gd name="adj" fmla="val 2857"/>
             </a:avLst>
           </a:prstGeom>
           <a:solidFill>
@@ -7389,160 +7569,18 @@
       </p:sp>
       <p:sp>
         <p:nvSpPr>
-          <p:cNvPr id="4" name="marker"/>
+          <p:cNvPr id="4" name="card"/>
           <p:cNvSpPr/>
           <p:nvPr/>
         </p:nvSpPr>
         <p:spPr>
           <a:xfrm>
-            <a:off x="594360" y="1508760"/>
-            <a:ext cx="502920" cy="502920"/>
-          </a:xfrm>
-          <a:prstGeom prst="ellipse">
-            <a:avLst/>
-          </a:prstGeom>
-          <a:solidFill>
-            <a:schemeClr val="accent3"/>
-          </a:solidFill>
-          <a:ln w="12700">
-            <a:solidFill>
-              <a:schemeClr val="accent3"/>
-            </a:solidFill>
-            <a:prstDash val="solid"/>
-          </a:ln>
-        </p:spPr>
-      </p:sp>
-      <p:sp>
-        <p:nvSpPr>
-          <p:cNvPr id="5" name="Text 3"/>
-          <p:cNvSpPr txBox="1"/>
-          <p:nvPr/>
-        </p:nvSpPr>
-        <p:spPr>
-          <a:xfrm>
-            <a:off x="594360" y="1600200"/>
-            <a:ext cx="502920" cy="365760"/>
-          </a:xfrm>
-          <a:prstGeom prst="rect">
-            <a:avLst/>
-          </a:prstGeom>
-          <a:noFill/>
-          <a:ln/>
-        </p:spPr>
-        <p:txBody>
-          <a:bodyPr wrap="square" lIns="0" tIns="0" rIns="0" bIns="0" rtlCol="0" anchor="t"/>
-          <a:lstStyle/>
-          <a:p>
-            <a:pPr algn="ctr" indent="0" marL="0">
-              <a:buNone/>
-            </a:pPr>
-            <a:r>
-              <a:rPr lang="en-US" sz="1800" b="1" dirty="0">
-                <a:solidFill>
-                  <a:schemeClr val="tx1"/>
-                </a:solidFill>
-                <a:latin typeface="Calibri" pitchFamily="34" charset="0"/>
-                <a:ea typeface="Calibri" pitchFamily="34" charset="-122"/>
-                <a:cs typeface="Calibri" pitchFamily="34" charset="-120"/>
-              </a:rPr>
-              <a:t>1</a:t>
-            </a:r>
-            <a:endParaRPr lang="en-US" sz="1800" dirty="0"/>
-          </a:p>
-        </p:txBody>
-      </p:sp>
-      <p:sp>
-        <p:nvSpPr>
-          <p:cNvPr id="6" name="Text 4"/>
-          <p:cNvSpPr txBox="1"/>
-          <p:nvPr/>
-        </p:nvSpPr>
-        <p:spPr>
-          <a:xfrm>
-            <a:off x="594360" y="2148840"/>
-            <a:ext cx="1737360" cy="365760"/>
-          </a:xfrm>
-          <a:prstGeom prst="rect">
-            <a:avLst/>
-          </a:prstGeom>
-          <a:noFill/>
-          <a:ln/>
-        </p:spPr>
-        <p:txBody>
-          <a:bodyPr wrap="square" lIns="0" tIns="0" rIns="0" bIns="0" rtlCol="0" anchor="t"/>
-          <a:lstStyle/>
-          <a:p>
-            <a:pPr indent="0" marL="0">
-              <a:buNone/>
-            </a:pPr>
-            <a:r>
-              <a:rPr lang="en-US" sz="1700" b="1" dirty="0">
-                <a:solidFill>
-                  <a:schemeClr val="tx1"/>
-                </a:solidFill>
-                <a:latin typeface="Cambria" pitchFamily="34" charset="0"/>
-                <a:ea typeface="Cambria" pitchFamily="34" charset="-122"/>
-                <a:cs typeface="Cambria" pitchFamily="34" charset="-120"/>
-              </a:rPr>
-              <a:t>Done</a:t>
-            </a:r>
-            <a:endParaRPr lang="en-US" sz="1700" dirty="0"/>
-          </a:p>
-        </p:txBody>
-      </p:sp>
-      <p:sp>
-        <p:nvSpPr>
-          <p:cNvPr id="7" name="Text 5"/>
-          <p:cNvSpPr txBox="1"/>
-          <p:nvPr/>
-        </p:nvSpPr>
-        <p:spPr>
-          <a:xfrm>
-            <a:off x="594360" y="2560320"/>
-            <a:ext cx="1737360" cy="1371600"/>
-          </a:xfrm>
-          <a:prstGeom prst="rect">
-            <a:avLst/>
-          </a:prstGeom>
-          <a:noFill/>
-          <a:ln/>
-        </p:spPr>
-        <p:txBody>
-          <a:bodyPr wrap="square" lIns="0" tIns="0" rIns="0" bIns="0" rtlCol="0" anchor="t"/>
-          <a:lstStyle/>
-          <a:p>
-            <a:pPr indent="0" marL="0">
-              <a:buNone/>
-            </a:pPr>
-            <a:r>
-              <a:rPr lang="en-US" sz="1100" dirty="0">
-                <a:solidFill>
-                  <a:schemeClr val="tx1"/>
-                </a:solidFill>
-                <a:latin typeface="Calibri" pitchFamily="34" charset="0"/>
-                <a:ea typeface="Calibri" pitchFamily="34" charset="-122"/>
-                <a:cs typeface="Calibri" pitchFamily="34" charset="-120"/>
-              </a:rPr>
-              <a:t>Model, RTL with every check passing, second look, tail memory, on-chip thresholds and grouping, scale tests</a:t>
-            </a:r>
-            <a:endParaRPr lang="en-US" sz="1100" dirty="0"/>
-          </a:p>
-        </p:txBody>
-      </p:sp>
-      <p:sp>
-        <p:nvSpPr>
-          <p:cNvPr id="8" name="card"/>
-          <p:cNvSpPr/>
-          <p:nvPr/>
-        </p:nvSpPr>
-        <p:spPr>
-          <a:xfrm>
-            <a:off x="2560320" y="1371600"/>
-            <a:ext cx="1965960" cy="2651760"/>
+            <a:off x="4663440" y="1280160"/>
+            <a:ext cx="4023360" cy="3200400"/>
           </a:xfrm>
           <a:prstGeom prst="roundRect">
             <a:avLst>
-              <a:gd name="adj" fmla="val 4651"/>
+              <a:gd name="adj" fmla="val 2857"/>
             </a:avLst>
           </a:prstGeom>
           <a:solidFill>
@@ -7558,39 +7596,14 @@
       </p:sp>
       <p:sp>
         <p:nvSpPr>
-          <p:cNvPr id="9" name="marker"/>
-          <p:cNvSpPr/>
-          <p:nvPr/>
-        </p:nvSpPr>
-        <p:spPr>
-          <a:xfrm>
-            <a:off x="2697480" y="1508760"/>
-            <a:ext cx="502920" cy="502920"/>
-          </a:xfrm>
-          <a:prstGeom prst="ellipse">
-            <a:avLst/>
-          </a:prstGeom>
-          <a:solidFill>
-            <a:schemeClr val="accent1"/>
-          </a:solidFill>
-          <a:ln w="12700">
-            <a:solidFill>
-              <a:schemeClr val="accent1"/>
-            </a:solidFill>
-            <a:prstDash val="solid"/>
-          </a:ln>
-        </p:spPr>
-      </p:sp>
-      <p:sp>
-        <p:nvSpPr>
-          <p:cNvPr id="10" name="Text 8"/>
+          <p:cNvPr id="5" name="Text 3"/>
           <p:cNvSpPr txBox="1"/>
           <p:nvPr/>
         </p:nvSpPr>
         <p:spPr>
           <a:xfrm>
-            <a:off x="2697480" y="1600200"/>
-            <a:ext cx="502920" cy="365760"/>
+            <a:off x="640080" y="1417320"/>
+            <a:ext cx="3657600" cy="365760"/>
           </a:xfrm>
           <a:prstGeom prst="rect">
             <a:avLst/>
@@ -7602,11 +7615,54 @@
           <a:bodyPr wrap="square" lIns="0" tIns="0" rIns="0" bIns="0" rtlCol="0" anchor="t"/>
           <a:lstStyle/>
           <a:p>
-            <a:pPr algn="ctr" indent="0" marL="0">
+            <a:pPr indent="0" marL="0">
               <a:buNone/>
             </a:pPr>
             <a:r>
-              <a:rPr lang="en-US" sz="1800" b="1" dirty="0">
+              <a:rPr lang="en-US" sz="2000" b="1" dirty="0">
+                <a:solidFill>
+                  <a:schemeClr val="accent6"/>
+                </a:solidFill>
+                <a:latin typeface="Cambria" pitchFamily="34" charset="0"/>
+                <a:ea typeface="Cambria" pitchFamily="34" charset="-122"/>
+                <a:cs typeface="Cambria" pitchFamily="34" charset="-120"/>
+              </a:rPr>
+              <a:t>Already exists</a:t>
+            </a:r>
+            <a:endParaRPr lang="en-US" sz="2000" dirty="0"/>
+          </a:p>
+        </p:txBody>
+      </p:sp>
+      <p:sp>
+        <p:nvSpPr>
+          <p:cNvPr id="6" name="Text 4"/>
+          <p:cNvSpPr txBox="1"/>
+          <p:nvPr/>
+        </p:nvSpPr>
+        <p:spPr>
+          <a:xfrm>
+            <a:off x="640080" y="1920240"/>
+            <a:ext cx="3657600" cy="2377440"/>
+          </a:xfrm>
+          <a:prstGeom prst="rect">
+            <a:avLst/>
+          </a:prstGeom>
+          <a:noFill/>
+          <a:ln/>
+        </p:spPr>
+        <p:txBody>
+          <a:bodyPr wrap="square" lIns="0" tIns="0" rIns="0" bIns="0" rtlCol="0" anchor="t"/>
+          <a:lstStyle/>
+          <a:p>
+            <a:pPr marL="342900" indent="-342900">
+              <a:spcAft>
+                <a:spcPts val="600"/>
+              </a:spcAft>
+              <a:buSzPct val="100000"/>
+              <a:buChar char="•"/>
+            </a:pPr>
+            <a:r>
+              <a:rPr lang="en-US" sz="1500" dirty="0">
                 <a:solidFill>
                   <a:schemeClr val="tx1"/>
                 </a:solidFill>
@@ -7614,22 +7670,61 @@
                 <a:ea typeface="Calibri" pitchFamily="34" charset="-122"/>
                 <a:cs typeface="Calibri" pitchFamily="34" charset="-120"/>
               </a:rPr>
-              <a:t>2</a:t>
-            </a:r>
-            <a:endParaRPr lang="en-US" sz="1800" dirty="0"/>
-          </a:p>
-        </p:txBody>
-      </p:sp>
-      <p:sp>
-        <p:nvSpPr>
-          <p:cNvPr id="11" name="Text 9"/>
+              <a:t>Hyperdimensional-computing accelerators</a:t>
+            </a:r>
+            <a:endParaRPr lang="en-US" sz="1500" dirty="0"/>
+          </a:p>
+          <a:p>
+            <a:pPr marL="342900" indent="-342900">
+              <a:spcAft>
+                <a:spcPts val="600"/>
+              </a:spcAft>
+              <a:buSzPct val="100000"/>
+              <a:buChar char="•"/>
+            </a:pPr>
+            <a:r>
+              <a:rPr lang="en-US" sz="1500" dirty="0">
+                <a:solidFill>
+                  <a:schemeClr val="tx1"/>
+                </a:solidFill>
+                <a:latin typeface="Calibri" pitchFamily="34" charset="0"/>
+                <a:ea typeface="Calibri" pitchFamily="34" charset="-122"/>
+                <a:cs typeface="Calibri" pitchFamily="34" charset="-120"/>
+              </a:rPr>
+              <a:t>Intel Loihi 2, TrueNorth, SpiNNaker (event-driven spiking chips)</a:t>
+            </a:r>
+            <a:endParaRPr lang="en-US" sz="1500" dirty="0"/>
+          </a:p>
+          <a:p>
+            <a:pPr marL="342900" indent="-342900">
+              <a:buSzPct val="100000"/>
+              <a:buChar char="•"/>
+            </a:pPr>
+            <a:r>
+              <a:rPr lang="en-US" sz="1500" dirty="0">
+                <a:solidFill>
+                  <a:schemeClr val="tx1"/>
+                </a:solidFill>
+                <a:latin typeface="Calibri" pitchFamily="34" charset="0"/>
+                <a:ea typeface="Calibri" pitchFamily="34" charset="-122"/>
+                <a:cs typeface="Calibri" pitchFamily="34" charset="-120"/>
+              </a:rPr>
+              <a:t>Replay-based continual learning</a:t>
+            </a:r>
+            <a:endParaRPr lang="en-US" sz="1500" dirty="0"/>
+          </a:p>
+        </p:txBody>
+      </p:sp>
+      <p:sp>
+        <p:nvSpPr>
+          <p:cNvPr id="7" name="Text 5"/>
           <p:cNvSpPr txBox="1"/>
           <p:nvPr/>
         </p:nvSpPr>
         <p:spPr>
           <a:xfrm>
-            <a:off x="2697480" y="2148840"/>
-            <a:ext cx="1737360" cy="365760"/>
+            <a:off x="4846320" y="1417320"/>
+            <a:ext cx="3657600" cy="365760"/>
           </a:xfrm>
           <a:prstGeom prst="rect">
             <a:avLst/>
@@ -7645,30 +7740,30 @@
               <a:buNone/>
             </a:pPr>
             <a:r>
-              <a:rPr lang="en-US" sz="1700" b="1" dirty="0">
-                <a:solidFill>
-                  <a:schemeClr val="tx1"/>
+              <a:rPr lang="en-US" sz="2000" b="1" dirty="0">
+                <a:solidFill>
+                  <a:schemeClr val="accent2"/>
                 </a:solidFill>
                 <a:latin typeface="Cambria" pitchFamily="34" charset="0"/>
                 <a:ea typeface="Cambria" pitchFamily="34" charset="-122"/>
                 <a:cs typeface="Cambria" pitchFamily="34" charset="-120"/>
               </a:rPr>
-              <a:t>Next</a:t>
-            </a:r>
-            <a:endParaRPr lang="en-US" sz="1700" dirty="0"/>
-          </a:p>
-        </p:txBody>
-      </p:sp>
-      <p:sp>
-        <p:nvSpPr>
-          <p:cNvPr id="12" name="Text 10"/>
+              <a:t>What we add</a:t>
+            </a:r>
+            <a:endParaRPr lang="en-US" sz="2000" dirty="0"/>
+          </a:p>
+        </p:txBody>
+      </p:sp>
+      <p:sp>
+        <p:nvSpPr>
+          <p:cNvPr id="8" name="Text 6"/>
           <p:cNvSpPr txBox="1"/>
           <p:nvPr/>
         </p:nvSpPr>
         <p:spPr>
           <a:xfrm>
-            <a:off x="2697480" y="2560320"/>
-            <a:ext cx="1737360" cy="1371600"/>
+            <a:off x="4846320" y="1920240"/>
+            <a:ext cx="3657600" cy="2377440"/>
           </a:xfrm>
           <a:prstGeom prst="rect">
             <a:avLst/>
@@ -7680,11 +7775,15 @@
           <a:bodyPr wrap="square" lIns="0" tIns="0" rIns="0" bIns="0" rtlCol="0" anchor="t"/>
           <a:lstStyle/>
           <a:p>
-            <a:pPr indent="0" marL="0">
-              <a:buNone/>
-            </a:pPr>
-            <a:r>
-              <a:rPr lang="en-US" sz="1100" dirty="0">
+            <a:pPr marL="342900" indent="-342900">
+              <a:spcAft>
+                <a:spcPts val="600"/>
+              </a:spcAft>
+              <a:buSzPct val="100000"/>
+              <a:buChar char="•"/>
+            </a:pPr>
+            <a:r>
+              <a:rPr lang="en-US" sz="1400" dirty="0">
                 <a:solidFill>
                   <a:schemeClr val="tx1"/>
                 </a:solidFill>
@@ -7692,90 +7791,20 @@
                 <a:ea typeface="Calibri" pitchFamily="34" charset="-122"/>
                 <a:cs typeface="Calibri" pitchFamily="34" charset="-120"/>
               </a:rPr>
-              <a:t>Run on the real Tang Nano: the first MEASURED numbers</a:t>
-            </a:r>
-            <a:endParaRPr lang="en-US" sz="1100" dirty="0"/>
-          </a:p>
-        </p:txBody>
-      </p:sp>
-      <p:sp>
-        <p:nvSpPr>
-          <p:cNvPr id="13" name="card"/>
-          <p:cNvSpPr/>
-          <p:nvPr/>
-        </p:nvSpPr>
-        <p:spPr>
-          <a:xfrm>
-            <a:off x="4663440" y="1371600"/>
-            <a:ext cx="1965960" cy="2651760"/>
-          </a:xfrm>
-          <a:prstGeom prst="roundRect">
-            <a:avLst>
-              <a:gd name="adj" fmla="val 4651"/>
-            </a:avLst>
-          </a:prstGeom>
-          <a:solidFill>
-            <a:schemeClr val="bg2"/>
-          </a:solidFill>
-          <a:ln w="12700">
-            <a:solidFill>
-              <a:schemeClr val="bg2"/>
-            </a:solidFill>
-            <a:prstDash val="solid"/>
-          </a:ln>
-        </p:spPr>
-      </p:sp>
-      <p:sp>
-        <p:nvSpPr>
-          <p:cNvPr id="14" name="marker"/>
-          <p:cNvSpPr/>
-          <p:nvPr/>
-        </p:nvSpPr>
-        <p:spPr>
-          <a:xfrm>
-            <a:off x="4800600" y="1508760"/>
-            <a:ext cx="502920" cy="502920"/>
-          </a:xfrm>
-          <a:prstGeom prst="ellipse">
-            <a:avLst/>
-          </a:prstGeom>
-          <a:solidFill>
-            <a:schemeClr val="accent2"/>
-          </a:solidFill>
-          <a:ln w="12700">
-            <a:solidFill>
-              <a:schemeClr val="accent2"/>
-            </a:solidFill>
-            <a:prstDash val="solid"/>
-          </a:ln>
-        </p:spPr>
-      </p:sp>
-      <p:sp>
-        <p:nvSpPr>
-          <p:cNvPr id="15" name="Text 13"/>
-          <p:cNvSpPr txBox="1"/>
-          <p:nvPr/>
-        </p:nvSpPr>
-        <p:spPr>
-          <a:xfrm>
-            <a:off x="4800600" y="1600200"/>
-            <a:ext cx="502920" cy="365760"/>
-          </a:xfrm>
-          <a:prstGeom prst="rect">
-            <a:avLst/>
-          </a:prstGeom>
-          <a:noFill/>
-          <a:ln/>
-        </p:spPr>
-        <p:txBody>
-          <a:bodyPr wrap="square" lIns="0" tIns="0" rIns="0" bIns="0" rtlCol="0" anchor="t"/>
-          <a:lstStyle/>
-          <a:p>
-            <a:pPr algn="ctr" indent="0" marL="0">
-              <a:buNone/>
-            </a:pPr>
-            <a:r>
-              <a:rPr lang="en-US" sz="1800" b="1" dirty="0">
+              <a:t>Dreams from 10-bit counters, no stored examples</a:t>
+            </a:r>
+            <a:endParaRPr lang="en-US" sz="1400" dirty="0"/>
+          </a:p>
+          <a:p>
+            <a:pPr marL="342900" indent="-342900">
+              <a:spcAft>
+                <a:spcPts val="600"/>
+              </a:spcAft>
+              <a:buSzPct val="100000"/>
+              <a:buChar char="•"/>
+            </a:pPr>
+            <a:r>
+              <a:rPr lang="en-US" sz="1400" dirty="0">
                 <a:solidFill>
                   <a:schemeClr val="tx1"/>
                 </a:solidFill>
@@ -7783,77 +7812,17 @@
                 <a:ea typeface="Calibri" pitchFamily="34" charset="-122"/>
                 <a:cs typeface="Calibri" pitchFamily="34" charset="-120"/>
               </a:rPr>
-              <a:t>3</a:t>
-            </a:r>
-            <a:endParaRPr lang="en-US" sz="1800" dirty="0"/>
-          </a:p>
-        </p:txBody>
-      </p:sp>
-      <p:sp>
-        <p:nvSpPr>
-          <p:cNvPr id="16" name="Text 14"/>
-          <p:cNvSpPr txBox="1"/>
-          <p:nvPr/>
-        </p:nvSpPr>
-        <p:spPr>
-          <a:xfrm>
-            <a:off x="4800600" y="2148840"/>
-            <a:ext cx="1737360" cy="365760"/>
-          </a:xfrm>
-          <a:prstGeom prst="rect">
-            <a:avLst/>
-          </a:prstGeom>
-          <a:noFill/>
-          <a:ln/>
-        </p:spPr>
-        <p:txBody>
-          <a:bodyPr wrap="square" lIns="0" tIns="0" rIns="0" bIns="0" rtlCol="0" anchor="t"/>
-          <a:lstStyle/>
-          <a:p>
-            <a:pPr indent="0" marL="0">
-              <a:buNone/>
-            </a:pPr>
-            <a:r>
-              <a:rPr lang="en-US" sz="1700" b="1" dirty="0">
-                <a:solidFill>
-                  <a:schemeClr val="tx1"/>
-                </a:solidFill>
-                <a:latin typeface="Cambria" pitchFamily="34" charset="0"/>
-                <a:ea typeface="Cambria" pitchFamily="34" charset="-122"/>
-                <a:cs typeface="Cambria" pitchFamily="34" charset="-120"/>
-              </a:rPr>
-              <a:t>Then</a:t>
-            </a:r>
-            <a:endParaRPr lang="en-US" sz="1700" dirty="0"/>
-          </a:p>
-        </p:txBody>
-      </p:sp>
-      <p:sp>
-        <p:nvSpPr>
-          <p:cNvPr id="17" name="Text 15"/>
-          <p:cNvSpPr txBox="1"/>
-          <p:nvPr/>
-        </p:nvSpPr>
-        <p:spPr>
-          <a:xfrm>
-            <a:off x="4800600" y="2560320"/>
-            <a:ext cx="1737360" cy="1371600"/>
-          </a:xfrm>
-          <a:prstGeom prst="rect">
-            <a:avLst/>
-          </a:prstGeom>
-          <a:noFill/>
-          <a:ln/>
-        </p:spPr>
-        <p:txBody>
-          <a:bodyPr wrap="square" lIns="0" tIns="0" rIns="0" bIns="0" rtlCol="0" anchor="t"/>
-          <a:lstStyle/>
-          <a:p>
-            <a:pPr indent="0" marL="0">
-              <a:buNone/>
-            </a:pPr>
-            <a:r>
-              <a:rPr lang="en-US" sz="1100" dirty="0">
+              <a:t>A night that ends by itself; consolidation that scales with the data</a:t>
+            </a:r>
+            <a:endParaRPr lang="en-US" sz="1400" dirty="0"/>
+          </a:p>
+          <a:p>
+            <a:pPr marL="342900" indent="-342900">
+              <a:buSzPct val="100000"/>
+              <a:buChar char="•"/>
+            </a:pPr>
+            <a:r>
+              <a:rPr lang="en-US" sz="1400" dirty="0">
                 <a:solidFill>
                   <a:schemeClr val="tx1"/>
                 </a:solidFill>
@@ -7861,215 +7830,7 @@
                 <a:ea typeface="Calibri" pitchFamily="34" charset="-122"/>
                 <a:cs typeface="Calibri" pitchFamily="34" charset="-120"/>
               </a:rPr>
-              <a:t>Harder tests: larger vocabulary, real recorded noise, a harder image set</a:t>
-            </a:r>
-            <a:endParaRPr lang="en-US" sz="1100" dirty="0"/>
-          </a:p>
-        </p:txBody>
-      </p:sp>
-      <p:sp>
-        <p:nvSpPr>
-          <p:cNvPr id="18" name="card"/>
-          <p:cNvSpPr/>
-          <p:nvPr/>
-        </p:nvSpPr>
-        <p:spPr>
-          <a:xfrm>
-            <a:off x="6766560" y="1371600"/>
-            <a:ext cx="1965960" cy="2651760"/>
-          </a:xfrm>
-          <a:prstGeom prst="roundRect">
-            <a:avLst>
-              <a:gd name="adj" fmla="val 4651"/>
-            </a:avLst>
-          </a:prstGeom>
-          <a:solidFill>
-            <a:schemeClr val="bg2"/>
-          </a:solidFill>
-          <a:ln w="12700">
-            <a:solidFill>
-              <a:schemeClr val="bg2"/>
-            </a:solidFill>
-            <a:prstDash val="solid"/>
-          </a:ln>
-        </p:spPr>
-      </p:sp>
-      <p:sp>
-        <p:nvSpPr>
-          <p:cNvPr id="19" name="marker"/>
-          <p:cNvSpPr/>
-          <p:nvPr/>
-        </p:nvSpPr>
-        <p:spPr>
-          <a:xfrm>
-            <a:off x="6903720" y="1508760"/>
-            <a:ext cx="502920" cy="502920"/>
-          </a:xfrm>
-          <a:prstGeom prst="ellipse">
-            <a:avLst/>
-          </a:prstGeom>
-          <a:solidFill>
-            <a:schemeClr val="accent5"/>
-          </a:solidFill>
-          <a:ln w="12700">
-            <a:solidFill>
-              <a:schemeClr val="accent5"/>
-            </a:solidFill>
-            <a:prstDash val="solid"/>
-          </a:ln>
-        </p:spPr>
-      </p:sp>
-      <p:sp>
-        <p:nvSpPr>
-          <p:cNvPr id="20" name="Text 18"/>
-          <p:cNvSpPr txBox="1"/>
-          <p:nvPr/>
-        </p:nvSpPr>
-        <p:spPr>
-          <a:xfrm>
-            <a:off x="6903720" y="1600200"/>
-            <a:ext cx="502920" cy="365760"/>
-          </a:xfrm>
-          <a:prstGeom prst="rect">
-            <a:avLst/>
-          </a:prstGeom>
-          <a:noFill/>
-          <a:ln/>
-        </p:spPr>
-        <p:txBody>
-          <a:bodyPr wrap="square" lIns="0" tIns="0" rIns="0" bIns="0" rtlCol="0" anchor="t"/>
-          <a:lstStyle/>
-          <a:p>
-            <a:pPr algn="ctr" indent="0" marL="0">
-              <a:buNone/>
-            </a:pPr>
-            <a:r>
-              <a:rPr lang="en-US" sz="1800" b="1" dirty="0">
-                <a:solidFill>
-                  <a:schemeClr val="tx1"/>
-                </a:solidFill>
-                <a:latin typeface="Calibri" pitchFamily="34" charset="0"/>
-                <a:ea typeface="Calibri" pitchFamily="34" charset="-122"/>
-                <a:cs typeface="Calibri" pitchFamily="34" charset="-120"/>
-              </a:rPr>
-              <a:t>4</a:t>
-            </a:r>
-            <a:endParaRPr lang="en-US" sz="1800" dirty="0"/>
-          </a:p>
-        </p:txBody>
-      </p:sp>
-      <p:sp>
-        <p:nvSpPr>
-          <p:cNvPr id="21" name="Text 19"/>
-          <p:cNvSpPr txBox="1"/>
-          <p:nvPr/>
-        </p:nvSpPr>
-        <p:spPr>
-          <a:xfrm>
-            <a:off x="6903720" y="2148840"/>
-            <a:ext cx="1737360" cy="365760"/>
-          </a:xfrm>
-          <a:prstGeom prst="rect">
-            <a:avLst/>
-          </a:prstGeom>
-          <a:noFill/>
-          <a:ln/>
-        </p:spPr>
-        <p:txBody>
-          <a:bodyPr wrap="square" lIns="0" tIns="0" rIns="0" bIns="0" rtlCol="0" anchor="t"/>
-          <a:lstStyle/>
-          <a:p>
-            <a:pPr indent="0" marL="0">
-              <a:buNone/>
-            </a:pPr>
-            <a:r>
-              <a:rPr lang="en-US" sz="1700" b="1" dirty="0">
-                <a:solidFill>
-                  <a:schemeClr val="tx1"/>
-                </a:solidFill>
-                <a:latin typeface="Cambria" pitchFamily="34" charset="0"/>
-                <a:ea typeface="Cambria" pitchFamily="34" charset="-122"/>
-                <a:cs typeface="Cambria" pitchFamily="34" charset="-120"/>
-              </a:rPr>
-              <a:t>Later</a:t>
-            </a:r>
-            <a:endParaRPr lang="en-US" sz="1700" dirty="0"/>
-          </a:p>
-        </p:txBody>
-      </p:sp>
-      <p:sp>
-        <p:nvSpPr>
-          <p:cNvPr id="22" name="Text 20"/>
-          <p:cNvSpPr txBox="1"/>
-          <p:nvPr/>
-        </p:nvSpPr>
-        <p:spPr>
-          <a:xfrm>
-            <a:off x="6903720" y="2560320"/>
-            <a:ext cx="1737360" cy="1371600"/>
-          </a:xfrm>
-          <a:prstGeom prst="rect">
-            <a:avLst/>
-          </a:prstGeom>
-          <a:noFill/>
-          <a:ln/>
-        </p:spPr>
-        <p:txBody>
-          <a:bodyPr wrap="square" lIns="0" tIns="0" rIns="0" bIns="0" rtlCol="0" anchor="t"/>
-          <a:lstStyle/>
-          <a:p>
-            <a:pPr indent="0" marL="0">
-              <a:buNone/>
-            </a:pPr>
-            <a:r>
-              <a:rPr lang="en-US" sz="1100" dirty="0">
-                <a:solidFill>
-                  <a:schemeClr val="tx1"/>
-                </a:solidFill>
-                <a:latin typeface="Calibri" pitchFamily="34" charset="0"/>
-                <a:ea typeface="Calibri" pitchFamily="34" charset="-122"/>
-                <a:cs typeface="Calibri" pitchFamily="34" charset="-120"/>
-              </a:rPr>
-              <a:t>Matrix-free chip for the L language model; ASIC memory for sound and the second look</a:t>
-            </a:r>
-            <a:endParaRPr lang="en-US" sz="1100" dirty="0"/>
-          </a:p>
-        </p:txBody>
-      </p:sp>
-      <p:sp>
-        <p:nvSpPr>
-          <p:cNvPr id="23" name="Text 21"/>
-          <p:cNvSpPr txBox="1"/>
-          <p:nvPr/>
-        </p:nvSpPr>
-        <p:spPr>
-          <a:xfrm>
-            <a:off x="457200" y="4206240"/>
-            <a:ext cx="8229600" cy="457200"/>
-          </a:xfrm>
-          <a:prstGeom prst="rect">
-            <a:avLst/>
-          </a:prstGeom>
-          <a:noFill/>
-          <a:ln/>
-        </p:spPr>
-        <p:txBody>
-          <a:bodyPr wrap="square" lIns="0" tIns="0" rIns="0" bIns="0" rtlCol="0" anchor="t"/>
-          <a:lstStyle/>
-          <a:p>
-            <a:pPr indent="0" marL="0">
-              <a:buNone/>
-            </a:pPr>
-            <a:r>
-              <a:rPr lang="en-US" sz="1400" dirty="0">
-                <a:solidFill>
-                  <a:schemeClr val="tx1"/>
-                </a:solidFill>
-                <a:latin typeface="Calibri" pitchFamily="34" charset="0"/>
-                <a:ea typeface="Calibri" pitchFamily="34" charset="-122"/>
-                <a:cs typeface="Calibri" pitchFamily="34" charset="-120"/>
-              </a:rPr>
-              <a:t>Horizon: a provable result within 6 to 8 months, then shrink and attract investors. No fabrication is planned yet.</a:t>
+              <a:t>No multiplier or matrix, bit-exact from raw senses to decision, with grouping and thresholds on the chip</a:t>
             </a:r>
             <a:endParaRPr lang="en-US" sz="1400" dirty="0"/>
           </a:p>
@@ -8155,6 +7916,1299 @@
         </p:nvSpPr>
         <p:spPr>
           <a:xfrm>
+            <a:off x="457200" y="274320"/>
+            <a:ext cx="8229600" cy="822960"/>
+          </a:xfrm>
+          <a:prstGeom prst="rect">
+            <a:avLst/>
+          </a:prstGeom>
+          <a:noFill/>
+          <a:ln/>
+        </p:spPr>
+        <p:txBody>
+          <a:bodyPr wrap="square" lIns="0" tIns="0" rIns="0" bIns="0" rtlCol="0" anchor="ctr"/>
+          <a:lstStyle/>
+          <a:p>
+            <a:pPr algn="l" indent="0" marL="0">
+              <a:buNone/>
+            </a:pPr>
+            <a:r>
+              <a:rPr lang="en-US" sz="3000" b="1" dirty="0">
+                <a:solidFill>
+                  <a:schemeClr val="tx1"/>
+                </a:solidFill>
+                <a:latin typeface="Cambria" pitchFamily="34" charset="0"/>
+                <a:ea typeface="Cambria" pitchFamily="34" charset="-122"/>
+                <a:cs typeface="Cambria" pitchFamily="34" charset="-120"/>
+              </a:rPr>
+              <a:t>What comes next</a:t>
+            </a:r>
+            <a:endParaRPr lang="en-US" sz="3000" dirty="0"/>
+          </a:p>
+        </p:txBody>
+      </p:sp>
+      <p:sp>
+        <p:nvSpPr>
+          <p:cNvPr id="3" name="card"/>
+          <p:cNvSpPr/>
+          <p:nvPr/>
+        </p:nvSpPr>
+        <p:spPr>
+          <a:xfrm>
+            <a:off x="457200" y="1371600"/>
+            <a:ext cx="1965960" cy="2651760"/>
+          </a:xfrm>
+          <a:prstGeom prst="roundRect">
+            <a:avLst>
+              <a:gd name="adj" fmla="val 4651"/>
+            </a:avLst>
+          </a:prstGeom>
+          <a:solidFill>
+            <a:schemeClr val="bg2"/>
+          </a:solidFill>
+          <a:ln w="12700">
+            <a:solidFill>
+              <a:schemeClr val="bg2"/>
+            </a:solidFill>
+            <a:prstDash val="solid"/>
+          </a:ln>
+        </p:spPr>
+      </p:sp>
+      <p:sp>
+        <p:nvSpPr>
+          <p:cNvPr id="4" name="marker"/>
+          <p:cNvSpPr/>
+          <p:nvPr/>
+        </p:nvSpPr>
+        <p:spPr>
+          <a:xfrm>
+            <a:off x="594360" y="1508760"/>
+            <a:ext cx="502920" cy="502920"/>
+          </a:xfrm>
+          <a:prstGeom prst="ellipse">
+            <a:avLst/>
+          </a:prstGeom>
+          <a:solidFill>
+            <a:schemeClr val="accent3"/>
+          </a:solidFill>
+          <a:ln w="12700">
+            <a:solidFill>
+              <a:schemeClr val="accent3"/>
+            </a:solidFill>
+            <a:prstDash val="solid"/>
+          </a:ln>
+        </p:spPr>
+      </p:sp>
+      <p:sp>
+        <p:nvSpPr>
+          <p:cNvPr id="5" name="Text 3"/>
+          <p:cNvSpPr txBox="1"/>
+          <p:nvPr/>
+        </p:nvSpPr>
+        <p:spPr>
+          <a:xfrm>
+            <a:off x="594360" y="1600200"/>
+            <a:ext cx="502920" cy="365760"/>
+          </a:xfrm>
+          <a:prstGeom prst="rect">
+            <a:avLst/>
+          </a:prstGeom>
+          <a:noFill/>
+          <a:ln/>
+        </p:spPr>
+        <p:txBody>
+          <a:bodyPr wrap="square" lIns="0" tIns="0" rIns="0" bIns="0" rtlCol="0" anchor="t"/>
+          <a:lstStyle/>
+          <a:p>
+            <a:pPr algn="ctr" indent="0" marL="0">
+              <a:buNone/>
+            </a:pPr>
+            <a:r>
+              <a:rPr lang="en-US" sz="1800" b="1" dirty="0">
+                <a:solidFill>
+                  <a:schemeClr val="tx1"/>
+                </a:solidFill>
+                <a:latin typeface="Calibri" pitchFamily="34" charset="0"/>
+                <a:ea typeface="Calibri" pitchFamily="34" charset="-122"/>
+                <a:cs typeface="Calibri" pitchFamily="34" charset="-120"/>
+              </a:rPr>
+              <a:t>1</a:t>
+            </a:r>
+            <a:endParaRPr lang="en-US" sz="1800" dirty="0"/>
+          </a:p>
+        </p:txBody>
+      </p:sp>
+      <p:sp>
+        <p:nvSpPr>
+          <p:cNvPr id="6" name="Text 4"/>
+          <p:cNvSpPr txBox="1"/>
+          <p:nvPr/>
+        </p:nvSpPr>
+        <p:spPr>
+          <a:xfrm>
+            <a:off x="594360" y="2148840"/>
+            <a:ext cx="1737360" cy="365760"/>
+          </a:xfrm>
+          <a:prstGeom prst="rect">
+            <a:avLst/>
+          </a:prstGeom>
+          <a:noFill/>
+          <a:ln/>
+        </p:spPr>
+        <p:txBody>
+          <a:bodyPr wrap="square" lIns="0" tIns="0" rIns="0" bIns="0" rtlCol="0" anchor="t"/>
+          <a:lstStyle/>
+          <a:p>
+            <a:pPr indent="0" marL="0">
+              <a:buNone/>
+            </a:pPr>
+            <a:r>
+              <a:rPr lang="en-US" sz="1700" b="1" dirty="0">
+                <a:solidFill>
+                  <a:schemeClr val="tx1"/>
+                </a:solidFill>
+                <a:latin typeface="Cambria" pitchFamily="34" charset="0"/>
+                <a:ea typeface="Cambria" pitchFamily="34" charset="-122"/>
+                <a:cs typeface="Cambria" pitchFamily="34" charset="-120"/>
+              </a:rPr>
+              <a:t>Done</a:t>
+            </a:r>
+            <a:endParaRPr lang="en-US" sz="1700" dirty="0"/>
+          </a:p>
+        </p:txBody>
+      </p:sp>
+      <p:sp>
+        <p:nvSpPr>
+          <p:cNvPr id="7" name="Text 5"/>
+          <p:cNvSpPr txBox="1"/>
+          <p:nvPr/>
+        </p:nvSpPr>
+        <p:spPr>
+          <a:xfrm>
+            <a:off x="594360" y="2560320"/>
+            <a:ext cx="1737360" cy="1371600"/>
+          </a:xfrm>
+          <a:prstGeom prst="rect">
+            <a:avLst/>
+          </a:prstGeom>
+          <a:noFill/>
+          <a:ln/>
+        </p:spPr>
+        <p:txBody>
+          <a:bodyPr wrap="square" lIns="0" tIns="0" rIns="0" bIns="0" rtlCol="0" anchor="t"/>
+          <a:lstStyle/>
+          <a:p>
+            <a:pPr indent="0" marL="0">
+              <a:buNone/>
+            </a:pPr>
+            <a:r>
+              <a:rPr lang="en-US" sz="1100" dirty="0">
+                <a:solidFill>
+                  <a:schemeClr val="tx1"/>
+                </a:solidFill>
+                <a:latin typeface="Calibri" pitchFamily="34" charset="0"/>
+                <a:ea typeface="Calibri" pitchFamily="34" charset="-122"/>
+                <a:cs typeface="Calibri" pitchFamily="34" charset="-120"/>
+              </a:rPr>
+              <a:t>Model, RTL with every check passing, second look, tail memory, on-chip thresholds and grouping, scale tests</a:t>
+            </a:r>
+            <a:endParaRPr lang="en-US" sz="1100" dirty="0"/>
+          </a:p>
+        </p:txBody>
+      </p:sp>
+      <p:sp>
+        <p:nvSpPr>
+          <p:cNvPr id="8" name="card"/>
+          <p:cNvSpPr/>
+          <p:nvPr/>
+        </p:nvSpPr>
+        <p:spPr>
+          <a:xfrm>
+            <a:off x="2560320" y="1371600"/>
+            <a:ext cx="1965960" cy="2651760"/>
+          </a:xfrm>
+          <a:prstGeom prst="roundRect">
+            <a:avLst>
+              <a:gd name="adj" fmla="val 4651"/>
+            </a:avLst>
+          </a:prstGeom>
+          <a:solidFill>
+            <a:schemeClr val="bg2"/>
+          </a:solidFill>
+          <a:ln w="12700">
+            <a:solidFill>
+              <a:schemeClr val="bg2"/>
+            </a:solidFill>
+            <a:prstDash val="solid"/>
+          </a:ln>
+        </p:spPr>
+      </p:sp>
+      <p:sp>
+        <p:nvSpPr>
+          <p:cNvPr id="9" name="marker"/>
+          <p:cNvSpPr/>
+          <p:nvPr/>
+        </p:nvSpPr>
+        <p:spPr>
+          <a:xfrm>
+            <a:off x="2697480" y="1508760"/>
+            <a:ext cx="502920" cy="502920"/>
+          </a:xfrm>
+          <a:prstGeom prst="ellipse">
+            <a:avLst/>
+          </a:prstGeom>
+          <a:solidFill>
+            <a:schemeClr val="accent1"/>
+          </a:solidFill>
+          <a:ln w="12700">
+            <a:solidFill>
+              <a:schemeClr val="accent1"/>
+            </a:solidFill>
+            <a:prstDash val="solid"/>
+          </a:ln>
+        </p:spPr>
+      </p:sp>
+      <p:sp>
+        <p:nvSpPr>
+          <p:cNvPr id="10" name="Text 8"/>
+          <p:cNvSpPr txBox="1"/>
+          <p:nvPr/>
+        </p:nvSpPr>
+        <p:spPr>
+          <a:xfrm>
+            <a:off x="2697480" y="1600200"/>
+            <a:ext cx="502920" cy="365760"/>
+          </a:xfrm>
+          <a:prstGeom prst="rect">
+            <a:avLst/>
+          </a:prstGeom>
+          <a:noFill/>
+          <a:ln/>
+        </p:spPr>
+        <p:txBody>
+          <a:bodyPr wrap="square" lIns="0" tIns="0" rIns="0" bIns="0" rtlCol="0" anchor="t"/>
+          <a:lstStyle/>
+          <a:p>
+            <a:pPr algn="ctr" indent="0" marL="0">
+              <a:buNone/>
+            </a:pPr>
+            <a:r>
+              <a:rPr lang="en-US" sz="1800" b="1" dirty="0">
+                <a:solidFill>
+                  <a:schemeClr val="tx1"/>
+                </a:solidFill>
+                <a:latin typeface="Calibri" pitchFamily="34" charset="0"/>
+                <a:ea typeface="Calibri" pitchFamily="34" charset="-122"/>
+                <a:cs typeface="Calibri" pitchFamily="34" charset="-120"/>
+              </a:rPr>
+              <a:t>2</a:t>
+            </a:r>
+            <a:endParaRPr lang="en-US" sz="1800" dirty="0"/>
+          </a:p>
+        </p:txBody>
+      </p:sp>
+      <p:sp>
+        <p:nvSpPr>
+          <p:cNvPr id="11" name="Text 9"/>
+          <p:cNvSpPr txBox="1"/>
+          <p:nvPr/>
+        </p:nvSpPr>
+        <p:spPr>
+          <a:xfrm>
+            <a:off x="2697480" y="2148840"/>
+            <a:ext cx="1737360" cy="365760"/>
+          </a:xfrm>
+          <a:prstGeom prst="rect">
+            <a:avLst/>
+          </a:prstGeom>
+          <a:noFill/>
+          <a:ln/>
+        </p:spPr>
+        <p:txBody>
+          <a:bodyPr wrap="square" lIns="0" tIns="0" rIns="0" bIns="0" rtlCol="0" anchor="t"/>
+          <a:lstStyle/>
+          <a:p>
+            <a:pPr indent="0" marL="0">
+              <a:buNone/>
+            </a:pPr>
+            <a:r>
+              <a:rPr lang="en-US" sz="1700" b="1" dirty="0">
+                <a:solidFill>
+                  <a:schemeClr val="tx1"/>
+                </a:solidFill>
+                <a:latin typeface="Cambria" pitchFamily="34" charset="0"/>
+                <a:ea typeface="Cambria" pitchFamily="34" charset="-122"/>
+                <a:cs typeface="Cambria" pitchFamily="34" charset="-120"/>
+              </a:rPr>
+              <a:t>Next</a:t>
+            </a:r>
+            <a:endParaRPr lang="en-US" sz="1700" dirty="0"/>
+          </a:p>
+        </p:txBody>
+      </p:sp>
+      <p:sp>
+        <p:nvSpPr>
+          <p:cNvPr id="12" name="Text 10"/>
+          <p:cNvSpPr txBox="1"/>
+          <p:nvPr/>
+        </p:nvSpPr>
+        <p:spPr>
+          <a:xfrm>
+            <a:off x="2697480" y="2560320"/>
+            <a:ext cx="1737360" cy="1371600"/>
+          </a:xfrm>
+          <a:prstGeom prst="rect">
+            <a:avLst/>
+          </a:prstGeom>
+          <a:noFill/>
+          <a:ln/>
+        </p:spPr>
+        <p:txBody>
+          <a:bodyPr wrap="square" lIns="0" tIns="0" rIns="0" bIns="0" rtlCol="0" anchor="t"/>
+          <a:lstStyle/>
+          <a:p>
+            <a:pPr indent="0" marL="0">
+              <a:buNone/>
+            </a:pPr>
+            <a:r>
+              <a:rPr lang="en-US" sz="1100" dirty="0">
+                <a:solidFill>
+                  <a:schemeClr val="tx1"/>
+                </a:solidFill>
+                <a:latin typeface="Calibri" pitchFamily="34" charset="0"/>
+                <a:ea typeface="Calibri" pitchFamily="34" charset="-122"/>
+                <a:cs typeface="Calibri" pitchFamily="34" charset="-120"/>
+              </a:rPr>
+              <a:t>Run on the real Tang Nano: the first MEASURED numbers</a:t>
+            </a:r>
+            <a:endParaRPr lang="en-US" sz="1100" dirty="0"/>
+          </a:p>
+        </p:txBody>
+      </p:sp>
+      <p:sp>
+        <p:nvSpPr>
+          <p:cNvPr id="13" name="card"/>
+          <p:cNvSpPr/>
+          <p:nvPr/>
+        </p:nvSpPr>
+        <p:spPr>
+          <a:xfrm>
+            <a:off x="4663440" y="1371600"/>
+            <a:ext cx="1965960" cy="2651760"/>
+          </a:xfrm>
+          <a:prstGeom prst="roundRect">
+            <a:avLst>
+              <a:gd name="adj" fmla="val 4651"/>
+            </a:avLst>
+          </a:prstGeom>
+          <a:solidFill>
+            <a:schemeClr val="bg2"/>
+          </a:solidFill>
+          <a:ln w="12700">
+            <a:solidFill>
+              <a:schemeClr val="bg2"/>
+            </a:solidFill>
+            <a:prstDash val="solid"/>
+          </a:ln>
+        </p:spPr>
+      </p:sp>
+      <p:sp>
+        <p:nvSpPr>
+          <p:cNvPr id="14" name="marker"/>
+          <p:cNvSpPr/>
+          <p:nvPr/>
+        </p:nvSpPr>
+        <p:spPr>
+          <a:xfrm>
+            <a:off x="4800600" y="1508760"/>
+            <a:ext cx="502920" cy="502920"/>
+          </a:xfrm>
+          <a:prstGeom prst="ellipse">
+            <a:avLst/>
+          </a:prstGeom>
+          <a:solidFill>
+            <a:schemeClr val="accent2"/>
+          </a:solidFill>
+          <a:ln w="12700">
+            <a:solidFill>
+              <a:schemeClr val="accent2"/>
+            </a:solidFill>
+            <a:prstDash val="solid"/>
+          </a:ln>
+        </p:spPr>
+      </p:sp>
+      <p:sp>
+        <p:nvSpPr>
+          <p:cNvPr id="15" name="Text 13"/>
+          <p:cNvSpPr txBox="1"/>
+          <p:nvPr/>
+        </p:nvSpPr>
+        <p:spPr>
+          <a:xfrm>
+            <a:off x="4800600" y="1600200"/>
+            <a:ext cx="502920" cy="365760"/>
+          </a:xfrm>
+          <a:prstGeom prst="rect">
+            <a:avLst/>
+          </a:prstGeom>
+          <a:noFill/>
+          <a:ln/>
+        </p:spPr>
+        <p:txBody>
+          <a:bodyPr wrap="square" lIns="0" tIns="0" rIns="0" bIns="0" rtlCol="0" anchor="t"/>
+          <a:lstStyle/>
+          <a:p>
+            <a:pPr algn="ctr" indent="0" marL="0">
+              <a:buNone/>
+            </a:pPr>
+            <a:r>
+              <a:rPr lang="en-US" sz="1800" b="1" dirty="0">
+                <a:solidFill>
+                  <a:schemeClr val="tx1"/>
+                </a:solidFill>
+                <a:latin typeface="Calibri" pitchFamily="34" charset="0"/>
+                <a:ea typeface="Calibri" pitchFamily="34" charset="-122"/>
+                <a:cs typeface="Calibri" pitchFamily="34" charset="-120"/>
+              </a:rPr>
+              <a:t>3</a:t>
+            </a:r>
+            <a:endParaRPr lang="en-US" sz="1800" dirty="0"/>
+          </a:p>
+        </p:txBody>
+      </p:sp>
+      <p:sp>
+        <p:nvSpPr>
+          <p:cNvPr id="16" name="Text 14"/>
+          <p:cNvSpPr txBox="1"/>
+          <p:nvPr/>
+        </p:nvSpPr>
+        <p:spPr>
+          <a:xfrm>
+            <a:off x="4800600" y="2148840"/>
+            <a:ext cx="1737360" cy="365760"/>
+          </a:xfrm>
+          <a:prstGeom prst="rect">
+            <a:avLst/>
+          </a:prstGeom>
+          <a:noFill/>
+          <a:ln/>
+        </p:spPr>
+        <p:txBody>
+          <a:bodyPr wrap="square" lIns="0" tIns="0" rIns="0" bIns="0" rtlCol="0" anchor="t"/>
+          <a:lstStyle/>
+          <a:p>
+            <a:pPr indent="0" marL="0">
+              <a:buNone/>
+            </a:pPr>
+            <a:r>
+              <a:rPr lang="en-US" sz="1700" b="1" dirty="0">
+                <a:solidFill>
+                  <a:schemeClr val="tx1"/>
+                </a:solidFill>
+                <a:latin typeface="Cambria" pitchFamily="34" charset="0"/>
+                <a:ea typeface="Cambria" pitchFamily="34" charset="-122"/>
+                <a:cs typeface="Cambria" pitchFamily="34" charset="-120"/>
+              </a:rPr>
+              <a:t>Then</a:t>
+            </a:r>
+            <a:endParaRPr lang="en-US" sz="1700" dirty="0"/>
+          </a:p>
+        </p:txBody>
+      </p:sp>
+      <p:sp>
+        <p:nvSpPr>
+          <p:cNvPr id="17" name="Text 15"/>
+          <p:cNvSpPr txBox="1"/>
+          <p:nvPr/>
+        </p:nvSpPr>
+        <p:spPr>
+          <a:xfrm>
+            <a:off x="4800600" y="2560320"/>
+            <a:ext cx="1737360" cy="1371600"/>
+          </a:xfrm>
+          <a:prstGeom prst="rect">
+            <a:avLst/>
+          </a:prstGeom>
+          <a:noFill/>
+          <a:ln/>
+        </p:spPr>
+        <p:txBody>
+          <a:bodyPr wrap="square" lIns="0" tIns="0" rIns="0" bIns="0" rtlCol="0" anchor="t"/>
+          <a:lstStyle/>
+          <a:p>
+            <a:pPr indent="0" marL="0">
+              <a:buNone/>
+            </a:pPr>
+            <a:r>
+              <a:rPr lang="en-US" sz="1100" dirty="0">
+                <a:solidFill>
+                  <a:schemeClr val="tx1"/>
+                </a:solidFill>
+                <a:latin typeface="Calibri" pitchFamily="34" charset="0"/>
+                <a:ea typeface="Calibri" pitchFamily="34" charset="-122"/>
+                <a:cs typeface="Calibri" pitchFamily="34" charset="-120"/>
+              </a:rPr>
+              <a:t>Harder tests: larger vocabulary, real recorded noise, a harder image set</a:t>
+            </a:r>
+            <a:endParaRPr lang="en-US" sz="1100" dirty="0"/>
+          </a:p>
+        </p:txBody>
+      </p:sp>
+      <p:sp>
+        <p:nvSpPr>
+          <p:cNvPr id="18" name="card"/>
+          <p:cNvSpPr/>
+          <p:nvPr/>
+        </p:nvSpPr>
+        <p:spPr>
+          <a:xfrm>
+            <a:off x="6766560" y="1371600"/>
+            <a:ext cx="1965960" cy="2651760"/>
+          </a:xfrm>
+          <a:prstGeom prst="roundRect">
+            <a:avLst>
+              <a:gd name="adj" fmla="val 4651"/>
+            </a:avLst>
+          </a:prstGeom>
+          <a:solidFill>
+            <a:schemeClr val="bg2"/>
+          </a:solidFill>
+          <a:ln w="12700">
+            <a:solidFill>
+              <a:schemeClr val="bg2"/>
+            </a:solidFill>
+            <a:prstDash val="solid"/>
+          </a:ln>
+        </p:spPr>
+      </p:sp>
+      <p:sp>
+        <p:nvSpPr>
+          <p:cNvPr id="19" name="marker"/>
+          <p:cNvSpPr/>
+          <p:nvPr/>
+        </p:nvSpPr>
+        <p:spPr>
+          <a:xfrm>
+            <a:off x="6903720" y="1508760"/>
+            <a:ext cx="502920" cy="502920"/>
+          </a:xfrm>
+          <a:prstGeom prst="ellipse">
+            <a:avLst/>
+          </a:prstGeom>
+          <a:solidFill>
+            <a:schemeClr val="accent5"/>
+          </a:solidFill>
+          <a:ln w="12700">
+            <a:solidFill>
+              <a:schemeClr val="accent5"/>
+            </a:solidFill>
+            <a:prstDash val="solid"/>
+          </a:ln>
+        </p:spPr>
+      </p:sp>
+      <p:sp>
+        <p:nvSpPr>
+          <p:cNvPr id="20" name="Text 18"/>
+          <p:cNvSpPr txBox="1"/>
+          <p:nvPr/>
+        </p:nvSpPr>
+        <p:spPr>
+          <a:xfrm>
+            <a:off x="6903720" y="1600200"/>
+            <a:ext cx="502920" cy="365760"/>
+          </a:xfrm>
+          <a:prstGeom prst="rect">
+            <a:avLst/>
+          </a:prstGeom>
+          <a:noFill/>
+          <a:ln/>
+        </p:spPr>
+        <p:txBody>
+          <a:bodyPr wrap="square" lIns="0" tIns="0" rIns="0" bIns="0" rtlCol="0" anchor="t"/>
+          <a:lstStyle/>
+          <a:p>
+            <a:pPr algn="ctr" indent="0" marL="0">
+              <a:buNone/>
+            </a:pPr>
+            <a:r>
+              <a:rPr lang="en-US" sz="1800" b="1" dirty="0">
+                <a:solidFill>
+                  <a:schemeClr val="tx1"/>
+                </a:solidFill>
+                <a:latin typeface="Calibri" pitchFamily="34" charset="0"/>
+                <a:ea typeface="Calibri" pitchFamily="34" charset="-122"/>
+                <a:cs typeface="Calibri" pitchFamily="34" charset="-120"/>
+              </a:rPr>
+              <a:t>4</a:t>
+            </a:r>
+            <a:endParaRPr lang="en-US" sz="1800" dirty="0"/>
+          </a:p>
+        </p:txBody>
+      </p:sp>
+      <p:sp>
+        <p:nvSpPr>
+          <p:cNvPr id="21" name="Text 19"/>
+          <p:cNvSpPr txBox="1"/>
+          <p:nvPr/>
+        </p:nvSpPr>
+        <p:spPr>
+          <a:xfrm>
+            <a:off x="6903720" y="2148840"/>
+            <a:ext cx="1737360" cy="365760"/>
+          </a:xfrm>
+          <a:prstGeom prst="rect">
+            <a:avLst/>
+          </a:prstGeom>
+          <a:noFill/>
+          <a:ln/>
+        </p:spPr>
+        <p:txBody>
+          <a:bodyPr wrap="square" lIns="0" tIns="0" rIns="0" bIns="0" rtlCol="0" anchor="t"/>
+          <a:lstStyle/>
+          <a:p>
+            <a:pPr indent="0" marL="0">
+              <a:buNone/>
+            </a:pPr>
+            <a:r>
+              <a:rPr lang="en-US" sz="1700" b="1" dirty="0">
+                <a:solidFill>
+                  <a:schemeClr val="tx1"/>
+                </a:solidFill>
+                <a:latin typeface="Cambria" pitchFamily="34" charset="0"/>
+                <a:ea typeface="Cambria" pitchFamily="34" charset="-122"/>
+                <a:cs typeface="Cambria" pitchFamily="34" charset="-120"/>
+              </a:rPr>
+              <a:t>Later</a:t>
+            </a:r>
+            <a:endParaRPr lang="en-US" sz="1700" dirty="0"/>
+          </a:p>
+        </p:txBody>
+      </p:sp>
+      <p:sp>
+        <p:nvSpPr>
+          <p:cNvPr id="22" name="Text 20"/>
+          <p:cNvSpPr txBox="1"/>
+          <p:nvPr/>
+        </p:nvSpPr>
+        <p:spPr>
+          <a:xfrm>
+            <a:off x="6903720" y="2560320"/>
+            <a:ext cx="1737360" cy="1371600"/>
+          </a:xfrm>
+          <a:prstGeom prst="rect">
+            <a:avLst/>
+          </a:prstGeom>
+          <a:noFill/>
+          <a:ln/>
+        </p:spPr>
+        <p:txBody>
+          <a:bodyPr wrap="square" lIns="0" tIns="0" rIns="0" bIns="0" rtlCol="0" anchor="t"/>
+          <a:lstStyle/>
+          <a:p>
+            <a:pPr indent="0" marL="0">
+              <a:buNone/>
+            </a:pPr>
+            <a:r>
+              <a:rPr lang="en-US" sz="1100" dirty="0">
+                <a:solidFill>
+                  <a:schemeClr val="tx1"/>
+                </a:solidFill>
+                <a:latin typeface="Calibri" pitchFamily="34" charset="0"/>
+                <a:ea typeface="Calibri" pitchFamily="34" charset="-122"/>
+                <a:cs typeface="Calibri" pitchFamily="34" charset="-120"/>
+              </a:rPr>
+              <a:t>Matrix-free chip for the L language model; ASIC memory for sound and the second look</a:t>
+            </a:r>
+            <a:endParaRPr lang="en-US" sz="1100" dirty="0"/>
+          </a:p>
+        </p:txBody>
+      </p:sp>
+      <p:sp>
+        <p:nvSpPr>
+          <p:cNvPr id="23" name="Text 21"/>
+          <p:cNvSpPr txBox="1"/>
+          <p:nvPr/>
+        </p:nvSpPr>
+        <p:spPr>
+          <a:xfrm>
+            <a:off x="457200" y="4206240"/>
+            <a:ext cx="8229600" cy="457200"/>
+          </a:xfrm>
+          <a:prstGeom prst="rect">
+            <a:avLst/>
+          </a:prstGeom>
+          <a:noFill/>
+          <a:ln/>
+        </p:spPr>
+        <p:txBody>
+          <a:bodyPr wrap="square" lIns="0" tIns="0" rIns="0" bIns="0" rtlCol="0" anchor="t"/>
+          <a:lstStyle/>
+          <a:p>
+            <a:pPr indent="0" marL="0">
+              <a:buNone/>
+            </a:pPr>
+            <a:r>
+              <a:rPr lang="en-US" sz="1400" dirty="0">
+                <a:solidFill>
+                  <a:schemeClr val="tx1"/>
+                </a:solidFill>
+                <a:latin typeface="Calibri" pitchFamily="34" charset="0"/>
+                <a:ea typeface="Calibri" pitchFamily="34" charset="-122"/>
+                <a:cs typeface="Calibri" pitchFamily="34" charset="-120"/>
+              </a:rPr>
+              <a:t>Horizon: a provable result within 6 to 8 months, then shrink and attract investors. No fabrication is planned yet.</a:t>
+            </a:r>
+            <a:endParaRPr lang="en-US" sz="1400" dirty="0"/>
+          </a:p>
+        </p:txBody>
+      </p:sp>
+      <p:sp>
+        <p:nvSpPr>
+          <p:cNvPr id="25" name="Slide Number Placeholder 0"/>
+          <p:cNvSpPr>
+            <a:spLocks noGrp="1"/>
+          </p:cNvSpPr>
+          <p:nvPr>
+            <p:ph type="sldNum" sz="quarter" idx="4294967295"/>
+          </p:nvPr>
+        </p:nvSpPr>
+        <p:spPr>
+          <a:xfrm>
+            <a:off x="8412480" y="4800600"/>
+            <a:ext cx="800000" cy="300000"/>
+          </a:xfrm>
+          <a:prstGeom prst="rect">
+            <a:avLst/>
+          </a:prstGeom>
+          <a:extLst>
+            <a:ext uri="{C572A759-6A51-4108-AA02-DFA0A04FC94B}">
+              <ma14:wrappingTextBoxFlag xmlns:ma14="http://schemas.microsoft.com/office/mac/drawingml/2011/main" val="0"/>
+            </a:ext>
+          </a:extLst>
+        </p:spPr>
+        <p:txBody>
+          <a:bodyPr/>
+          <a:lstStyle>
+            <a:lvl1pPr>
+              <a:defRPr sz="1000">
+                <a:solidFill>
+                  <a:schemeClr val="accent6"/>
+                </a:solidFill>
+              </a:defRPr>
+            </a:lvl1pPr>
+          </a:lstStyle>
+          <a:p>
+            <a:pPr algn="l"/>
+            <a:fld id="{F7021451-1387-4CA6-816F-3879F97B5CBC}" type="slidenum">
+              <a:rPr b="0" lang="en-US"/>
+              <a:t>16</a:t>
+            </a:fld>
+            <a:endParaRPr lang="en-US"/>
+          </a:p>
+        </p:txBody>
+      </p:sp>
+    </p:spTree>
+  </p:cSld>
+  <p:clrMapOvr>
+    <a:masterClrMapping/>
+  </p:clrMapOvr>
+</p:sld>
+</file>
+
+<file path=ppt/slides/slide17.xml><?xml version="1.0" encoding="utf-8"?>
+<p:sld xmlns:a="http://schemas.openxmlformats.org/drawingml/2006/main" xmlns:r="http://schemas.openxmlformats.org/officeDocument/2006/relationships" xmlns:p="http://schemas.openxmlformats.org/presentationml/2006/main">
+  <p:cSld name="Slide 17">
+    <p:spTree>
+      <p:nvGrpSpPr>
+        <p:cNvPr id="1" name=""/>
+        <p:cNvGrpSpPr/>
+        <p:nvPr/>
+      </p:nvGrpSpPr>
+      <p:grpSpPr>
+        <a:xfrm>
+          <a:off x="0" y="0"/>
+          <a:ext cx="0" cy="0"/>
+          <a:chOff x="0" y="0"/>
+          <a:chExt cx="0" cy="0"/>
+        </a:xfrm>
+      </p:grpSpPr>
+      <p:sp>
+        <p:nvSpPr>
+          <p:cNvPr id="2" name="Text 0"/>
+          <p:cNvSpPr/>
+          <p:nvPr>
+            <p:ph idx="100" type="title" hasCustomPrompt="1"/>
+          </p:nvPr>
+        </p:nvSpPr>
+        <p:spPr>
+          <a:xfrm>
+            <a:off x="457200" y="274320"/>
+            <a:ext cx="8229600" cy="822960"/>
+          </a:xfrm>
+          <a:prstGeom prst="rect">
+            <a:avLst/>
+          </a:prstGeom>
+          <a:noFill/>
+          <a:ln/>
+        </p:spPr>
+        <p:txBody>
+          <a:bodyPr wrap="square" lIns="0" tIns="0" rIns="0" bIns="0" rtlCol="0" anchor="ctr"/>
+          <a:lstStyle/>
+          <a:p>
+            <a:pPr algn="l" indent="0" marL="0">
+              <a:buNone/>
+            </a:pPr>
+            <a:r>
+              <a:rPr lang="en-US" sz="3000" b="1" dirty="0">
+                <a:solidFill>
+                  <a:schemeClr val="tx1"/>
+                </a:solidFill>
+                <a:latin typeface="Cambria" pitchFamily="34" charset="0"/>
+                <a:ea typeface="Cambria" pitchFamily="34" charset="-122"/>
+                <a:cs typeface="Cambria" pitchFamily="34" charset="-120"/>
+              </a:rPr>
+              <a:t>Two tracks toward the bigger problem</a:t>
+            </a:r>
+            <a:endParaRPr lang="en-US" sz="3000" dirty="0"/>
+          </a:p>
+        </p:txBody>
+      </p:sp>
+      <p:sp>
+        <p:nvSpPr>
+          <p:cNvPr id="3" name="card"/>
+          <p:cNvSpPr/>
+          <p:nvPr/>
+        </p:nvSpPr>
+        <p:spPr>
+          <a:xfrm>
+            <a:off x="457200" y="1280160"/>
+            <a:ext cx="4023360" cy="3291840"/>
+          </a:xfrm>
+          <a:prstGeom prst="roundRect">
+            <a:avLst>
+              <a:gd name="adj" fmla="val 2778"/>
+            </a:avLst>
+          </a:prstGeom>
+          <a:solidFill>
+            <a:schemeClr val="bg2"/>
+          </a:solidFill>
+          <a:ln w="12700">
+            <a:solidFill>
+              <a:schemeClr val="bg2"/>
+            </a:solidFill>
+            <a:prstDash val="solid"/>
+          </a:ln>
+        </p:spPr>
+      </p:sp>
+      <p:sp>
+        <p:nvSpPr>
+          <p:cNvPr id="4" name="card"/>
+          <p:cNvSpPr/>
+          <p:nvPr/>
+        </p:nvSpPr>
+        <p:spPr>
+          <a:xfrm>
+            <a:off x="4663440" y="1280160"/>
+            <a:ext cx="4023360" cy="3291840"/>
+          </a:xfrm>
+          <a:prstGeom prst="roundRect">
+            <a:avLst>
+              <a:gd name="adj" fmla="val 2778"/>
+            </a:avLst>
+          </a:prstGeom>
+          <a:solidFill>
+            <a:schemeClr val="bg2"/>
+          </a:solidFill>
+          <a:ln w="12700">
+            <a:solidFill>
+              <a:schemeClr val="bg2"/>
+            </a:solidFill>
+            <a:prstDash val="solid"/>
+          </a:ln>
+        </p:spPr>
+      </p:sp>
+      <p:sp>
+        <p:nvSpPr>
+          <p:cNvPr id="5" name="Text 3"/>
+          <p:cNvSpPr txBox="1"/>
+          <p:nvPr/>
+        </p:nvSpPr>
+        <p:spPr>
+          <a:xfrm>
+            <a:off x="640080" y="1389888"/>
+            <a:ext cx="3657600" cy="365760"/>
+          </a:xfrm>
+          <a:prstGeom prst="rect">
+            <a:avLst/>
+          </a:prstGeom>
+          <a:noFill/>
+          <a:ln/>
+        </p:spPr>
+        <p:txBody>
+          <a:bodyPr wrap="square" lIns="0" tIns="0" rIns="0" bIns="0" rtlCol="0" anchor="t"/>
+          <a:lstStyle/>
+          <a:p>
+            <a:pPr indent="0" marL="0">
+              <a:buNone/>
+            </a:pPr>
+            <a:r>
+              <a:rPr lang="en-US" sz="1700" b="1" dirty="0">
+                <a:solidFill>
+                  <a:schemeClr val="accent3"/>
+                </a:solidFill>
+                <a:latin typeface="Cambria" pitchFamily="34" charset="0"/>
+                <a:ea typeface="Cambria" pitchFamily="34" charset="-122"/>
+                <a:cs typeface="Cambria" pitchFamily="34" charset="-120"/>
+              </a:rPr>
+              <a:t>Track 1: the L chip (hardware)</a:t>
+            </a:r>
+            <a:endParaRPr lang="en-US" sz="1700" dirty="0"/>
+          </a:p>
+        </p:txBody>
+      </p:sp>
+      <p:sp>
+        <p:nvSpPr>
+          <p:cNvPr id="6" name="Text 4"/>
+          <p:cNvSpPr txBox="1"/>
+          <p:nvPr/>
+        </p:nvSpPr>
+        <p:spPr>
+          <a:xfrm>
+            <a:off x="640080" y="1828800"/>
+            <a:ext cx="3657600" cy="2651760"/>
+          </a:xfrm>
+          <a:prstGeom prst="rect">
+            <a:avLst/>
+          </a:prstGeom>
+          <a:noFill/>
+          <a:ln/>
+        </p:spPr>
+        <p:txBody>
+          <a:bodyPr wrap="square" lIns="0" tIns="0" rIns="0" bIns="0" rtlCol="0" anchor="t"/>
+          <a:lstStyle/>
+          <a:p>
+            <a:pPr marL="342900" indent="-342900">
+              <a:spcAft>
+                <a:spcPts val="500"/>
+              </a:spcAft>
+              <a:buSzPct val="100000"/>
+              <a:buChar char="•"/>
+            </a:pPr>
+            <a:r>
+              <a:rPr lang="en-US" sz="1300" dirty="0">
+                <a:solidFill>
+                  <a:schemeClr val="tx1"/>
+                </a:solidFill>
+                <a:latin typeface="Calibri" pitchFamily="34" charset="0"/>
+                <a:ea typeface="Calibri" pitchFamily="34" charset="-122"/>
+                <a:cs typeface="Calibri" pitchFamily="34" charset="-120"/>
+              </a:rPr>
+              <a:t>Now: verified in simulation, bit-exact RTL</a:t>
+            </a:r>
+            <a:endParaRPr lang="en-US" sz="1300" dirty="0"/>
+          </a:p>
+          <a:p>
+            <a:pPr marL="342900" indent="-342900">
+              <a:spcAft>
+                <a:spcPts val="500"/>
+              </a:spcAft>
+              <a:buSzPct val="100000"/>
+              <a:buChar char="•"/>
+            </a:pPr>
+            <a:r>
+              <a:rPr lang="en-US" sz="1300" dirty="0">
+                <a:solidFill>
+                  <a:schemeClr val="tx1"/>
+                </a:solidFill>
+                <a:latin typeface="Calibri" pitchFamily="34" charset="0"/>
+                <a:ea typeface="Calibri" pitchFamily="34" charset="-122"/>
+                <a:cs typeface="Calibri" pitchFamily="34" charset="-120"/>
+              </a:rPr>
+              <a:t>Next: run on the Tang Nano for the first MEASURED numbers</a:t>
+            </a:r>
+            <a:endParaRPr lang="en-US" sz="1300" dirty="0"/>
+          </a:p>
+          <a:p>
+            <a:pPr marL="342900" indent="-342900">
+              <a:buSzPct val="100000"/>
+              <a:buChar char="•"/>
+            </a:pPr>
+            <a:r>
+              <a:rPr lang="en-US" sz="1300" dirty="0">
+                <a:solidFill>
+                  <a:schemeClr val="tx1"/>
+                </a:solidFill>
+                <a:latin typeface="Calibri" pitchFamily="34" charset="0"/>
+                <a:ea typeface="Calibri" pitchFamily="34" charset="-122"/>
+                <a:cs typeface="Calibri" pitchFamily="34" charset="-120"/>
+              </a:rPr>
+              <a:t>Then: harder tests, external memory for sound and the second look</a:t>
+            </a:r>
+            <a:endParaRPr lang="en-US" sz="1300" dirty="0"/>
+          </a:p>
+        </p:txBody>
+      </p:sp>
+      <p:sp>
+        <p:nvSpPr>
+          <p:cNvPr id="7" name="Text 5"/>
+          <p:cNvSpPr txBox="1"/>
+          <p:nvPr/>
+        </p:nvSpPr>
+        <p:spPr>
+          <a:xfrm>
+            <a:off x="4846320" y="1389888"/>
+            <a:ext cx="3657600" cy="365760"/>
+          </a:xfrm>
+          <a:prstGeom prst="rect">
+            <a:avLst/>
+          </a:prstGeom>
+          <a:noFill/>
+          <a:ln/>
+        </p:spPr>
+        <p:txBody>
+          <a:bodyPr wrap="square" lIns="0" tIns="0" rIns="0" bIns="0" rtlCol="0" anchor="t"/>
+          <a:lstStyle/>
+          <a:p>
+            <a:pPr indent="0" marL="0">
+              <a:buNone/>
+            </a:pPr>
+            <a:r>
+              <a:rPr lang="en-US" sz="1700" b="1" dirty="0">
+                <a:solidFill>
+                  <a:schemeClr val="accent2"/>
+                </a:solidFill>
+                <a:latin typeface="Cambria" pitchFamily="34" charset="0"/>
+                <a:ea typeface="Cambria" pitchFamily="34" charset="-122"/>
+                <a:cs typeface="Cambria" pitchFamily="34" charset="-120"/>
+              </a:rPr>
+              <a:t>Track 2: the L AI model (later)</a:t>
+            </a:r>
+            <a:endParaRPr lang="en-US" sz="1700" dirty="0"/>
+          </a:p>
+        </p:txBody>
+      </p:sp>
+      <p:sp>
+        <p:nvSpPr>
+          <p:cNvPr id="8" name="Text 6"/>
+          <p:cNvSpPr txBox="1"/>
+          <p:nvPr/>
+        </p:nvSpPr>
+        <p:spPr>
+          <a:xfrm>
+            <a:off x="4846320" y="1828800"/>
+            <a:ext cx="3657600" cy="2651760"/>
+          </a:xfrm>
+          <a:prstGeom prst="rect">
+            <a:avLst/>
+          </a:prstGeom>
+          <a:noFill/>
+          <a:ln/>
+        </p:spPr>
+        <p:txBody>
+          <a:bodyPr wrap="square" lIns="0" tIns="0" rIns="0" bIns="0" rtlCol="0" anchor="t"/>
+          <a:lstStyle/>
+          <a:p>
+            <a:pPr marL="342900" indent="-342900">
+              <a:spcAft>
+                <a:spcPts val="400"/>
+              </a:spcAft>
+              <a:buSzPct val="100000"/>
+              <a:buChar char="•"/>
+            </a:pPr>
+            <a:r>
+              <a:rPr lang="en-US" sz="1200" dirty="0">
+                <a:solidFill>
+                  <a:schemeClr val="tx1"/>
+                </a:solidFill>
+                <a:latin typeface="Calibri" pitchFamily="34" charset="0"/>
+                <a:ea typeface="Calibri" pitchFamily="34" charset="-122"/>
+                <a:cs typeface="Calibri" pitchFamily="34" charset="-120"/>
+              </a:rPr>
+              <a:t>Gate 1: measure the model: firing rates, ablations, seeds</a:t>
+            </a:r>
+            <a:endParaRPr lang="en-US" sz="1200" dirty="0"/>
+          </a:p>
+          <a:p>
+            <a:pPr marL="342900" indent="-342900">
+              <a:spcAft>
+                <a:spcPts val="400"/>
+              </a:spcAft>
+              <a:buSzPct val="100000"/>
+              <a:buChar char="•"/>
+            </a:pPr>
+            <a:r>
+              <a:rPr lang="en-US" sz="1200" dirty="0">
+                <a:solidFill>
+                  <a:schemeClr val="tx1"/>
+                </a:solidFill>
+                <a:latin typeface="Calibri" pitchFamily="34" charset="0"/>
+                <a:ea typeface="Calibri" pitchFamily="34" charset="-122"/>
+                <a:cs typeface="Calibri" pitchFamily="34" charset="-120"/>
+              </a:rPr>
+              <a:t>Gate 2: fused GPU baseline; stop if a GPU is already close</a:t>
+            </a:r>
+            <a:endParaRPr lang="en-US" sz="1200" dirty="0"/>
+          </a:p>
+          <a:p>
+            <a:pPr marL="342900" indent="-342900">
+              <a:spcAft>
+                <a:spcPts val="400"/>
+              </a:spcAft>
+              <a:buSzPct val="100000"/>
+              <a:buChar char="•"/>
+            </a:pPr>
+            <a:r>
+              <a:rPr lang="en-US" sz="1200" dirty="0">
+                <a:solidFill>
+                  <a:schemeClr val="tx1"/>
+                </a:solidFill>
+                <a:latin typeface="Calibri" pitchFamily="34" charset="0"/>
+                <a:ea typeface="Calibri" pitchFamily="34" charset="-122"/>
+                <a:cs typeface="Calibri" pitchFamily="34" charset="-120"/>
+              </a:rPr>
+              <a:t>Gate 3: matrix-free version keeps its quality</a:t>
+            </a:r>
+            <a:endParaRPr lang="en-US" sz="1200" dirty="0"/>
+          </a:p>
+          <a:p>
+            <a:pPr marL="342900" indent="-342900">
+              <a:buSzPct val="100000"/>
+              <a:buChar char="•"/>
+            </a:pPr>
+            <a:r>
+              <a:rPr lang="en-US" sz="1200" dirty="0">
+                <a:solidFill>
+                  <a:schemeClr val="tx1"/>
+                </a:solidFill>
+                <a:latin typeface="Calibri" pitchFamily="34" charset="0"/>
+                <a:ea typeface="Calibri" pitchFamily="34" charset="-122"/>
+                <a:cs typeface="Calibri" pitchFamily="34" charset="-120"/>
+              </a:rPr>
+              <a:t>Then: simulator and FPGA; study memory: can constant-size state and event-driven reads move work from scarce HBM to cheaper DRAM or SRAM? (a question, not a claim)</a:t>
+            </a:r>
+            <a:endParaRPr lang="en-US" sz="1200" dirty="0"/>
+          </a:p>
+        </p:txBody>
+      </p:sp>
+      <p:sp>
+        <p:nvSpPr>
+          <p:cNvPr id="9" name="Text 7"/>
+          <p:cNvSpPr txBox="1"/>
+          <p:nvPr/>
+        </p:nvSpPr>
+        <p:spPr>
+          <a:xfrm>
+            <a:off x="457200" y="4617720"/>
+            <a:ext cx="8229600" cy="274320"/>
+          </a:xfrm>
+          <a:prstGeom prst="rect">
+            <a:avLst/>
+          </a:prstGeom>
+          <a:noFill/>
+          <a:ln/>
+        </p:spPr>
+        <p:txBody>
+          <a:bodyPr wrap="square" lIns="0" tIns="0" rIns="0" bIns="0" rtlCol="0" anchor="t"/>
+          <a:lstStyle/>
+          <a:p>
+            <a:pPr indent="0" marL="0">
+              <a:buNone/>
+            </a:pPr>
+            <a:r>
+              <a:rPr lang="en-US" sz="1100" dirty="0">
+                <a:solidFill>
+                  <a:schemeClr val="accent6"/>
+                </a:solidFill>
+                <a:latin typeface="Calibri" pitchFamily="34" charset="0"/>
+                <a:ea typeface="Calibri" pitchFamily="34" charset="-122"/>
+                <a:cs typeface="Calibri" pitchFamily="34" charset="-120"/>
+              </a:rPr>
+              <a:t>PLAN: the language-model track has small-scale evidence only (9M parameters).</a:t>
+            </a:r>
+            <a:endParaRPr lang="en-US" sz="1100" dirty="0"/>
+          </a:p>
+        </p:txBody>
+      </p:sp>
+      <p:sp>
+        <p:nvSpPr>
+          <p:cNvPr id="25" name="Slide Number Placeholder 0"/>
+          <p:cNvSpPr>
+            <a:spLocks noGrp="1"/>
+          </p:cNvSpPr>
+          <p:nvPr>
+            <p:ph type="sldNum" sz="quarter" idx="4294967295"/>
+          </p:nvPr>
+        </p:nvSpPr>
+        <p:spPr>
+          <a:xfrm>
+            <a:off x="8412480" y="4800600"/>
+            <a:ext cx="800000" cy="300000"/>
+          </a:xfrm>
+          <a:prstGeom prst="rect">
+            <a:avLst/>
+          </a:prstGeom>
+          <a:extLst>
+            <a:ext uri="{C572A759-6A51-4108-AA02-DFA0A04FC94B}">
+              <ma14:wrappingTextBoxFlag xmlns:ma14="http://schemas.microsoft.com/office/mac/drawingml/2011/main" val="0"/>
+            </a:ext>
+          </a:extLst>
+        </p:spPr>
+        <p:txBody>
+          <a:bodyPr/>
+          <a:lstStyle>
+            <a:lvl1pPr>
+              <a:defRPr sz="1000">
+                <a:solidFill>
+                  <a:schemeClr val="accent6"/>
+                </a:solidFill>
+              </a:defRPr>
+            </a:lvl1pPr>
+          </a:lstStyle>
+          <a:p>
+            <a:pPr algn="l"/>
+            <a:fld id="{F7021451-1387-4CA6-816F-3879F97B5CBC}" type="slidenum">
+              <a:rPr b="0" lang="en-US"/>
+              <a:t>17</a:t>
+            </a:fld>
+            <a:endParaRPr lang="en-US"/>
+          </a:p>
+        </p:txBody>
+      </p:sp>
+    </p:spTree>
+  </p:cSld>
+  <p:clrMapOvr>
+    <a:masterClrMapping/>
+  </p:clrMapOvr>
+</p:sld>
+</file>
+
+<file path=ppt/slides/slide18.xml><?xml version="1.0" encoding="utf-8"?>
+<p:sld xmlns:a="http://schemas.openxmlformats.org/drawingml/2006/main" xmlns:r="http://schemas.openxmlformats.org/officeDocument/2006/relationships" xmlns:p="http://schemas.openxmlformats.org/presentationml/2006/main">
+  <p:cSld name="Slide 18">
+    <p:spTree>
+      <p:nvGrpSpPr>
+        <p:cNvPr id="1" name=""/>
+        <p:cNvGrpSpPr/>
+        <p:nvPr/>
+      </p:nvGrpSpPr>
+      <p:grpSpPr>
+        <a:xfrm>
+          <a:off x="0" y="0"/>
+          <a:ext cx="0" cy="0"/>
+          <a:chOff x="0" y="0"/>
+          <a:chExt cx="0" cy="0"/>
+        </a:xfrm>
+      </p:grpSpPr>
+      <p:sp>
+        <p:nvSpPr>
+          <p:cNvPr id="2" name="Text 0"/>
+          <p:cNvSpPr/>
+          <p:nvPr>
+            <p:ph idx="100" type="title" hasCustomPrompt="1"/>
+          </p:nvPr>
+        </p:nvSpPr>
+        <p:spPr>
+          <a:xfrm>
             <a:off x="548640" y="1371600"/>
             <a:ext cx="8046720" cy="1280160"/>
           </a:xfrm>
@@ -9595,7 +10649,7 @@
                 <a:ea typeface="Calibri" pitchFamily="34" charset="-122"/>
                 <a:cs typeface="Calibri" pitchFamily="34" charset="-120"/>
               </a:rPr>
-              <a:t>Share</a:t>
+              <a:t>Share (optional)</a:t>
             </a:r>
             <a:endParaRPr lang="en-US" sz="1500" dirty="0"/>
           </a:p>
@@ -9634,7 +10688,7 @@
                 <a:ea typeface="Calibri" pitchFamily="34" charset="-122"/>
                 <a:cs typeface="Calibri" pitchFamily="34" charset="-120"/>
               </a:rPr>
-              <a:t>A second chip takes over the memory, or two memories merge by adding counts.</a:t>
+              <a:t>One chip works alone. Two chips can merge what they learned by adding counts, or one hands its memory to the other. A normal network cannot do this.</a:t>
             </a:r>
             <a:endParaRPr lang="en-US" sz="1200" dirty="0"/>
           </a:p>

</xml_diff>

<commit_message>
Deck: hypothesis slide and fabrication slide (20 slides); hypothesis note
Co-Authored-By: Claude Sonnet 5.5 <noreply@anthropic.com>
Claude-Session: https://claude.ai/code/session_013SV3SfseaABNzbLHJy34eL
</commit_message>
<xml_diff>
--- a/docs/L_pitch_draft.pptx
+++ b/docs/L_pitch_draft.pptx
@@ -23,9 +23,11 @@
     <p:sldId id="271" r:id="rId17"/>
     <p:sldId id="272" r:id="rId18"/>
     <p:sldId id="273" r:id="rId19"/>
+    <p:sldId id="274" r:id="rId20"/>
+    <p:sldId id="275" r:id="rId21"/>
   </p:sldIdLst>
   <p:notesMasterIdLst>
-    <p:notesMasterId r:id="rId20"/>
+    <p:notesMasterId r:id="rId22"/>
   </p:notesMasterIdLst>
   <p:sldSz cx="9144000" cy="5143500"/>
   <p:notesSz cx="5143500" cy="9144000"/>
@@ -124,18 +126,18 @@
   <p:extLst>
     <p:ext uri="{521415D9-36F7-43E2-AB2F-B90AF26B5E84}">
       <p14:sectionLst xmlns:p14="http://schemas.microsoft.com/office/powerpoint/2010/main">
-        <p14:section name="Open" id="{2020365c-0ae3-34aa-913e-74444ef698de}">
+        <p14:section name="Open" id="{abd375a9-7095-07fd-a7b2-eca2b76bb588}">
           <p14:sldIdLst>
             <p14:sldId id="256"/>
           </p14:sldIdLst>
         </p14:section>
-        <p14:section name="Why" id="{1b147422-f91c-b7b5-9436-7df7600e48b5}">
+        <p14:section name="Why" id="{2d3deca2-ad86-84e8-635c-2147a89318b9}">
           <p14:sldIdLst>
             <p14:sldId id="257"/>
             <p14:sldId id="258"/>
           </p14:sldIdLst>
         </p14:section>
-        <p14:section name="Results" id="{c17449ae-f85a-74d6-d213-de6d5af3f4df}">
+        <p14:section name="Results" id="{29614bab-de19-7474-d1f5-67abd267ddd7}">
           <p14:sldIdLst>
             <p14:sldId id="259"/>
             <p14:sldId id="260"/>
@@ -146,24 +148,26 @@
             <p14:sldId id="265"/>
           </p14:sldIdLst>
         </p14:section>
-        <p14:section name="Build" id="{9e8fddcb-83ae-7ce0-f4f3-4f594dc4d349}">
+        <p14:section name="Build" id="{b662091f-514f-98bd-1719-c8ae63c24758}">
           <p14:sldIdLst>
             <p14:sldId id="266"/>
             <p14:sldId id="267"/>
           </p14:sldIdLst>
         </p14:section>
-        <p14:section name="Honest" id="{2d829c2f-225d-7168-7808-9b68cd68324e}">
+        <p14:section name="Honest" id="{bf5cc849-e9cc-beb1-8ca0-3847ad4598f2}">
           <p14:sldIdLst>
             <p14:sldId id="268"/>
             <p14:sldId id="269"/>
             <p14:sldId id="270"/>
+            <p14:sldId id="271"/>
           </p14:sldIdLst>
         </p14:section>
-        <p14:section name="Next" id="{159c12d9-4a4a-71ff-917d-ccf5c56edc7d}">
+        <p14:section name="Next" id="{72f6f034-01de-077b-ce46-d2d3fd582523}">
           <p14:sldIdLst>
-            <p14:sldId id="271"/>
             <p14:sldId id="272"/>
             <p14:sldId id="273"/>
+            <p14:sldId id="274"/>
+            <p14:sldId id="275"/>
           </p14:sldIdLst>
         </p14:section>
       </p14:sectionLst>
@@ -3652,7 +3656,7 @@
           <a:p>
             <a:r>
               <a:rPr lang="en-US" dirty="0"/>
-              <a:t>This is the slide I want you to remember. Nothing has run on hardware. Staged clothing is about 82 percent, five points under its one-pass number, and I tried many fixes. A trained CNN is still ahead on clothing by about two points. The tests are small and the noise is simulated; the two-sense data is paired by class, not real audio-visual recordings. The second look costs about 2.8 times the memory, and a few steps still run on the host.</a:t>
+              <a:t>This is the hypothesis, said as a hypothesis. A brain-style model with a constant-size state, sparse event-driven activity and low-bit weights, on a chip built for it, should need much less memory traffic and energy per token than a transformer on a GPU at the same quality. That could reduce the demand for scarce high-bandwidth memory and the heat and water of serving. The model has to be proven first, because the chip can only exploit those properties. It is falsified if the quality edge disappears at larger sizes or when matrix-free, if a fused GPU version gets within about three times of the simulated chip, or if a transformer chip with the same memory matches the energy per token. The thresholds are my proposals, not data.</a:t>
             </a:r>
             <a:endParaRPr lang="en-US" dirty="0"/>
           </a:p>
@@ -3740,7 +3744,7 @@
           <a:p>
             <a:r>
               <a:rPr lang="en-US" dirty="0"/>
-              <a:t>We are not the first continual-learning chip. Hyperdimensional-computing accelerators and event-driven spiking chips such as Loihi 2, TrueNorth and SpiNNaker exist. What we add is the combination: dreams from small counters so no examples are stored, a night that ends by itself, consolidation that scales with the data, and a design with no multiplier or matrix that is bit-exact from raw senses to the decision.</a:t>
+              <a:t>This is the slide I want you to remember. Nothing has run on hardware. Staged clothing is about 82 percent, five points under its one-pass number, and I tried many fixes. A trained CNN is still ahead on clothing by about two points. The tests are small and the noise is simulated; the two-sense data is paired by class, not real audio-visual recordings. The second look costs about 2.8 times the memory, and a few steps still run on the host.</a:t>
             </a:r>
             <a:endParaRPr lang="en-US" dirty="0"/>
           </a:p>
@@ -3828,7 +3832,7 @@
           <a:p>
             <a:r>
               <a:rPr lang="en-US" dirty="0"/>
-              <a:t>What comes next. The model and RTL are done and verified in simulation. The next milestone is the real Tang Nano board, which gives the first measured numbers. Then harder tests: a larger vocabulary, real recorded noise and a harder image set. Later, a matrix-free chip for the L language model, and external memory for sound and the second look. No fabrication is planned yet.</a:t>
+              <a:t>We are not the first continual-learning chip. Hyperdimensional-computing accelerators and event-driven spiking chips such as Loihi 2, TrueNorth and SpiNNaker exist. What we add is the combination: dreams from small counters so no examples are stored, a night that ends by itself, consolidation that scales with the data, and a design with no multiplier or matrix that is bit-exact from raw senses to the decision.</a:t>
             </a:r>
             <a:endParaRPr lang="en-US" dirty="0"/>
           </a:p>
@@ -3916,7 +3920,7 @@
           <a:p>
             <a:r>
               <a:rPr lang="en-US" dirty="0"/>
-              <a:t>We plan to approach the bigger problem on two tracks. Track one is the L chip, which is done in simulation and next goes to a real board. Track two is the L AI model for language, which has small-scale evidence only, so it goes through gates: first measure the model, then compare against a fused GPU implementation and stop if the GPU is already close, then check that a matrix-free version keeps its quality. Only then a simulator and an FPGA. Later we study memory: whether the constant-size state and event-driven reads can move work from scarce high-bandwidth memory to cheaper DRAM or on-chip memory. That is a question to study, not a claim.</a:t>
+              <a:t>What comes next. The model and RTL are done and verified in simulation. The next milestone is the real Tang Nano board, which gives the first measured numbers. Then harder tests: a larger vocabulary, real recorded noise and a harder image set. Later, a matrix-free chip for the L language model, and external memory for sound and the second look. No fabrication is planned yet.</a:t>
             </a:r>
             <a:endParaRPr lang="en-US" dirty="0"/>
           </a:p>
@@ -4004,7 +4008,7 @@
           <a:p>
             <a:r>
               <a:rPr lang="en-US" dirty="0"/>
-              <a:t>To close: L is a chip design that keeps learning after it ships. It keeps what it knew, shares what it learned, and needs no multiplier. It is weaker than a trained network in a few places, and I have told you where. Thank you, I am happy to take questions.</a:t>
+              <a:t>We plan to approach the bigger problem on two tracks. Track one is the L chip, which is done in simulation and next goes to a real board. Track two is the L AI model for language, which has small-scale evidence only, so it goes through gates: first measure the model, then compare against a fused GPU implementation and stop if the GPU is already close, then check that a matrix-free version keeps its quality. Only then a simulator and an FPGA. Later we study memory: whether the constant-size state and event-driven reads can move work from scarce high-bandwidth memory to cheaper DRAM or on-chip memory. That is a question to study, not a claim.</a:t>
             </a:r>
             <a:endParaRPr lang="en-US" dirty="0"/>
           </a:p>
@@ -4028,6 +4032,94 @@
             <a:fld id="{F7021451-1387-4CA6-816F-3879F97B5CBC}" type="slidenum">
               <a:rPr lang="en-US"/>
               <a:t>18</a:t>
+            </a:fld>
+            <a:endParaRPr lang="en-US"/>
+          </a:p>
+        </p:txBody>
+      </p:sp>
+    </p:spTree>
+    <p:extLst>
+      <p:ext uri="{BB962C8B-B14F-4D97-AF65-F5344CB8AC3E}">
+        <p14:creationId xmlns:p14="http://schemas.microsoft.com/office/powerpoint/2010/main" val="1024086991"/>
+      </p:ext>
+    </p:extLst>
+  </p:cSld>
+  <p:clrMapOvr>
+    <a:masterClrMapping/>
+  </p:clrMapOvr>
+</p:notes>
+</file>
+
+<file path=ppt/notesSlides/notesSlide19.xml><?xml version="1.0" encoding="utf-8"?>
+<p:notes xmlns:a="http://schemas.openxmlformats.org/drawingml/2006/main" xmlns:r="http://schemas.openxmlformats.org/officeDocument/2006/relationships" xmlns:p="http://schemas.openxmlformats.org/presentationml/2006/main">
+  <p:cSld>
+    <p:spTree>
+      <p:nvGrpSpPr>
+        <p:cNvPr id="1" name=""/>
+        <p:cNvGrpSpPr/>
+        <p:nvPr/>
+      </p:nvGrpSpPr>
+      <p:grpSpPr>
+        <a:xfrm>
+          <a:off x="0" y="0"/>
+          <a:ext cx="0" cy="0"/>
+          <a:chOff x="0" y="0"/>
+          <a:chExt cx="0" cy="0"/>
+        </a:xfrm>
+      </p:grpSpPr>
+      <p:sp>
+        <p:nvSpPr>
+          <p:cNvPr id="2" name="Slide Image Placeholder 1"/>
+          <p:cNvSpPr>
+            <a:spLocks noGrp="1" noRot="1" noChangeAspect="1"/>
+          </p:cNvSpPr>
+          <p:nvPr>
+            <p:ph type="sldImg"/>
+          </p:nvPr>
+        </p:nvSpPr>
+        <p:spPr/>
+      </p:sp>
+      <p:sp>
+        <p:nvSpPr>
+          <p:cNvPr id="3" name="Notes Placeholder 2"/>
+          <p:cNvSpPr>
+            <a:spLocks noGrp="1"/>
+          </p:cNvSpPr>
+          <p:nvPr>
+            <p:ph type="body" idx="1"/>
+          </p:nvPr>
+        </p:nvSpPr>
+        <p:spPr/>
+        <p:txBody>
+          <a:bodyPr/>
+          <a:lstStyle/>
+          <a:p>
+            <a:r>
+              <a:rPr lang="en-US" dirty="0"/>
+              <a:t>On fabrication. The open 130 nanometre flow is good for a prototype but not comparable to a GPU. Today's data-centre GPUs use a five-nanometre-class process and dies up to about 800 square millimetres. Reaching that node costs tens of millions of dollars and needs foundry access we do not have, so we will not claim it. The plan is to write the design independent of the node, compare energy against GPUs at a GPU-class node using published scaling, which is an uncertain estimate, prove the design on an FPGA, and tape out at an accessible mature node, around 28 to 65 nanometres through a university or shuttle programme, when funded. Silicon CMOS is the only practical material for dense logic: mature, high yield, full tools. Its limits are cost at advanced nodes, heat, SRAM that no longer shrinks as fast, and supply concentrated in a few fabs. Other materials are not ready for dense logic. All cost figures are estimates from memory of public reports; verify before quoting.</a:t>
+            </a:r>
+            <a:endParaRPr lang="en-US" dirty="0"/>
+          </a:p>
+        </p:txBody>
+      </p:sp>
+      <p:sp>
+        <p:nvSpPr>
+          <p:cNvPr id="4" name="Slide Number Placeholder 3"/>
+          <p:cNvSpPr>
+            <a:spLocks noGrp="1"/>
+          </p:cNvSpPr>
+          <p:nvPr>
+            <p:ph type="sldNum" sz="quarter" idx="10"/>
+          </p:nvPr>
+        </p:nvSpPr>
+        <p:spPr/>
+        <p:txBody>
+          <a:bodyPr/>
+          <a:lstStyle/>
+          <a:p>
+            <a:fld id="{F7021451-1387-4CA6-816F-3879F97B5CBC}" type="slidenum">
+              <a:rPr lang="en-US"/>
+              <a:t>19</a:t>
             </a:fld>
             <a:endParaRPr lang="en-US"/>
           </a:p>
@@ -4116,6 +4208,94 @@
             <a:fld id="{F7021451-1387-4CA6-816F-3879F97B5CBC}" type="slidenum">
               <a:rPr lang="en-US"/>
               <a:t>2</a:t>
+            </a:fld>
+            <a:endParaRPr lang="en-US"/>
+          </a:p>
+        </p:txBody>
+      </p:sp>
+    </p:spTree>
+    <p:extLst>
+      <p:ext uri="{BB962C8B-B14F-4D97-AF65-F5344CB8AC3E}">
+        <p14:creationId xmlns:p14="http://schemas.microsoft.com/office/powerpoint/2010/main" val="1024086991"/>
+      </p:ext>
+    </p:extLst>
+  </p:cSld>
+  <p:clrMapOvr>
+    <a:masterClrMapping/>
+  </p:clrMapOvr>
+</p:notes>
+</file>
+
+<file path=ppt/notesSlides/notesSlide20.xml><?xml version="1.0" encoding="utf-8"?>
+<p:notes xmlns:a="http://schemas.openxmlformats.org/drawingml/2006/main" xmlns:r="http://schemas.openxmlformats.org/officeDocument/2006/relationships" xmlns:p="http://schemas.openxmlformats.org/presentationml/2006/main">
+  <p:cSld>
+    <p:spTree>
+      <p:nvGrpSpPr>
+        <p:cNvPr id="1" name=""/>
+        <p:cNvGrpSpPr/>
+        <p:nvPr/>
+      </p:nvGrpSpPr>
+      <p:grpSpPr>
+        <a:xfrm>
+          <a:off x="0" y="0"/>
+          <a:ext cx="0" cy="0"/>
+          <a:chOff x="0" y="0"/>
+          <a:chExt cx="0" cy="0"/>
+        </a:xfrm>
+      </p:grpSpPr>
+      <p:sp>
+        <p:nvSpPr>
+          <p:cNvPr id="2" name="Slide Image Placeholder 1"/>
+          <p:cNvSpPr>
+            <a:spLocks noGrp="1" noRot="1" noChangeAspect="1"/>
+          </p:cNvSpPr>
+          <p:nvPr>
+            <p:ph type="sldImg"/>
+          </p:nvPr>
+        </p:nvSpPr>
+        <p:spPr/>
+      </p:sp>
+      <p:sp>
+        <p:nvSpPr>
+          <p:cNvPr id="3" name="Notes Placeholder 2"/>
+          <p:cNvSpPr>
+            <a:spLocks noGrp="1"/>
+          </p:cNvSpPr>
+          <p:nvPr>
+            <p:ph type="body" idx="1"/>
+          </p:nvPr>
+        </p:nvSpPr>
+        <p:spPr/>
+        <p:txBody>
+          <a:bodyPr/>
+          <a:lstStyle/>
+          <a:p>
+            <a:r>
+              <a:rPr lang="en-US" dirty="0"/>
+              <a:t>To close: L is a chip design that keeps learning after it ships. It keeps what it knew, shares what it learned, and needs no multiplier. It is weaker than a trained network in a few places, and I have told you where. Thank you, I am happy to take questions.</a:t>
+            </a:r>
+            <a:endParaRPr lang="en-US" dirty="0"/>
+          </a:p>
+        </p:txBody>
+      </p:sp>
+      <p:sp>
+        <p:nvSpPr>
+          <p:cNvPr id="4" name="Slide Number Placeholder 3"/>
+          <p:cNvSpPr>
+            <a:spLocks noGrp="1"/>
+          </p:cNvSpPr>
+          <p:nvPr>
+            <p:ph type="sldNum" sz="quarter" idx="10"/>
+          </p:nvPr>
+        </p:nvSpPr>
+        <p:spPr/>
+        <p:txBody>
+          <a:bodyPr/>
+          <a:lstStyle/>
+          <a:p>
+            <a:fld id="{F7021451-1387-4CA6-816F-3879F97B5CBC}" type="slidenum">
+              <a:rPr lang="en-US"/>
+              <a:t>20</a:t>
             </a:fld>
             <a:endParaRPr lang="en-US"/>
           </a:p>
@@ -7296,7 +7476,7 @@
                 <a:ea typeface="Cambria" pitchFamily="34" charset="-122"/>
                 <a:cs typeface="Cambria" pitchFamily="34" charset="-120"/>
               </a:rPr>
-              <a:t>Where it is level, and where it is weaker</a:t>
+              <a:t>The hypothesis we will test</a:t>
             </a:r>
             <a:endParaRPr lang="en-US" sz="3000" dirty="0"/>
           </a:p>
@@ -7304,14 +7484,290 @@
       </p:sp>
       <p:sp>
         <p:nvSpPr>
-          <p:cNvPr id="3" name="Text 1"/>
+          <p:cNvPr id="3" name="card"/>
+          <p:cNvSpPr/>
+          <p:nvPr/>
+        </p:nvSpPr>
+        <p:spPr>
+          <a:xfrm>
+            <a:off x="457200" y="1234440"/>
+            <a:ext cx="8229600" cy="1234440"/>
+          </a:xfrm>
+          <a:prstGeom prst="roundRect">
+            <a:avLst>
+              <a:gd name="adj" fmla="val 7407"/>
+            </a:avLst>
+          </a:prstGeom>
+          <a:solidFill>
+            <a:srgbClr val="FFF4DD"/>
+          </a:solidFill>
+          <a:ln w="12700">
+            <a:solidFill>
+              <a:srgbClr val="FFF4DD"/>
+            </a:solidFill>
+            <a:prstDash val="solid"/>
+          </a:ln>
+        </p:spPr>
+      </p:sp>
+      <p:sp>
+        <p:nvSpPr>
+          <p:cNvPr id="4" name="Text 2"/>
           <p:cNvSpPr txBox="1"/>
           <p:nvPr/>
         </p:nvSpPr>
         <p:spPr>
           <a:xfrm>
-            <a:off x="457200" y="1280160"/>
-            <a:ext cx="8229600" cy="3291840"/>
+            <a:off x="640080" y="1325880"/>
+            <a:ext cx="7863840" cy="365760"/>
+          </a:xfrm>
+          <a:prstGeom prst="rect">
+            <a:avLst/>
+          </a:prstGeom>
+          <a:noFill/>
+          <a:ln/>
+        </p:spPr>
+        <p:txBody>
+          <a:bodyPr wrap="square" lIns="0" tIns="0" rIns="0" bIns="0" rtlCol="0" anchor="t"/>
+          <a:lstStyle/>
+          <a:p>
+            <a:pPr indent="0" marL="0">
+              <a:buNone/>
+            </a:pPr>
+            <a:r>
+              <a:rPr lang="en-US" sz="1200" b="1" dirty="0">
+                <a:solidFill>
+                  <a:schemeClr val="accent1"/>
+                </a:solidFill>
+                <a:latin typeface="Calibri" pitchFamily="34" charset="0"/>
+                <a:ea typeface="Calibri" pitchFamily="34" charset="-122"/>
+                <a:cs typeface="Calibri" pitchFamily="34" charset="-120"/>
+              </a:rPr>
+              <a:t>HYPOTHESIS (not a result)</a:t>
+            </a:r>
+            <a:endParaRPr lang="en-US" sz="1200" dirty="0"/>
+          </a:p>
+        </p:txBody>
+      </p:sp>
+      <p:sp>
+        <p:nvSpPr>
+          <p:cNvPr id="5" name="Text 3"/>
+          <p:cNvSpPr txBox="1"/>
+          <p:nvPr/>
+        </p:nvSpPr>
+        <p:spPr>
+          <a:xfrm>
+            <a:off x="640080" y="1600200"/>
+            <a:ext cx="7863840" cy="822960"/>
+          </a:xfrm>
+          <a:prstGeom prst="rect">
+            <a:avLst/>
+          </a:prstGeom>
+          <a:noFill/>
+          <a:ln/>
+        </p:spPr>
+        <p:txBody>
+          <a:bodyPr wrap="square" lIns="0" tIns="0" rIns="0" bIns="0" rtlCol="0" anchor="t"/>
+          <a:lstStyle/>
+          <a:p>
+            <a:pPr indent="0" marL="0">
+              <a:buNone/>
+            </a:pPr>
+            <a:r>
+              <a:rPr lang="en-US" sz="1400" dirty="0">
+                <a:solidFill>
+                  <a:schemeClr val="tx1"/>
+                </a:solidFill>
+                <a:latin typeface="Calibri" pitchFamily="34" charset="0"/>
+                <a:ea typeface="Calibri" pitchFamily="34" charset="-122"/>
+                <a:cs typeface="Calibri" pitchFamily="34" charset="-120"/>
+              </a:rPr>
+              <a:t>A brain-style model with constant-size state, sparse event-driven activity and low-bit weights, on a chip built for it, needs far less memory traffic and energy per token than a transformer on a GPU at the same quality, and so less scarce HBM, heat and water.</a:t>
+            </a:r>
+            <a:endParaRPr lang="en-US" sz="1400" dirty="0"/>
+          </a:p>
+        </p:txBody>
+      </p:sp>
+      <p:sp>
+        <p:nvSpPr>
+          <p:cNvPr id="6" name="card"/>
+          <p:cNvSpPr/>
+          <p:nvPr/>
+        </p:nvSpPr>
+        <p:spPr>
+          <a:xfrm>
+            <a:off x="457200" y="2651760"/>
+            <a:ext cx="4023360" cy="1920240"/>
+          </a:xfrm>
+          <a:prstGeom prst="roundRect">
+            <a:avLst>
+              <a:gd name="adj" fmla="val 4762"/>
+            </a:avLst>
+          </a:prstGeom>
+          <a:solidFill>
+            <a:schemeClr val="bg2"/>
+          </a:solidFill>
+          <a:ln w="12700">
+            <a:solidFill>
+              <a:schemeClr val="bg2"/>
+            </a:solidFill>
+            <a:prstDash val="solid"/>
+          </a:ln>
+        </p:spPr>
+      </p:sp>
+      <p:sp>
+        <p:nvSpPr>
+          <p:cNvPr id="7" name="card"/>
+          <p:cNvSpPr/>
+          <p:nvPr/>
+        </p:nvSpPr>
+        <p:spPr>
+          <a:xfrm>
+            <a:off x="4663440" y="2651760"/>
+            <a:ext cx="4023360" cy="1920240"/>
+          </a:xfrm>
+          <a:prstGeom prst="roundRect">
+            <a:avLst>
+              <a:gd name="adj" fmla="val 4762"/>
+            </a:avLst>
+          </a:prstGeom>
+          <a:solidFill>
+            <a:schemeClr val="bg2"/>
+          </a:solidFill>
+          <a:ln w="12700">
+            <a:solidFill>
+              <a:schemeClr val="bg2"/>
+            </a:solidFill>
+            <a:prstDash val="solid"/>
+          </a:ln>
+        </p:spPr>
+      </p:sp>
+      <p:sp>
+        <p:nvSpPr>
+          <p:cNvPr id="8" name="Text 6"/>
+          <p:cNvSpPr txBox="1"/>
+          <p:nvPr/>
+        </p:nvSpPr>
+        <p:spPr>
+          <a:xfrm>
+            <a:off x="640080" y="2743200"/>
+            <a:ext cx="3657600" cy="365760"/>
+          </a:xfrm>
+          <a:prstGeom prst="rect">
+            <a:avLst/>
+          </a:prstGeom>
+          <a:noFill/>
+          <a:ln/>
+        </p:spPr>
+        <p:txBody>
+          <a:bodyPr wrap="square" lIns="0" tIns="0" rIns="0" bIns="0" rtlCol="0" anchor="t"/>
+          <a:lstStyle/>
+          <a:p>
+            <a:pPr indent="0" marL="0">
+              <a:buNone/>
+            </a:pPr>
+            <a:r>
+              <a:rPr lang="en-US" sz="1500" b="1" dirty="0">
+                <a:solidFill>
+                  <a:schemeClr val="accent2"/>
+                </a:solidFill>
+                <a:latin typeface="Cambria" pitchFamily="34" charset="0"/>
+                <a:ea typeface="Cambria" pitchFamily="34" charset="-122"/>
+                <a:cs typeface="Cambria" pitchFamily="34" charset="-120"/>
+              </a:rPr>
+              <a:t>Why the model comes first</a:t>
+            </a:r>
+            <a:endParaRPr lang="en-US" sz="1500" dirty="0"/>
+          </a:p>
+        </p:txBody>
+      </p:sp>
+      <p:sp>
+        <p:nvSpPr>
+          <p:cNvPr id="9" name="Text 7"/>
+          <p:cNvSpPr txBox="1"/>
+          <p:nvPr/>
+        </p:nvSpPr>
+        <p:spPr>
+          <a:xfrm>
+            <a:off x="640080" y="3108960"/>
+            <a:ext cx="3657600" cy="1371600"/>
+          </a:xfrm>
+          <a:prstGeom prst="rect">
+            <a:avLst/>
+          </a:prstGeom>
+          <a:noFill/>
+          <a:ln/>
+        </p:spPr>
+        <p:txBody>
+          <a:bodyPr wrap="square" lIns="0" tIns="0" rIns="0" bIns="0" rtlCol="0" anchor="t"/>
+          <a:lstStyle/>
+          <a:p>
+            <a:pPr indent="0" marL="0">
+              <a:buNone/>
+            </a:pPr>
+            <a:r>
+              <a:rPr lang="en-US" sz="1200" dirty="0">
+                <a:solidFill>
+                  <a:schemeClr val="tx1"/>
+                </a:solidFill>
+                <a:latin typeface="Calibri" pitchFamily="34" charset="0"/>
+                <a:ea typeface="Calibri" pitchFamily="34" charset="-122"/>
+                <a:cs typeface="Calibri" pitchFamily="34" charset="-120"/>
+              </a:rPr>
+              <a:t>The savings come from the model's state size, sparsity and low-bit weights. A chip can only exploit them, not create them. L Cortex proves the principles at small scale only.</a:t>
+            </a:r>
+            <a:endParaRPr lang="en-US" sz="1200" dirty="0"/>
+          </a:p>
+        </p:txBody>
+      </p:sp>
+      <p:sp>
+        <p:nvSpPr>
+          <p:cNvPr id="10" name="Text 8"/>
+          <p:cNvSpPr txBox="1"/>
+          <p:nvPr/>
+        </p:nvSpPr>
+        <p:spPr>
+          <a:xfrm>
+            <a:off x="4846320" y="2743200"/>
+            <a:ext cx="3657600" cy="365760"/>
+          </a:xfrm>
+          <a:prstGeom prst="rect">
+            <a:avLst/>
+          </a:prstGeom>
+          <a:noFill/>
+          <a:ln/>
+        </p:spPr>
+        <p:txBody>
+          <a:bodyPr wrap="square" lIns="0" tIns="0" rIns="0" bIns="0" rtlCol="0" anchor="t"/>
+          <a:lstStyle/>
+          <a:p>
+            <a:pPr indent="0" marL="0">
+              <a:buNone/>
+            </a:pPr>
+            <a:r>
+              <a:rPr lang="en-US" sz="1500" b="1" dirty="0">
+                <a:solidFill>
+                  <a:schemeClr val="accent4"/>
+                </a:solidFill>
+                <a:latin typeface="Cambria" pitchFamily="34" charset="0"/>
+                <a:ea typeface="Cambria" pitchFamily="34" charset="-122"/>
+                <a:cs typeface="Cambria" pitchFamily="34" charset="-120"/>
+              </a:rPr>
+              <a:t>It is falsified if</a:t>
+            </a:r>
+            <a:endParaRPr lang="en-US" sz="1500" dirty="0"/>
+          </a:p>
+        </p:txBody>
+      </p:sp>
+      <p:sp>
+        <p:nvSpPr>
+          <p:cNvPr id="11" name="Text 9"/>
+          <p:cNvSpPr txBox="1"/>
+          <p:nvPr/>
+        </p:nvSpPr>
+        <p:spPr>
+          <a:xfrm>
+            <a:off x="4846320" y="3108960"/>
+            <a:ext cx="3657600" cy="1417320"/>
           </a:xfrm>
           <a:prstGeom prst="rect">
             <a:avLst/>
@@ -7325,13 +7781,13 @@
           <a:p>
             <a:pPr marL="342900" indent="-342900">
               <a:spcAft>
-                <a:spcPts val="900"/>
+                <a:spcPts val="400"/>
               </a:spcAft>
               <a:buSzPct val="100000"/>
               <a:buChar char="•"/>
             </a:pPr>
             <a:r>
-              <a:rPr lang="en-US" sz="1600" dirty="0">
+              <a:rPr lang="en-US" sz="1200" dirty="0">
                 <a:solidFill>
                   <a:schemeClr val="tx1"/>
                 </a:solidFill>
@@ -7339,20 +7795,20 @@
                 <a:ea typeface="Calibri" pitchFamily="34" charset="-122"/>
                 <a:cs typeface="Calibri" pitchFamily="34" charset="-120"/>
               </a:rPr>
-              <a:t>Nothing is measured on hardware yet: every chip number is simulated</a:t>
-            </a:r>
-            <a:endParaRPr lang="en-US" sz="1600" dirty="0"/>
+              <a:t>L loses its quality edge at larger sizes or when matrix-free</a:t>
+            </a:r>
+            <a:endParaRPr lang="en-US" sz="1200" dirty="0"/>
           </a:p>
           <a:p>
             <a:pPr marL="342900" indent="-342900">
               <a:spcAft>
-                <a:spcPts val="900"/>
+                <a:spcPts val="400"/>
               </a:spcAft>
               <a:buSzPct val="100000"/>
               <a:buChar char="•"/>
             </a:pPr>
             <a:r>
-              <a:rPr lang="en-US" sz="1600" dirty="0">
+              <a:rPr lang="en-US" sz="1200" dirty="0">
                 <a:solidFill>
                   <a:schemeClr val="tx1"/>
                 </a:solidFill>
@@ -7360,20 +7816,17 @@
                 <a:ea typeface="Calibri" pitchFamily="34" charset="-122"/>
                 <a:cs typeface="Calibri" pitchFamily="34" charset="-120"/>
               </a:rPr>
-              <a:t>Staged clothing about 82%, 5 points below its one pass; many ideas tried</a:t>
-            </a:r>
-            <a:endParaRPr lang="en-US" sz="1600" dirty="0"/>
+              <a:t>A fused GPU version gets within about 3x of the simulated chip</a:t>
+            </a:r>
+            <a:endParaRPr lang="en-US" sz="1200" dirty="0"/>
           </a:p>
           <a:p>
             <a:pPr marL="342900" indent="-342900">
-              <a:spcAft>
-                <a:spcPts val="900"/>
-              </a:spcAft>
               <a:buSzPct val="100000"/>
               <a:buChar char="•"/>
             </a:pPr>
             <a:r>
-              <a:rPr lang="en-US" sz="1600" dirty="0">
+              <a:rPr lang="en-US" sz="1200" dirty="0">
                 <a:solidFill>
                   <a:schemeClr val="tx1"/>
                 </a:solidFill>
@@ -7381,51 +7834,9 @@
                 <a:ea typeface="Calibri" pitchFamily="34" charset="-122"/>
                 <a:cs typeface="Calibri" pitchFamily="34" charset="-120"/>
               </a:rPr>
-              <a:t>A trained CNN is ahead by about 2 points on clothing when all data is available</a:t>
-            </a:r>
-            <a:endParaRPr lang="en-US" sz="1600" dirty="0"/>
-          </a:p>
-          <a:p>
-            <a:pPr marL="342900" indent="-342900">
-              <a:spcAft>
-                <a:spcPts val="900"/>
-              </a:spcAft>
-              <a:buSzPct val="100000"/>
-              <a:buChar char="•"/>
-            </a:pPr>
-            <a:r>
-              <a:rPr lang="en-US" sz="1600" dirty="0">
-                <a:solidFill>
-                  <a:schemeClr val="tx1"/>
-                </a:solidFill>
-                <a:latin typeface="Calibri" pitchFamily="34" charset="0"/>
-                <a:ea typeface="Calibri" pitchFamily="34" charset="-122"/>
-                <a:cs typeface="Calibri" pitchFamily="34" charset="-120"/>
-              </a:rPr>
-              <a:t>Small tests: digits, clothing, 20 classes, up to 35 words; noise is simulated; two-sense data is paired by class</a:t>
-            </a:r>
-            <a:endParaRPr lang="en-US" sz="1600" dirty="0"/>
-          </a:p>
-          <a:p>
-            <a:pPr marL="342900" indent="-342900">
-              <a:spcAft>
-                <a:spcPts val="900"/>
-              </a:spcAft>
-              <a:buSzPct val="100000"/>
-              <a:buChar char="•"/>
-            </a:pPr>
-            <a:r>
-              <a:rPr lang="en-US" sz="1600" dirty="0">
-                <a:solidFill>
-                  <a:schemeClr val="tx1"/>
-                </a:solidFill>
-                <a:latin typeface="Calibri" pitchFamily="34" charset="0"/>
-                <a:ea typeface="Calibri" pitchFamily="34" charset="-122"/>
-                <a:cs typeface="Calibri" pitchFamily="34" charset="-120"/>
-              </a:rPr>
-              <a:t>Second look costs about 2.8x memory; a few steps still run on the host</a:t>
-            </a:r>
-            <a:endParaRPr lang="en-US" sz="1600" dirty="0"/>
+              <a:t>A transformer chip with the same memory matches its energy per token</a:t>
+            </a:r>
+            <a:endParaRPr lang="en-US" sz="1200" dirty="0"/>
           </a:p>
         </p:txBody>
       </p:sp>
@@ -7534,7 +7945,7 @@
                 <a:ea typeface="Cambria" pitchFamily="34" charset="-122"/>
                 <a:cs typeface="Cambria" pitchFamily="34" charset="-120"/>
               </a:rPr>
-              <a:t>Not the first, and clear about what is new</a:t>
+              <a:t>Where it is level, and where it is weaker</a:t>
             </a:r>
             <a:endParaRPr lang="en-US" sz="3000" dirty="0"/>
           </a:p>
@@ -7542,107 +7953,14 @@
       </p:sp>
       <p:sp>
         <p:nvSpPr>
-          <p:cNvPr id="3" name="card"/>
-          <p:cNvSpPr/>
+          <p:cNvPr id="3" name="Text 1"/>
+          <p:cNvSpPr txBox="1"/>
           <p:nvPr/>
         </p:nvSpPr>
         <p:spPr>
           <a:xfrm>
             <a:off x="457200" y="1280160"/>
-            <a:ext cx="4023360" cy="3200400"/>
-          </a:xfrm>
-          <a:prstGeom prst="roundRect">
-            <a:avLst>
-              <a:gd name="adj" fmla="val 2857"/>
-            </a:avLst>
-          </a:prstGeom>
-          <a:solidFill>
-            <a:schemeClr val="bg2"/>
-          </a:solidFill>
-          <a:ln w="12700">
-            <a:solidFill>
-              <a:schemeClr val="bg2"/>
-            </a:solidFill>
-            <a:prstDash val="solid"/>
-          </a:ln>
-        </p:spPr>
-      </p:sp>
-      <p:sp>
-        <p:nvSpPr>
-          <p:cNvPr id="4" name="card"/>
-          <p:cNvSpPr/>
-          <p:nvPr/>
-        </p:nvSpPr>
-        <p:spPr>
-          <a:xfrm>
-            <a:off x="4663440" y="1280160"/>
-            <a:ext cx="4023360" cy="3200400"/>
-          </a:xfrm>
-          <a:prstGeom prst="roundRect">
-            <a:avLst>
-              <a:gd name="adj" fmla="val 2857"/>
-            </a:avLst>
-          </a:prstGeom>
-          <a:solidFill>
-            <a:schemeClr val="bg2"/>
-          </a:solidFill>
-          <a:ln w="12700">
-            <a:solidFill>
-              <a:schemeClr val="bg2"/>
-            </a:solidFill>
-            <a:prstDash val="solid"/>
-          </a:ln>
-        </p:spPr>
-      </p:sp>
-      <p:sp>
-        <p:nvSpPr>
-          <p:cNvPr id="5" name="Text 3"/>
-          <p:cNvSpPr txBox="1"/>
-          <p:nvPr/>
-        </p:nvSpPr>
-        <p:spPr>
-          <a:xfrm>
-            <a:off x="640080" y="1417320"/>
-            <a:ext cx="3657600" cy="365760"/>
-          </a:xfrm>
-          <a:prstGeom prst="rect">
-            <a:avLst/>
-          </a:prstGeom>
-          <a:noFill/>
-          <a:ln/>
-        </p:spPr>
-        <p:txBody>
-          <a:bodyPr wrap="square" lIns="0" tIns="0" rIns="0" bIns="0" rtlCol="0" anchor="t"/>
-          <a:lstStyle/>
-          <a:p>
-            <a:pPr indent="0" marL="0">
-              <a:buNone/>
-            </a:pPr>
-            <a:r>
-              <a:rPr lang="en-US" sz="2000" b="1" dirty="0">
-                <a:solidFill>
-                  <a:schemeClr val="accent6"/>
-                </a:solidFill>
-                <a:latin typeface="Cambria" pitchFamily="34" charset="0"/>
-                <a:ea typeface="Cambria" pitchFamily="34" charset="-122"/>
-                <a:cs typeface="Cambria" pitchFamily="34" charset="-120"/>
-              </a:rPr>
-              <a:t>Already exists</a:t>
-            </a:r>
-            <a:endParaRPr lang="en-US" sz="2000" dirty="0"/>
-          </a:p>
-        </p:txBody>
-      </p:sp>
-      <p:sp>
-        <p:nvSpPr>
-          <p:cNvPr id="6" name="Text 4"/>
-          <p:cNvSpPr txBox="1"/>
-          <p:nvPr/>
-        </p:nvSpPr>
-        <p:spPr>
-          <a:xfrm>
-            <a:off x="640080" y="1920240"/>
-            <a:ext cx="3657600" cy="2377440"/>
+            <a:ext cx="8229600" cy="3291840"/>
           </a:xfrm>
           <a:prstGeom prst="rect">
             <a:avLst/>
@@ -7656,13 +7974,13 @@
           <a:p>
             <a:pPr marL="342900" indent="-342900">
               <a:spcAft>
-                <a:spcPts val="600"/>
+                <a:spcPts val="900"/>
               </a:spcAft>
               <a:buSzPct val="100000"/>
               <a:buChar char="•"/>
             </a:pPr>
             <a:r>
-              <a:rPr lang="en-US" sz="1500" dirty="0">
+              <a:rPr lang="en-US" sz="1600" dirty="0">
                 <a:solidFill>
                   <a:schemeClr val="tx1"/>
                 </a:solidFill>
@@ -7670,20 +7988,20 @@
                 <a:ea typeface="Calibri" pitchFamily="34" charset="-122"/>
                 <a:cs typeface="Calibri" pitchFamily="34" charset="-120"/>
               </a:rPr>
-              <a:t>Hyperdimensional-computing accelerators</a:t>
-            </a:r>
-            <a:endParaRPr lang="en-US" sz="1500" dirty="0"/>
+              <a:t>Nothing is measured on hardware yet: every chip number is simulated</a:t>
+            </a:r>
+            <a:endParaRPr lang="en-US" sz="1600" dirty="0"/>
           </a:p>
           <a:p>
             <a:pPr marL="342900" indent="-342900">
               <a:spcAft>
-                <a:spcPts val="600"/>
+                <a:spcPts val="900"/>
               </a:spcAft>
               <a:buSzPct val="100000"/>
               <a:buChar char="•"/>
             </a:pPr>
             <a:r>
-              <a:rPr lang="en-US" sz="1500" dirty="0">
+              <a:rPr lang="en-US" sz="1600" dirty="0">
                 <a:solidFill>
                   <a:schemeClr val="tx1"/>
                 </a:solidFill>
@@ -7691,17 +8009,20 @@
                 <a:ea typeface="Calibri" pitchFamily="34" charset="-122"/>
                 <a:cs typeface="Calibri" pitchFamily="34" charset="-120"/>
               </a:rPr>
-              <a:t>Intel Loihi 2, TrueNorth, SpiNNaker (event-driven spiking chips)</a:t>
-            </a:r>
-            <a:endParaRPr lang="en-US" sz="1500" dirty="0"/>
+              <a:t>Staged clothing about 82%, 5 points below its one pass; many ideas tried</a:t>
+            </a:r>
+            <a:endParaRPr lang="en-US" sz="1600" dirty="0"/>
           </a:p>
           <a:p>
             <a:pPr marL="342900" indent="-342900">
+              <a:spcAft>
+                <a:spcPts val="900"/>
+              </a:spcAft>
               <a:buSzPct val="100000"/>
               <a:buChar char="•"/>
             </a:pPr>
             <a:r>
-              <a:rPr lang="en-US" sz="1500" dirty="0">
+              <a:rPr lang="en-US" sz="1600" dirty="0">
                 <a:solidFill>
                   <a:schemeClr val="tx1"/>
                 </a:solidFill>
@@ -7709,81 +8030,20 @@
                 <a:ea typeface="Calibri" pitchFamily="34" charset="-122"/>
                 <a:cs typeface="Calibri" pitchFamily="34" charset="-120"/>
               </a:rPr>
-              <a:t>Replay-based continual learning</a:t>
-            </a:r>
-            <a:endParaRPr lang="en-US" sz="1500" dirty="0"/>
-          </a:p>
-        </p:txBody>
-      </p:sp>
-      <p:sp>
-        <p:nvSpPr>
-          <p:cNvPr id="7" name="Text 5"/>
-          <p:cNvSpPr txBox="1"/>
-          <p:nvPr/>
-        </p:nvSpPr>
-        <p:spPr>
-          <a:xfrm>
-            <a:off x="4846320" y="1417320"/>
-            <a:ext cx="3657600" cy="365760"/>
-          </a:xfrm>
-          <a:prstGeom prst="rect">
-            <a:avLst/>
-          </a:prstGeom>
-          <a:noFill/>
-          <a:ln/>
-        </p:spPr>
-        <p:txBody>
-          <a:bodyPr wrap="square" lIns="0" tIns="0" rIns="0" bIns="0" rtlCol="0" anchor="t"/>
-          <a:lstStyle/>
-          <a:p>
-            <a:pPr indent="0" marL="0">
-              <a:buNone/>
-            </a:pPr>
-            <a:r>
-              <a:rPr lang="en-US" sz="2000" b="1" dirty="0">
-                <a:solidFill>
-                  <a:schemeClr val="accent2"/>
-                </a:solidFill>
-                <a:latin typeface="Cambria" pitchFamily="34" charset="0"/>
-                <a:ea typeface="Cambria" pitchFamily="34" charset="-122"/>
-                <a:cs typeface="Cambria" pitchFamily="34" charset="-120"/>
-              </a:rPr>
-              <a:t>What we add</a:t>
-            </a:r>
-            <a:endParaRPr lang="en-US" sz="2000" dirty="0"/>
-          </a:p>
-        </p:txBody>
-      </p:sp>
-      <p:sp>
-        <p:nvSpPr>
-          <p:cNvPr id="8" name="Text 6"/>
-          <p:cNvSpPr txBox="1"/>
-          <p:nvPr/>
-        </p:nvSpPr>
-        <p:spPr>
-          <a:xfrm>
-            <a:off x="4846320" y="1920240"/>
-            <a:ext cx="3657600" cy="2377440"/>
-          </a:xfrm>
-          <a:prstGeom prst="rect">
-            <a:avLst/>
-          </a:prstGeom>
-          <a:noFill/>
-          <a:ln/>
-        </p:spPr>
-        <p:txBody>
-          <a:bodyPr wrap="square" lIns="0" tIns="0" rIns="0" bIns="0" rtlCol="0" anchor="t"/>
-          <a:lstStyle/>
+              <a:t>A trained CNN is ahead by about 2 points on clothing when all data is available</a:t>
+            </a:r>
+            <a:endParaRPr lang="en-US" sz="1600" dirty="0"/>
+          </a:p>
           <a:p>
             <a:pPr marL="342900" indent="-342900">
               <a:spcAft>
-                <a:spcPts val="600"/>
+                <a:spcPts val="900"/>
               </a:spcAft>
               <a:buSzPct val="100000"/>
               <a:buChar char="•"/>
             </a:pPr>
             <a:r>
-              <a:rPr lang="en-US" sz="1400" dirty="0">
+              <a:rPr lang="en-US" sz="1600" dirty="0">
                 <a:solidFill>
                   <a:schemeClr val="tx1"/>
                 </a:solidFill>
@@ -7791,20 +8051,20 @@
                 <a:ea typeface="Calibri" pitchFamily="34" charset="-122"/>
                 <a:cs typeface="Calibri" pitchFamily="34" charset="-120"/>
               </a:rPr>
-              <a:t>Dreams from 10-bit counters, no stored examples</a:t>
-            </a:r>
-            <a:endParaRPr lang="en-US" sz="1400" dirty="0"/>
+              <a:t>Small tests: digits, clothing, 20 classes, up to 35 words; noise is simulated; two-sense data is paired by class</a:t>
+            </a:r>
+            <a:endParaRPr lang="en-US" sz="1600" dirty="0"/>
           </a:p>
           <a:p>
             <a:pPr marL="342900" indent="-342900">
               <a:spcAft>
-                <a:spcPts val="600"/>
+                <a:spcPts val="900"/>
               </a:spcAft>
               <a:buSzPct val="100000"/>
               <a:buChar char="•"/>
             </a:pPr>
             <a:r>
-              <a:rPr lang="en-US" sz="1400" dirty="0">
+              <a:rPr lang="en-US" sz="1600" dirty="0">
                 <a:solidFill>
                   <a:schemeClr val="tx1"/>
                 </a:solidFill>
@@ -7812,27 +8072,9 @@
                 <a:ea typeface="Calibri" pitchFamily="34" charset="-122"/>
                 <a:cs typeface="Calibri" pitchFamily="34" charset="-120"/>
               </a:rPr>
-              <a:t>A night that ends by itself; consolidation that scales with the data</a:t>
-            </a:r>
-            <a:endParaRPr lang="en-US" sz="1400" dirty="0"/>
-          </a:p>
-          <a:p>
-            <a:pPr marL="342900" indent="-342900">
-              <a:buSzPct val="100000"/>
-              <a:buChar char="•"/>
-            </a:pPr>
-            <a:r>
-              <a:rPr lang="en-US" sz="1400" dirty="0">
-                <a:solidFill>
-                  <a:schemeClr val="tx1"/>
-                </a:solidFill>
-                <a:latin typeface="Calibri" pitchFamily="34" charset="0"/>
-                <a:ea typeface="Calibri" pitchFamily="34" charset="-122"/>
-                <a:cs typeface="Calibri" pitchFamily="34" charset="-120"/>
-              </a:rPr>
-              <a:t>No multiplier or matrix, bit-exact from raw senses to decision, with grouping and thresholds on the chip</a:t>
-            </a:r>
-            <a:endParaRPr lang="en-US" sz="1400" dirty="0"/>
+              <a:t>Second look costs about 2.8x memory; a few steps still run on the host</a:t>
+            </a:r>
+            <a:endParaRPr lang="en-US" sz="1600" dirty="0"/>
           </a:p>
         </p:txBody>
       </p:sp>
@@ -7941,7 +8183,7 @@
                 <a:ea typeface="Cambria" pitchFamily="34" charset="-122"/>
                 <a:cs typeface="Cambria" pitchFamily="34" charset="-120"/>
               </a:rPr>
-              <a:t>What comes next</a:t>
+              <a:t>Not the first, and clear about what is new</a:t>
             </a:r>
             <a:endParaRPr lang="en-US" sz="3000" dirty="0"/>
           </a:p>
@@ -7955,12 +8197,12 @@
         </p:nvSpPr>
         <p:spPr>
           <a:xfrm>
-            <a:off x="457200" y="1371600"/>
-            <a:ext cx="1965960" cy="2651760"/>
+            <a:off x="457200" y="1280160"/>
+            <a:ext cx="4023360" cy="3200400"/>
           </a:xfrm>
           <a:prstGeom prst="roundRect">
             <a:avLst>
-              <a:gd name="adj" fmla="val 4651"/>
+              <a:gd name="adj" fmla="val 2857"/>
             </a:avLst>
           </a:prstGeom>
           <a:solidFill>
@@ -7976,160 +8218,18 @@
       </p:sp>
       <p:sp>
         <p:nvSpPr>
-          <p:cNvPr id="4" name="marker"/>
+          <p:cNvPr id="4" name="card"/>
           <p:cNvSpPr/>
           <p:nvPr/>
         </p:nvSpPr>
         <p:spPr>
           <a:xfrm>
-            <a:off x="594360" y="1508760"/>
-            <a:ext cx="502920" cy="502920"/>
-          </a:xfrm>
-          <a:prstGeom prst="ellipse">
-            <a:avLst/>
-          </a:prstGeom>
-          <a:solidFill>
-            <a:schemeClr val="accent3"/>
-          </a:solidFill>
-          <a:ln w="12700">
-            <a:solidFill>
-              <a:schemeClr val="accent3"/>
-            </a:solidFill>
-            <a:prstDash val="solid"/>
-          </a:ln>
-        </p:spPr>
-      </p:sp>
-      <p:sp>
-        <p:nvSpPr>
-          <p:cNvPr id="5" name="Text 3"/>
-          <p:cNvSpPr txBox="1"/>
-          <p:nvPr/>
-        </p:nvSpPr>
-        <p:spPr>
-          <a:xfrm>
-            <a:off x="594360" y="1600200"/>
-            <a:ext cx="502920" cy="365760"/>
-          </a:xfrm>
-          <a:prstGeom prst="rect">
-            <a:avLst/>
-          </a:prstGeom>
-          <a:noFill/>
-          <a:ln/>
-        </p:spPr>
-        <p:txBody>
-          <a:bodyPr wrap="square" lIns="0" tIns="0" rIns="0" bIns="0" rtlCol="0" anchor="t"/>
-          <a:lstStyle/>
-          <a:p>
-            <a:pPr algn="ctr" indent="0" marL="0">
-              <a:buNone/>
-            </a:pPr>
-            <a:r>
-              <a:rPr lang="en-US" sz="1800" b="1" dirty="0">
-                <a:solidFill>
-                  <a:schemeClr val="tx1"/>
-                </a:solidFill>
-                <a:latin typeface="Calibri" pitchFamily="34" charset="0"/>
-                <a:ea typeface="Calibri" pitchFamily="34" charset="-122"/>
-                <a:cs typeface="Calibri" pitchFamily="34" charset="-120"/>
-              </a:rPr>
-              <a:t>1</a:t>
-            </a:r>
-            <a:endParaRPr lang="en-US" sz="1800" dirty="0"/>
-          </a:p>
-        </p:txBody>
-      </p:sp>
-      <p:sp>
-        <p:nvSpPr>
-          <p:cNvPr id="6" name="Text 4"/>
-          <p:cNvSpPr txBox="1"/>
-          <p:nvPr/>
-        </p:nvSpPr>
-        <p:spPr>
-          <a:xfrm>
-            <a:off x="594360" y="2148840"/>
-            <a:ext cx="1737360" cy="365760"/>
-          </a:xfrm>
-          <a:prstGeom prst="rect">
-            <a:avLst/>
-          </a:prstGeom>
-          <a:noFill/>
-          <a:ln/>
-        </p:spPr>
-        <p:txBody>
-          <a:bodyPr wrap="square" lIns="0" tIns="0" rIns="0" bIns="0" rtlCol="0" anchor="t"/>
-          <a:lstStyle/>
-          <a:p>
-            <a:pPr indent="0" marL="0">
-              <a:buNone/>
-            </a:pPr>
-            <a:r>
-              <a:rPr lang="en-US" sz="1700" b="1" dirty="0">
-                <a:solidFill>
-                  <a:schemeClr val="tx1"/>
-                </a:solidFill>
-                <a:latin typeface="Cambria" pitchFamily="34" charset="0"/>
-                <a:ea typeface="Cambria" pitchFamily="34" charset="-122"/>
-                <a:cs typeface="Cambria" pitchFamily="34" charset="-120"/>
-              </a:rPr>
-              <a:t>Done</a:t>
-            </a:r>
-            <a:endParaRPr lang="en-US" sz="1700" dirty="0"/>
-          </a:p>
-        </p:txBody>
-      </p:sp>
-      <p:sp>
-        <p:nvSpPr>
-          <p:cNvPr id="7" name="Text 5"/>
-          <p:cNvSpPr txBox="1"/>
-          <p:nvPr/>
-        </p:nvSpPr>
-        <p:spPr>
-          <a:xfrm>
-            <a:off x="594360" y="2560320"/>
-            <a:ext cx="1737360" cy="1371600"/>
-          </a:xfrm>
-          <a:prstGeom prst="rect">
-            <a:avLst/>
-          </a:prstGeom>
-          <a:noFill/>
-          <a:ln/>
-        </p:spPr>
-        <p:txBody>
-          <a:bodyPr wrap="square" lIns="0" tIns="0" rIns="0" bIns="0" rtlCol="0" anchor="t"/>
-          <a:lstStyle/>
-          <a:p>
-            <a:pPr indent="0" marL="0">
-              <a:buNone/>
-            </a:pPr>
-            <a:r>
-              <a:rPr lang="en-US" sz="1100" dirty="0">
-                <a:solidFill>
-                  <a:schemeClr val="tx1"/>
-                </a:solidFill>
-                <a:latin typeface="Calibri" pitchFamily="34" charset="0"/>
-                <a:ea typeface="Calibri" pitchFamily="34" charset="-122"/>
-                <a:cs typeface="Calibri" pitchFamily="34" charset="-120"/>
-              </a:rPr>
-              <a:t>Model, RTL with every check passing, second look, tail memory, on-chip thresholds and grouping, scale tests</a:t>
-            </a:r>
-            <a:endParaRPr lang="en-US" sz="1100" dirty="0"/>
-          </a:p>
-        </p:txBody>
-      </p:sp>
-      <p:sp>
-        <p:nvSpPr>
-          <p:cNvPr id="8" name="card"/>
-          <p:cNvSpPr/>
-          <p:nvPr/>
-        </p:nvSpPr>
-        <p:spPr>
-          <a:xfrm>
-            <a:off x="2560320" y="1371600"/>
-            <a:ext cx="1965960" cy="2651760"/>
+            <a:off x="4663440" y="1280160"/>
+            <a:ext cx="4023360" cy="3200400"/>
           </a:xfrm>
           <a:prstGeom prst="roundRect">
             <a:avLst>
-              <a:gd name="adj" fmla="val 4651"/>
+              <a:gd name="adj" fmla="val 2857"/>
             </a:avLst>
           </a:prstGeom>
           <a:solidFill>
@@ -8145,39 +8245,14 @@
       </p:sp>
       <p:sp>
         <p:nvSpPr>
-          <p:cNvPr id="9" name="marker"/>
-          <p:cNvSpPr/>
-          <p:nvPr/>
-        </p:nvSpPr>
-        <p:spPr>
-          <a:xfrm>
-            <a:off x="2697480" y="1508760"/>
-            <a:ext cx="502920" cy="502920"/>
-          </a:xfrm>
-          <a:prstGeom prst="ellipse">
-            <a:avLst/>
-          </a:prstGeom>
-          <a:solidFill>
-            <a:schemeClr val="accent1"/>
-          </a:solidFill>
-          <a:ln w="12700">
-            <a:solidFill>
-              <a:schemeClr val="accent1"/>
-            </a:solidFill>
-            <a:prstDash val="solid"/>
-          </a:ln>
-        </p:spPr>
-      </p:sp>
-      <p:sp>
-        <p:nvSpPr>
-          <p:cNvPr id="10" name="Text 8"/>
+          <p:cNvPr id="5" name="Text 3"/>
           <p:cNvSpPr txBox="1"/>
           <p:nvPr/>
         </p:nvSpPr>
         <p:spPr>
           <a:xfrm>
-            <a:off x="2697480" y="1600200"/>
-            <a:ext cx="502920" cy="365760"/>
+            <a:off x="640080" y="1417320"/>
+            <a:ext cx="3657600" cy="365760"/>
           </a:xfrm>
           <a:prstGeom prst="rect">
             <a:avLst/>
@@ -8189,11 +8264,54 @@
           <a:bodyPr wrap="square" lIns="0" tIns="0" rIns="0" bIns="0" rtlCol="0" anchor="t"/>
           <a:lstStyle/>
           <a:p>
-            <a:pPr algn="ctr" indent="0" marL="0">
+            <a:pPr indent="0" marL="0">
               <a:buNone/>
             </a:pPr>
             <a:r>
-              <a:rPr lang="en-US" sz="1800" b="1" dirty="0">
+              <a:rPr lang="en-US" sz="2000" b="1" dirty="0">
+                <a:solidFill>
+                  <a:schemeClr val="accent6"/>
+                </a:solidFill>
+                <a:latin typeface="Cambria" pitchFamily="34" charset="0"/>
+                <a:ea typeface="Cambria" pitchFamily="34" charset="-122"/>
+                <a:cs typeface="Cambria" pitchFamily="34" charset="-120"/>
+              </a:rPr>
+              <a:t>Already exists</a:t>
+            </a:r>
+            <a:endParaRPr lang="en-US" sz="2000" dirty="0"/>
+          </a:p>
+        </p:txBody>
+      </p:sp>
+      <p:sp>
+        <p:nvSpPr>
+          <p:cNvPr id="6" name="Text 4"/>
+          <p:cNvSpPr txBox="1"/>
+          <p:nvPr/>
+        </p:nvSpPr>
+        <p:spPr>
+          <a:xfrm>
+            <a:off x="640080" y="1920240"/>
+            <a:ext cx="3657600" cy="2377440"/>
+          </a:xfrm>
+          <a:prstGeom prst="rect">
+            <a:avLst/>
+          </a:prstGeom>
+          <a:noFill/>
+          <a:ln/>
+        </p:spPr>
+        <p:txBody>
+          <a:bodyPr wrap="square" lIns="0" tIns="0" rIns="0" bIns="0" rtlCol="0" anchor="t"/>
+          <a:lstStyle/>
+          <a:p>
+            <a:pPr marL="342900" indent="-342900">
+              <a:spcAft>
+                <a:spcPts val="600"/>
+              </a:spcAft>
+              <a:buSzPct val="100000"/>
+              <a:buChar char="•"/>
+            </a:pPr>
+            <a:r>
+              <a:rPr lang="en-US" sz="1500" dirty="0">
                 <a:solidFill>
                   <a:schemeClr val="tx1"/>
                 </a:solidFill>
@@ -8201,22 +8319,61 @@
                 <a:ea typeface="Calibri" pitchFamily="34" charset="-122"/>
                 <a:cs typeface="Calibri" pitchFamily="34" charset="-120"/>
               </a:rPr>
-              <a:t>2</a:t>
-            </a:r>
-            <a:endParaRPr lang="en-US" sz="1800" dirty="0"/>
-          </a:p>
-        </p:txBody>
-      </p:sp>
-      <p:sp>
-        <p:nvSpPr>
-          <p:cNvPr id="11" name="Text 9"/>
+              <a:t>Hyperdimensional-computing accelerators</a:t>
+            </a:r>
+            <a:endParaRPr lang="en-US" sz="1500" dirty="0"/>
+          </a:p>
+          <a:p>
+            <a:pPr marL="342900" indent="-342900">
+              <a:spcAft>
+                <a:spcPts val="600"/>
+              </a:spcAft>
+              <a:buSzPct val="100000"/>
+              <a:buChar char="•"/>
+            </a:pPr>
+            <a:r>
+              <a:rPr lang="en-US" sz="1500" dirty="0">
+                <a:solidFill>
+                  <a:schemeClr val="tx1"/>
+                </a:solidFill>
+                <a:latin typeface="Calibri" pitchFamily="34" charset="0"/>
+                <a:ea typeface="Calibri" pitchFamily="34" charset="-122"/>
+                <a:cs typeface="Calibri" pitchFamily="34" charset="-120"/>
+              </a:rPr>
+              <a:t>Intel Loihi 2, TrueNorth, SpiNNaker (event-driven spiking chips)</a:t>
+            </a:r>
+            <a:endParaRPr lang="en-US" sz="1500" dirty="0"/>
+          </a:p>
+          <a:p>
+            <a:pPr marL="342900" indent="-342900">
+              <a:buSzPct val="100000"/>
+              <a:buChar char="•"/>
+            </a:pPr>
+            <a:r>
+              <a:rPr lang="en-US" sz="1500" dirty="0">
+                <a:solidFill>
+                  <a:schemeClr val="tx1"/>
+                </a:solidFill>
+                <a:latin typeface="Calibri" pitchFamily="34" charset="0"/>
+                <a:ea typeface="Calibri" pitchFamily="34" charset="-122"/>
+                <a:cs typeface="Calibri" pitchFamily="34" charset="-120"/>
+              </a:rPr>
+              <a:t>Replay-based continual learning</a:t>
+            </a:r>
+            <a:endParaRPr lang="en-US" sz="1500" dirty="0"/>
+          </a:p>
+        </p:txBody>
+      </p:sp>
+      <p:sp>
+        <p:nvSpPr>
+          <p:cNvPr id="7" name="Text 5"/>
           <p:cNvSpPr txBox="1"/>
           <p:nvPr/>
         </p:nvSpPr>
         <p:spPr>
           <a:xfrm>
-            <a:off x="2697480" y="2148840"/>
-            <a:ext cx="1737360" cy="365760"/>
+            <a:off x="4846320" y="1417320"/>
+            <a:ext cx="3657600" cy="365760"/>
           </a:xfrm>
           <a:prstGeom prst="rect">
             <a:avLst/>
@@ -8232,30 +8389,30 @@
               <a:buNone/>
             </a:pPr>
             <a:r>
-              <a:rPr lang="en-US" sz="1700" b="1" dirty="0">
-                <a:solidFill>
-                  <a:schemeClr val="tx1"/>
+              <a:rPr lang="en-US" sz="2000" b="1" dirty="0">
+                <a:solidFill>
+                  <a:schemeClr val="accent2"/>
                 </a:solidFill>
                 <a:latin typeface="Cambria" pitchFamily="34" charset="0"/>
                 <a:ea typeface="Cambria" pitchFamily="34" charset="-122"/>
                 <a:cs typeface="Cambria" pitchFamily="34" charset="-120"/>
               </a:rPr>
-              <a:t>Next</a:t>
-            </a:r>
-            <a:endParaRPr lang="en-US" sz="1700" dirty="0"/>
-          </a:p>
-        </p:txBody>
-      </p:sp>
-      <p:sp>
-        <p:nvSpPr>
-          <p:cNvPr id="12" name="Text 10"/>
+              <a:t>What we add</a:t>
+            </a:r>
+            <a:endParaRPr lang="en-US" sz="2000" dirty="0"/>
+          </a:p>
+        </p:txBody>
+      </p:sp>
+      <p:sp>
+        <p:nvSpPr>
+          <p:cNvPr id="8" name="Text 6"/>
           <p:cNvSpPr txBox="1"/>
           <p:nvPr/>
         </p:nvSpPr>
         <p:spPr>
           <a:xfrm>
-            <a:off x="2697480" y="2560320"/>
-            <a:ext cx="1737360" cy="1371600"/>
+            <a:off x="4846320" y="1920240"/>
+            <a:ext cx="3657600" cy="2377440"/>
           </a:xfrm>
           <a:prstGeom prst="rect">
             <a:avLst/>
@@ -8267,11 +8424,15 @@
           <a:bodyPr wrap="square" lIns="0" tIns="0" rIns="0" bIns="0" rtlCol="0" anchor="t"/>
           <a:lstStyle/>
           <a:p>
-            <a:pPr indent="0" marL="0">
-              <a:buNone/>
-            </a:pPr>
-            <a:r>
-              <a:rPr lang="en-US" sz="1100" dirty="0">
+            <a:pPr marL="342900" indent="-342900">
+              <a:spcAft>
+                <a:spcPts val="600"/>
+              </a:spcAft>
+              <a:buSzPct val="100000"/>
+              <a:buChar char="•"/>
+            </a:pPr>
+            <a:r>
+              <a:rPr lang="en-US" sz="1400" dirty="0">
                 <a:solidFill>
                   <a:schemeClr val="tx1"/>
                 </a:solidFill>
@@ -8279,90 +8440,20 @@
                 <a:ea typeface="Calibri" pitchFamily="34" charset="-122"/>
                 <a:cs typeface="Calibri" pitchFamily="34" charset="-120"/>
               </a:rPr>
-              <a:t>Run on the real Tang Nano: the first MEASURED numbers</a:t>
-            </a:r>
-            <a:endParaRPr lang="en-US" sz="1100" dirty="0"/>
-          </a:p>
-        </p:txBody>
-      </p:sp>
-      <p:sp>
-        <p:nvSpPr>
-          <p:cNvPr id="13" name="card"/>
-          <p:cNvSpPr/>
-          <p:nvPr/>
-        </p:nvSpPr>
-        <p:spPr>
-          <a:xfrm>
-            <a:off x="4663440" y="1371600"/>
-            <a:ext cx="1965960" cy="2651760"/>
-          </a:xfrm>
-          <a:prstGeom prst="roundRect">
-            <a:avLst>
-              <a:gd name="adj" fmla="val 4651"/>
-            </a:avLst>
-          </a:prstGeom>
-          <a:solidFill>
-            <a:schemeClr val="bg2"/>
-          </a:solidFill>
-          <a:ln w="12700">
-            <a:solidFill>
-              <a:schemeClr val="bg2"/>
-            </a:solidFill>
-            <a:prstDash val="solid"/>
-          </a:ln>
-        </p:spPr>
-      </p:sp>
-      <p:sp>
-        <p:nvSpPr>
-          <p:cNvPr id="14" name="marker"/>
-          <p:cNvSpPr/>
-          <p:nvPr/>
-        </p:nvSpPr>
-        <p:spPr>
-          <a:xfrm>
-            <a:off x="4800600" y="1508760"/>
-            <a:ext cx="502920" cy="502920"/>
-          </a:xfrm>
-          <a:prstGeom prst="ellipse">
-            <a:avLst/>
-          </a:prstGeom>
-          <a:solidFill>
-            <a:schemeClr val="accent2"/>
-          </a:solidFill>
-          <a:ln w="12700">
-            <a:solidFill>
-              <a:schemeClr val="accent2"/>
-            </a:solidFill>
-            <a:prstDash val="solid"/>
-          </a:ln>
-        </p:spPr>
-      </p:sp>
-      <p:sp>
-        <p:nvSpPr>
-          <p:cNvPr id="15" name="Text 13"/>
-          <p:cNvSpPr txBox="1"/>
-          <p:nvPr/>
-        </p:nvSpPr>
-        <p:spPr>
-          <a:xfrm>
-            <a:off x="4800600" y="1600200"/>
-            <a:ext cx="502920" cy="365760"/>
-          </a:xfrm>
-          <a:prstGeom prst="rect">
-            <a:avLst/>
-          </a:prstGeom>
-          <a:noFill/>
-          <a:ln/>
-        </p:spPr>
-        <p:txBody>
-          <a:bodyPr wrap="square" lIns="0" tIns="0" rIns="0" bIns="0" rtlCol="0" anchor="t"/>
-          <a:lstStyle/>
-          <a:p>
-            <a:pPr algn="ctr" indent="0" marL="0">
-              <a:buNone/>
-            </a:pPr>
-            <a:r>
-              <a:rPr lang="en-US" sz="1800" b="1" dirty="0">
+              <a:t>Dreams from 10-bit counters, no stored examples</a:t>
+            </a:r>
+            <a:endParaRPr lang="en-US" sz="1400" dirty="0"/>
+          </a:p>
+          <a:p>
+            <a:pPr marL="342900" indent="-342900">
+              <a:spcAft>
+                <a:spcPts val="600"/>
+              </a:spcAft>
+              <a:buSzPct val="100000"/>
+              <a:buChar char="•"/>
+            </a:pPr>
+            <a:r>
+              <a:rPr lang="en-US" sz="1400" dirty="0">
                 <a:solidFill>
                   <a:schemeClr val="tx1"/>
                 </a:solidFill>
@@ -8370,77 +8461,17 @@
                 <a:ea typeface="Calibri" pitchFamily="34" charset="-122"/>
                 <a:cs typeface="Calibri" pitchFamily="34" charset="-120"/>
               </a:rPr>
-              <a:t>3</a:t>
-            </a:r>
-            <a:endParaRPr lang="en-US" sz="1800" dirty="0"/>
-          </a:p>
-        </p:txBody>
-      </p:sp>
-      <p:sp>
-        <p:nvSpPr>
-          <p:cNvPr id="16" name="Text 14"/>
-          <p:cNvSpPr txBox="1"/>
-          <p:nvPr/>
-        </p:nvSpPr>
-        <p:spPr>
-          <a:xfrm>
-            <a:off x="4800600" y="2148840"/>
-            <a:ext cx="1737360" cy="365760"/>
-          </a:xfrm>
-          <a:prstGeom prst="rect">
-            <a:avLst/>
-          </a:prstGeom>
-          <a:noFill/>
-          <a:ln/>
-        </p:spPr>
-        <p:txBody>
-          <a:bodyPr wrap="square" lIns="0" tIns="0" rIns="0" bIns="0" rtlCol="0" anchor="t"/>
-          <a:lstStyle/>
-          <a:p>
-            <a:pPr indent="0" marL="0">
-              <a:buNone/>
-            </a:pPr>
-            <a:r>
-              <a:rPr lang="en-US" sz="1700" b="1" dirty="0">
-                <a:solidFill>
-                  <a:schemeClr val="tx1"/>
-                </a:solidFill>
-                <a:latin typeface="Cambria" pitchFamily="34" charset="0"/>
-                <a:ea typeface="Cambria" pitchFamily="34" charset="-122"/>
-                <a:cs typeface="Cambria" pitchFamily="34" charset="-120"/>
-              </a:rPr>
-              <a:t>Then</a:t>
-            </a:r>
-            <a:endParaRPr lang="en-US" sz="1700" dirty="0"/>
-          </a:p>
-        </p:txBody>
-      </p:sp>
-      <p:sp>
-        <p:nvSpPr>
-          <p:cNvPr id="17" name="Text 15"/>
-          <p:cNvSpPr txBox="1"/>
-          <p:nvPr/>
-        </p:nvSpPr>
-        <p:spPr>
-          <a:xfrm>
-            <a:off x="4800600" y="2560320"/>
-            <a:ext cx="1737360" cy="1371600"/>
-          </a:xfrm>
-          <a:prstGeom prst="rect">
-            <a:avLst/>
-          </a:prstGeom>
-          <a:noFill/>
-          <a:ln/>
-        </p:spPr>
-        <p:txBody>
-          <a:bodyPr wrap="square" lIns="0" tIns="0" rIns="0" bIns="0" rtlCol="0" anchor="t"/>
-          <a:lstStyle/>
-          <a:p>
-            <a:pPr indent="0" marL="0">
-              <a:buNone/>
-            </a:pPr>
-            <a:r>
-              <a:rPr lang="en-US" sz="1100" dirty="0">
+              <a:t>A night that ends by itself; consolidation that scales with the data</a:t>
+            </a:r>
+            <a:endParaRPr lang="en-US" sz="1400" dirty="0"/>
+          </a:p>
+          <a:p>
+            <a:pPr marL="342900" indent="-342900">
+              <a:buSzPct val="100000"/>
+              <a:buChar char="•"/>
+            </a:pPr>
+            <a:r>
+              <a:rPr lang="en-US" sz="1400" dirty="0">
                 <a:solidFill>
                   <a:schemeClr val="tx1"/>
                 </a:solidFill>
@@ -8448,215 +8479,7 @@
                 <a:ea typeface="Calibri" pitchFamily="34" charset="-122"/>
                 <a:cs typeface="Calibri" pitchFamily="34" charset="-120"/>
               </a:rPr>
-              <a:t>Harder tests: larger vocabulary, real recorded noise, a harder image set</a:t>
-            </a:r>
-            <a:endParaRPr lang="en-US" sz="1100" dirty="0"/>
-          </a:p>
-        </p:txBody>
-      </p:sp>
-      <p:sp>
-        <p:nvSpPr>
-          <p:cNvPr id="18" name="card"/>
-          <p:cNvSpPr/>
-          <p:nvPr/>
-        </p:nvSpPr>
-        <p:spPr>
-          <a:xfrm>
-            <a:off x="6766560" y="1371600"/>
-            <a:ext cx="1965960" cy="2651760"/>
-          </a:xfrm>
-          <a:prstGeom prst="roundRect">
-            <a:avLst>
-              <a:gd name="adj" fmla="val 4651"/>
-            </a:avLst>
-          </a:prstGeom>
-          <a:solidFill>
-            <a:schemeClr val="bg2"/>
-          </a:solidFill>
-          <a:ln w="12700">
-            <a:solidFill>
-              <a:schemeClr val="bg2"/>
-            </a:solidFill>
-            <a:prstDash val="solid"/>
-          </a:ln>
-        </p:spPr>
-      </p:sp>
-      <p:sp>
-        <p:nvSpPr>
-          <p:cNvPr id="19" name="marker"/>
-          <p:cNvSpPr/>
-          <p:nvPr/>
-        </p:nvSpPr>
-        <p:spPr>
-          <a:xfrm>
-            <a:off x="6903720" y="1508760"/>
-            <a:ext cx="502920" cy="502920"/>
-          </a:xfrm>
-          <a:prstGeom prst="ellipse">
-            <a:avLst/>
-          </a:prstGeom>
-          <a:solidFill>
-            <a:schemeClr val="accent5"/>
-          </a:solidFill>
-          <a:ln w="12700">
-            <a:solidFill>
-              <a:schemeClr val="accent5"/>
-            </a:solidFill>
-            <a:prstDash val="solid"/>
-          </a:ln>
-        </p:spPr>
-      </p:sp>
-      <p:sp>
-        <p:nvSpPr>
-          <p:cNvPr id="20" name="Text 18"/>
-          <p:cNvSpPr txBox="1"/>
-          <p:nvPr/>
-        </p:nvSpPr>
-        <p:spPr>
-          <a:xfrm>
-            <a:off x="6903720" y="1600200"/>
-            <a:ext cx="502920" cy="365760"/>
-          </a:xfrm>
-          <a:prstGeom prst="rect">
-            <a:avLst/>
-          </a:prstGeom>
-          <a:noFill/>
-          <a:ln/>
-        </p:spPr>
-        <p:txBody>
-          <a:bodyPr wrap="square" lIns="0" tIns="0" rIns="0" bIns="0" rtlCol="0" anchor="t"/>
-          <a:lstStyle/>
-          <a:p>
-            <a:pPr algn="ctr" indent="0" marL="0">
-              <a:buNone/>
-            </a:pPr>
-            <a:r>
-              <a:rPr lang="en-US" sz="1800" b="1" dirty="0">
-                <a:solidFill>
-                  <a:schemeClr val="tx1"/>
-                </a:solidFill>
-                <a:latin typeface="Calibri" pitchFamily="34" charset="0"/>
-                <a:ea typeface="Calibri" pitchFamily="34" charset="-122"/>
-                <a:cs typeface="Calibri" pitchFamily="34" charset="-120"/>
-              </a:rPr>
-              <a:t>4</a:t>
-            </a:r>
-            <a:endParaRPr lang="en-US" sz="1800" dirty="0"/>
-          </a:p>
-        </p:txBody>
-      </p:sp>
-      <p:sp>
-        <p:nvSpPr>
-          <p:cNvPr id="21" name="Text 19"/>
-          <p:cNvSpPr txBox="1"/>
-          <p:nvPr/>
-        </p:nvSpPr>
-        <p:spPr>
-          <a:xfrm>
-            <a:off x="6903720" y="2148840"/>
-            <a:ext cx="1737360" cy="365760"/>
-          </a:xfrm>
-          <a:prstGeom prst="rect">
-            <a:avLst/>
-          </a:prstGeom>
-          <a:noFill/>
-          <a:ln/>
-        </p:spPr>
-        <p:txBody>
-          <a:bodyPr wrap="square" lIns="0" tIns="0" rIns="0" bIns="0" rtlCol="0" anchor="t"/>
-          <a:lstStyle/>
-          <a:p>
-            <a:pPr indent="0" marL="0">
-              <a:buNone/>
-            </a:pPr>
-            <a:r>
-              <a:rPr lang="en-US" sz="1700" b="1" dirty="0">
-                <a:solidFill>
-                  <a:schemeClr val="tx1"/>
-                </a:solidFill>
-                <a:latin typeface="Cambria" pitchFamily="34" charset="0"/>
-                <a:ea typeface="Cambria" pitchFamily="34" charset="-122"/>
-                <a:cs typeface="Cambria" pitchFamily="34" charset="-120"/>
-              </a:rPr>
-              <a:t>Later</a:t>
-            </a:r>
-            <a:endParaRPr lang="en-US" sz="1700" dirty="0"/>
-          </a:p>
-        </p:txBody>
-      </p:sp>
-      <p:sp>
-        <p:nvSpPr>
-          <p:cNvPr id="22" name="Text 20"/>
-          <p:cNvSpPr txBox="1"/>
-          <p:nvPr/>
-        </p:nvSpPr>
-        <p:spPr>
-          <a:xfrm>
-            <a:off x="6903720" y="2560320"/>
-            <a:ext cx="1737360" cy="1371600"/>
-          </a:xfrm>
-          <a:prstGeom prst="rect">
-            <a:avLst/>
-          </a:prstGeom>
-          <a:noFill/>
-          <a:ln/>
-        </p:spPr>
-        <p:txBody>
-          <a:bodyPr wrap="square" lIns="0" tIns="0" rIns="0" bIns="0" rtlCol="0" anchor="t"/>
-          <a:lstStyle/>
-          <a:p>
-            <a:pPr indent="0" marL="0">
-              <a:buNone/>
-            </a:pPr>
-            <a:r>
-              <a:rPr lang="en-US" sz="1100" dirty="0">
-                <a:solidFill>
-                  <a:schemeClr val="tx1"/>
-                </a:solidFill>
-                <a:latin typeface="Calibri" pitchFamily="34" charset="0"/>
-                <a:ea typeface="Calibri" pitchFamily="34" charset="-122"/>
-                <a:cs typeface="Calibri" pitchFamily="34" charset="-120"/>
-              </a:rPr>
-              <a:t>Matrix-free chip for the L language model; ASIC memory for sound and the second look</a:t>
-            </a:r>
-            <a:endParaRPr lang="en-US" sz="1100" dirty="0"/>
-          </a:p>
-        </p:txBody>
-      </p:sp>
-      <p:sp>
-        <p:nvSpPr>
-          <p:cNvPr id="23" name="Text 21"/>
-          <p:cNvSpPr txBox="1"/>
-          <p:nvPr/>
-        </p:nvSpPr>
-        <p:spPr>
-          <a:xfrm>
-            <a:off x="457200" y="4206240"/>
-            <a:ext cx="8229600" cy="457200"/>
-          </a:xfrm>
-          <a:prstGeom prst="rect">
-            <a:avLst/>
-          </a:prstGeom>
-          <a:noFill/>
-          <a:ln/>
-        </p:spPr>
-        <p:txBody>
-          <a:bodyPr wrap="square" lIns="0" tIns="0" rIns="0" bIns="0" rtlCol="0" anchor="t"/>
-          <a:lstStyle/>
-          <a:p>
-            <a:pPr indent="0" marL="0">
-              <a:buNone/>
-            </a:pPr>
-            <a:r>
-              <a:rPr lang="en-US" sz="1400" dirty="0">
-                <a:solidFill>
-                  <a:schemeClr val="tx1"/>
-                </a:solidFill>
-                <a:latin typeface="Calibri" pitchFamily="34" charset="0"/>
-                <a:ea typeface="Calibri" pitchFamily="34" charset="-122"/>
-                <a:cs typeface="Calibri" pitchFamily="34" charset="-120"/>
-              </a:rPr>
-              <a:t>Horizon: a provable result within 6 to 8 months, then shrink and attract investors. No fabrication is planned yet.</a:t>
+              <a:t>No multiplier or matrix, bit-exact from raw senses to decision, with grouping and thresholds on the chip</a:t>
             </a:r>
             <a:endParaRPr lang="en-US" sz="1400" dirty="0"/>
           </a:p>
@@ -8767,7 +8590,7 @@
                 <a:ea typeface="Cambria" pitchFamily="34" charset="-122"/>
                 <a:cs typeface="Cambria" pitchFamily="34" charset="-120"/>
               </a:rPr>
-              <a:t>Two tracks toward the bigger problem</a:t>
+              <a:t>What comes next</a:t>
             </a:r>
             <a:endParaRPr lang="en-US" sz="3000" dirty="0"/>
           </a:p>
@@ -8781,12 +8604,12 @@
         </p:nvSpPr>
         <p:spPr>
           <a:xfrm>
-            <a:off x="457200" y="1280160"/>
-            <a:ext cx="4023360" cy="3291840"/>
+            <a:off x="457200" y="1371600"/>
+            <a:ext cx="1965960" cy="2651760"/>
           </a:xfrm>
           <a:prstGeom prst="roundRect">
             <a:avLst>
-              <a:gd name="adj" fmla="val 2778"/>
+              <a:gd name="adj" fmla="val 4651"/>
             </a:avLst>
           </a:prstGeom>
           <a:solidFill>
@@ -8802,18 +8625,160 @@
       </p:sp>
       <p:sp>
         <p:nvSpPr>
-          <p:cNvPr id="4" name="card"/>
+          <p:cNvPr id="4" name="marker"/>
           <p:cNvSpPr/>
           <p:nvPr/>
         </p:nvSpPr>
         <p:spPr>
           <a:xfrm>
-            <a:off x="4663440" y="1280160"/>
-            <a:ext cx="4023360" cy="3291840"/>
+            <a:off x="594360" y="1508760"/>
+            <a:ext cx="502920" cy="502920"/>
+          </a:xfrm>
+          <a:prstGeom prst="ellipse">
+            <a:avLst/>
+          </a:prstGeom>
+          <a:solidFill>
+            <a:schemeClr val="accent3"/>
+          </a:solidFill>
+          <a:ln w="12700">
+            <a:solidFill>
+              <a:schemeClr val="accent3"/>
+            </a:solidFill>
+            <a:prstDash val="solid"/>
+          </a:ln>
+        </p:spPr>
+      </p:sp>
+      <p:sp>
+        <p:nvSpPr>
+          <p:cNvPr id="5" name="Text 3"/>
+          <p:cNvSpPr txBox="1"/>
+          <p:nvPr/>
+        </p:nvSpPr>
+        <p:spPr>
+          <a:xfrm>
+            <a:off x="594360" y="1600200"/>
+            <a:ext cx="502920" cy="365760"/>
+          </a:xfrm>
+          <a:prstGeom prst="rect">
+            <a:avLst/>
+          </a:prstGeom>
+          <a:noFill/>
+          <a:ln/>
+        </p:spPr>
+        <p:txBody>
+          <a:bodyPr wrap="square" lIns="0" tIns="0" rIns="0" bIns="0" rtlCol="0" anchor="t"/>
+          <a:lstStyle/>
+          <a:p>
+            <a:pPr algn="ctr" indent="0" marL="0">
+              <a:buNone/>
+            </a:pPr>
+            <a:r>
+              <a:rPr lang="en-US" sz="1800" b="1" dirty="0">
+                <a:solidFill>
+                  <a:schemeClr val="tx1"/>
+                </a:solidFill>
+                <a:latin typeface="Calibri" pitchFamily="34" charset="0"/>
+                <a:ea typeface="Calibri" pitchFamily="34" charset="-122"/>
+                <a:cs typeface="Calibri" pitchFamily="34" charset="-120"/>
+              </a:rPr>
+              <a:t>1</a:t>
+            </a:r>
+            <a:endParaRPr lang="en-US" sz="1800" dirty="0"/>
+          </a:p>
+        </p:txBody>
+      </p:sp>
+      <p:sp>
+        <p:nvSpPr>
+          <p:cNvPr id="6" name="Text 4"/>
+          <p:cNvSpPr txBox="1"/>
+          <p:nvPr/>
+        </p:nvSpPr>
+        <p:spPr>
+          <a:xfrm>
+            <a:off x="594360" y="2148840"/>
+            <a:ext cx="1737360" cy="365760"/>
+          </a:xfrm>
+          <a:prstGeom prst="rect">
+            <a:avLst/>
+          </a:prstGeom>
+          <a:noFill/>
+          <a:ln/>
+        </p:spPr>
+        <p:txBody>
+          <a:bodyPr wrap="square" lIns="0" tIns="0" rIns="0" bIns="0" rtlCol="0" anchor="t"/>
+          <a:lstStyle/>
+          <a:p>
+            <a:pPr indent="0" marL="0">
+              <a:buNone/>
+            </a:pPr>
+            <a:r>
+              <a:rPr lang="en-US" sz="1700" b="1" dirty="0">
+                <a:solidFill>
+                  <a:schemeClr val="tx1"/>
+                </a:solidFill>
+                <a:latin typeface="Cambria" pitchFamily="34" charset="0"/>
+                <a:ea typeface="Cambria" pitchFamily="34" charset="-122"/>
+                <a:cs typeface="Cambria" pitchFamily="34" charset="-120"/>
+              </a:rPr>
+              <a:t>Done</a:t>
+            </a:r>
+            <a:endParaRPr lang="en-US" sz="1700" dirty="0"/>
+          </a:p>
+        </p:txBody>
+      </p:sp>
+      <p:sp>
+        <p:nvSpPr>
+          <p:cNvPr id="7" name="Text 5"/>
+          <p:cNvSpPr txBox="1"/>
+          <p:nvPr/>
+        </p:nvSpPr>
+        <p:spPr>
+          <a:xfrm>
+            <a:off x="594360" y="2560320"/>
+            <a:ext cx="1737360" cy="1371600"/>
+          </a:xfrm>
+          <a:prstGeom prst="rect">
+            <a:avLst/>
+          </a:prstGeom>
+          <a:noFill/>
+          <a:ln/>
+        </p:spPr>
+        <p:txBody>
+          <a:bodyPr wrap="square" lIns="0" tIns="0" rIns="0" bIns="0" rtlCol="0" anchor="t"/>
+          <a:lstStyle/>
+          <a:p>
+            <a:pPr indent="0" marL="0">
+              <a:buNone/>
+            </a:pPr>
+            <a:r>
+              <a:rPr lang="en-US" sz="1100" dirty="0">
+                <a:solidFill>
+                  <a:schemeClr val="tx1"/>
+                </a:solidFill>
+                <a:latin typeface="Calibri" pitchFamily="34" charset="0"/>
+                <a:ea typeface="Calibri" pitchFamily="34" charset="-122"/>
+                <a:cs typeface="Calibri" pitchFamily="34" charset="-120"/>
+              </a:rPr>
+              <a:t>Model, RTL with every check passing, second look, tail memory, on-chip thresholds and grouping, scale tests</a:t>
+            </a:r>
+            <a:endParaRPr lang="en-US" sz="1100" dirty="0"/>
+          </a:p>
+        </p:txBody>
+      </p:sp>
+      <p:sp>
+        <p:nvSpPr>
+          <p:cNvPr id="8" name="card"/>
+          <p:cNvSpPr/>
+          <p:nvPr/>
+        </p:nvSpPr>
+        <p:spPr>
+          <a:xfrm>
+            <a:off x="2560320" y="1371600"/>
+            <a:ext cx="1965960" cy="2651760"/>
           </a:xfrm>
           <a:prstGeom prst="roundRect">
             <a:avLst>
-              <a:gd name="adj" fmla="val 2778"/>
+              <a:gd name="adj" fmla="val 4651"/>
             </a:avLst>
           </a:prstGeom>
           <a:solidFill>
@@ -8829,14 +8794,78 @@
       </p:sp>
       <p:sp>
         <p:nvSpPr>
-          <p:cNvPr id="5" name="Text 3"/>
+          <p:cNvPr id="9" name="marker"/>
+          <p:cNvSpPr/>
+          <p:nvPr/>
+        </p:nvSpPr>
+        <p:spPr>
+          <a:xfrm>
+            <a:off x="2697480" y="1508760"/>
+            <a:ext cx="502920" cy="502920"/>
+          </a:xfrm>
+          <a:prstGeom prst="ellipse">
+            <a:avLst/>
+          </a:prstGeom>
+          <a:solidFill>
+            <a:schemeClr val="accent1"/>
+          </a:solidFill>
+          <a:ln w="12700">
+            <a:solidFill>
+              <a:schemeClr val="accent1"/>
+            </a:solidFill>
+            <a:prstDash val="solid"/>
+          </a:ln>
+        </p:spPr>
+      </p:sp>
+      <p:sp>
+        <p:nvSpPr>
+          <p:cNvPr id="10" name="Text 8"/>
           <p:cNvSpPr txBox="1"/>
           <p:nvPr/>
         </p:nvSpPr>
         <p:spPr>
           <a:xfrm>
-            <a:off x="640080" y="1389888"/>
-            <a:ext cx="3657600" cy="365760"/>
+            <a:off x="2697480" y="1600200"/>
+            <a:ext cx="502920" cy="365760"/>
+          </a:xfrm>
+          <a:prstGeom prst="rect">
+            <a:avLst/>
+          </a:prstGeom>
+          <a:noFill/>
+          <a:ln/>
+        </p:spPr>
+        <p:txBody>
+          <a:bodyPr wrap="square" lIns="0" tIns="0" rIns="0" bIns="0" rtlCol="0" anchor="t"/>
+          <a:lstStyle/>
+          <a:p>
+            <a:pPr algn="ctr" indent="0" marL="0">
+              <a:buNone/>
+            </a:pPr>
+            <a:r>
+              <a:rPr lang="en-US" sz="1800" b="1" dirty="0">
+                <a:solidFill>
+                  <a:schemeClr val="tx1"/>
+                </a:solidFill>
+                <a:latin typeface="Calibri" pitchFamily="34" charset="0"/>
+                <a:ea typeface="Calibri" pitchFamily="34" charset="-122"/>
+                <a:cs typeface="Calibri" pitchFamily="34" charset="-120"/>
+              </a:rPr>
+              <a:t>2</a:t>
+            </a:r>
+            <a:endParaRPr lang="en-US" sz="1800" dirty="0"/>
+          </a:p>
+        </p:txBody>
+      </p:sp>
+      <p:sp>
+        <p:nvSpPr>
+          <p:cNvPr id="11" name="Text 9"/>
+          <p:cNvSpPr txBox="1"/>
+          <p:nvPr/>
+        </p:nvSpPr>
+        <p:spPr>
+          <a:xfrm>
+            <a:off x="2697480" y="2148840"/>
+            <a:ext cx="1737360" cy="365760"/>
           </a:xfrm>
           <a:prstGeom prst="rect">
             <a:avLst/>
@@ -8854,13 +8883,13 @@
             <a:r>
               <a:rPr lang="en-US" sz="1700" b="1" dirty="0">
                 <a:solidFill>
-                  <a:schemeClr val="accent3"/>
+                  <a:schemeClr val="tx1"/>
                 </a:solidFill>
                 <a:latin typeface="Cambria" pitchFamily="34" charset="0"/>
                 <a:ea typeface="Cambria" pitchFamily="34" charset="-122"/>
                 <a:cs typeface="Cambria" pitchFamily="34" charset="-120"/>
               </a:rPr>
-              <a:t>Track 1: the L chip (hardware)</a:t>
+              <a:t>Next</a:t>
             </a:r>
             <a:endParaRPr lang="en-US" sz="1700" dirty="0"/>
           </a:p>
@@ -8868,14 +8897,14 @@
       </p:sp>
       <p:sp>
         <p:nvSpPr>
-          <p:cNvPr id="6" name="Text 4"/>
+          <p:cNvPr id="12" name="Text 10"/>
           <p:cNvSpPr txBox="1"/>
           <p:nvPr/>
         </p:nvSpPr>
         <p:spPr>
           <a:xfrm>
-            <a:off x="640080" y="1828800"/>
-            <a:ext cx="3657600" cy="2651760"/>
+            <a:off x="2697480" y="2560320"/>
+            <a:ext cx="1737360" cy="1371600"/>
           </a:xfrm>
           <a:prstGeom prst="rect">
             <a:avLst/>
@@ -8887,15 +8916,11 @@
           <a:bodyPr wrap="square" lIns="0" tIns="0" rIns="0" bIns="0" rtlCol="0" anchor="t"/>
           <a:lstStyle/>
           <a:p>
-            <a:pPr marL="342900" indent="-342900">
-              <a:spcAft>
-                <a:spcPts val="500"/>
-              </a:spcAft>
-              <a:buSzPct val="100000"/>
-              <a:buChar char="•"/>
-            </a:pPr>
-            <a:r>
-              <a:rPr lang="en-US" sz="1300" dirty="0">
+            <a:pPr indent="0" marL="0">
+              <a:buNone/>
+            </a:pPr>
+            <a:r>
+              <a:rPr lang="en-US" sz="1100" dirty="0">
                 <a:solidFill>
                   <a:schemeClr val="tx1"/>
                 </a:solidFill>
@@ -8903,20 +8928,90 @@
                 <a:ea typeface="Calibri" pitchFamily="34" charset="-122"/>
                 <a:cs typeface="Calibri" pitchFamily="34" charset="-120"/>
               </a:rPr>
-              <a:t>Now: verified in simulation, bit-exact RTL</a:t>
-            </a:r>
-            <a:endParaRPr lang="en-US" sz="1300" dirty="0"/>
-          </a:p>
-          <a:p>
-            <a:pPr marL="342900" indent="-342900">
-              <a:spcAft>
-                <a:spcPts val="500"/>
-              </a:spcAft>
-              <a:buSzPct val="100000"/>
-              <a:buChar char="•"/>
-            </a:pPr>
-            <a:r>
-              <a:rPr lang="en-US" sz="1300" dirty="0">
+              <a:t>Run on the real Tang Nano: the first MEASURED numbers</a:t>
+            </a:r>
+            <a:endParaRPr lang="en-US" sz="1100" dirty="0"/>
+          </a:p>
+        </p:txBody>
+      </p:sp>
+      <p:sp>
+        <p:nvSpPr>
+          <p:cNvPr id="13" name="card"/>
+          <p:cNvSpPr/>
+          <p:nvPr/>
+        </p:nvSpPr>
+        <p:spPr>
+          <a:xfrm>
+            <a:off x="4663440" y="1371600"/>
+            <a:ext cx="1965960" cy="2651760"/>
+          </a:xfrm>
+          <a:prstGeom prst="roundRect">
+            <a:avLst>
+              <a:gd name="adj" fmla="val 4651"/>
+            </a:avLst>
+          </a:prstGeom>
+          <a:solidFill>
+            <a:schemeClr val="bg2"/>
+          </a:solidFill>
+          <a:ln w="12700">
+            <a:solidFill>
+              <a:schemeClr val="bg2"/>
+            </a:solidFill>
+            <a:prstDash val="solid"/>
+          </a:ln>
+        </p:spPr>
+      </p:sp>
+      <p:sp>
+        <p:nvSpPr>
+          <p:cNvPr id="14" name="marker"/>
+          <p:cNvSpPr/>
+          <p:nvPr/>
+        </p:nvSpPr>
+        <p:spPr>
+          <a:xfrm>
+            <a:off x="4800600" y="1508760"/>
+            <a:ext cx="502920" cy="502920"/>
+          </a:xfrm>
+          <a:prstGeom prst="ellipse">
+            <a:avLst/>
+          </a:prstGeom>
+          <a:solidFill>
+            <a:schemeClr val="accent2"/>
+          </a:solidFill>
+          <a:ln w="12700">
+            <a:solidFill>
+              <a:schemeClr val="accent2"/>
+            </a:solidFill>
+            <a:prstDash val="solid"/>
+          </a:ln>
+        </p:spPr>
+      </p:sp>
+      <p:sp>
+        <p:nvSpPr>
+          <p:cNvPr id="15" name="Text 13"/>
+          <p:cNvSpPr txBox="1"/>
+          <p:nvPr/>
+        </p:nvSpPr>
+        <p:spPr>
+          <a:xfrm>
+            <a:off x="4800600" y="1600200"/>
+            <a:ext cx="502920" cy="365760"/>
+          </a:xfrm>
+          <a:prstGeom prst="rect">
+            <a:avLst/>
+          </a:prstGeom>
+          <a:noFill/>
+          <a:ln/>
+        </p:spPr>
+        <p:txBody>
+          <a:bodyPr wrap="square" lIns="0" tIns="0" rIns="0" bIns="0" rtlCol="0" anchor="t"/>
+          <a:lstStyle/>
+          <a:p>
+            <a:pPr algn="ctr" indent="0" marL="0">
+              <a:buNone/>
+            </a:pPr>
+            <a:r>
+              <a:rPr lang="en-US" sz="1800" b="1" dirty="0">
                 <a:solidFill>
                   <a:schemeClr val="tx1"/>
                 </a:solidFill>
@@ -8924,17 +9019,77 @@
                 <a:ea typeface="Calibri" pitchFamily="34" charset="-122"/>
                 <a:cs typeface="Calibri" pitchFamily="34" charset="-120"/>
               </a:rPr>
-              <a:t>Next: run on the Tang Nano for the first MEASURED numbers</a:t>
-            </a:r>
-            <a:endParaRPr lang="en-US" sz="1300" dirty="0"/>
-          </a:p>
-          <a:p>
-            <a:pPr marL="342900" indent="-342900">
-              <a:buSzPct val="100000"/>
-              <a:buChar char="•"/>
-            </a:pPr>
-            <a:r>
-              <a:rPr lang="en-US" sz="1300" dirty="0">
+              <a:t>3</a:t>
+            </a:r>
+            <a:endParaRPr lang="en-US" sz="1800" dirty="0"/>
+          </a:p>
+        </p:txBody>
+      </p:sp>
+      <p:sp>
+        <p:nvSpPr>
+          <p:cNvPr id="16" name="Text 14"/>
+          <p:cNvSpPr txBox="1"/>
+          <p:nvPr/>
+        </p:nvSpPr>
+        <p:spPr>
+          <a:xfrm>
+            <a:off x="4800600" y="2148840"/>
+            <a:ext cx="1737360" cy="365760"/>
+          </a:xfrm>
+          <a:prstGeom prst="rect">
+            <a:avLst/>
+          </a:prstGeom>
+          <a:noFill/>
+          <a:ln/>
+        </p:spPr>
+        <p:txBody>
+          <a:bodyPr wrap="square" lIns="0" tIns="0" rIns="0" bIns="0" rtlCol="0" anchor="t"/>
+          <a:lstStyle/>
+          <a:p>
+            <a:pPr indent="0" marL="0">
+              <a:buNone/>
+            </a:pPr>
+            <a:r>
+              <a:rPr lang="en-US" sz="1700" b="1" dirty="0">
+                <a:solidFill>
+                  <a:schemeClr val="tx1"/>
+                </a:solidFill>
+                <a:latin typeface="Cambria" pitchFamily="34" charset="0"/>
+                <a:ea typeface="Cambria" pitchFamily="34" charset="-122"/>
+                <a:cs typeface="Cambria" pitchFamily="34" charset="-120"/>
+              </a:rPr>
+              <a:t>Then</a:t>
+            </a:r>
+            <a:endParaRPr lang="en-US" sz="1700" dirty="0"/>
+          </a:p>
+        </p:txBody>
+      </p:sp>
+      <p:sp>
+        <p:nvSpPr>
+          <p:cNvPr id="17" name="Text 15"/>
+          <p:cNvSpPr txBox="1"/>
+          <p:nvPr/>
+        </p:nvSpPr>
+        <p:spPr>
+          <a:xfrm>
+            <a:off x="4800600" y="2560320"/>
+            <a:ext cx="1737360" cy="1371600"/>
+          </a:xfrm>
+          <a:prstGeom prst="rect">
+            <a:avLst/>
+          </a:prstGeom>
+          <a:noFill/>
+          <a:ln/>
+        </p:spPr>
+        <p:txBody>
+          <a:bodyPr wrap="square" lIns="0" tIns="0" rIns="0" bIns="0" rtlCol="0" anchor="t"/>
+          <a:lstStyle/>
+          <a:p>
+            <a:pPr indent="0" marL="0">
+              <a:buNone/>
+            </a:pPr>
+            <a:r>
+              <a:rPr lang="en-US" sz="1100" dirty="0">
                 <a:solidFill>
                   <a:schemeClr val="tx1"/>
                 </a:solidFill>
@@ -8942,22 +9097,113 @@
                 <a:ea typeface="Calibri" pitchFamily="34" charset="-122"/>
                 <a:cs typeface="Calibri" pitchFamily="34" charset="-120"/>
               </a:rPr>
-              <a:t>Then: harder tests, external memory for sound and the second look</a:t>
-            </a:r>
-            <a:endParaRPr lang="en-US" sz="1300" dirty="0"/>
-          </a:p>
-        </p:txBody>
-      </p:sp>
-      <p:sp>
-        <p:nvSpPr>
-          <p:cNvPr id="7" name="Text 5"/>
+              <a:t>Harder tests: larger vocabulary, real recorded noise, a harder image set</a:t>
+            </a:r>
+            <a:endParaRPr lang="en-US" sz="1100" dirty="0"/>
+          </a:p>
+        </p:txBody>
+      </p:sp>
+      <p:sp>
+        <p:nvSpPr>
+          <p:cNvPr id="18" name="card"/>
+          <p:cNvSpPr/>
+          <p:nvPr/>
+        </p:nvSpPr>
+        <p:spPr>
+          <a:xfrm>
+            <a:off x="6766560" y="1371600"/>
+            <a:ext cx="1965960" cy="2651760"/>
+          </a:xfrm>
+          <a:prstGeom prst="roundRect">
+            <a:avLst>
+              <a:gd name="adj" fmla="val 4651"/>
+            </a:avLst>
+          </a:prstGeom>
+          <a:solidFill>
+            <a:schemeClr val="bg2"/>
+          </a:solidFill>
+          <a:ln w="12700">
+            <a:solidFill>
+              <a:schemeClr val="bg2"/>
+            </a:solidFill>
+            <a:prstDash val="solid"/>
+          </a:ln>
+        </p:spPr>
+      </p:sp>
+      <p:sp>
+        <p:nvSpPr>
+          <p:cNvPr id="19" name="marker"/>
+          <p:cNvSpPr/>
+          <p:nvPr/>
+        </p:nvSpPr>
+        <p:spPr>
+          <a:xfrm>
+            <a:off x="6903720" y="1508760"/>
+            <a:ext cx="502920" cy="502920"/>
+          </a:xfrm>
+          <a:prstGeom prst="ellipse">
+            <a:avLst/>
+          </a:prstGeom>
+          <a:solidFill>
+            <a:schemeClr val="accent5"/>
+          </a:solidFill>
+          <a:ln w="12700">
+            <a:solidFill>
+              <a:schemeClr val="accent5"/>
+            </a:solidFill>
+            <a:prstDash val="solid"/>
+          </a:ln>
+        </p:spPr>
+      </p:sp>
+      <p:sp>
+        <p:nvSpPr>
+          <p:cNvPr id="20" name="Text 18"/>
           <p:cNvSpPr txBox="1"/>
           <p:nvPr/>
         </p:nvSpPr>
         <p:spPr>
           <a:xfrm>
-            <a:off x="4846320" y="1389888"/>
-            <a:ext cx="3657600" cy="365760"/>
+            <a:off x="6903720" y="1600200"/>
+            <a:ext cx="502920" cy="365760"/>
+          </a:xfrm>
+          <a:prstGeom prst="rect">
+            <a:avLst/>
+          </a:prstGeom>
+          <a:noFill/>
+          <a:ln/>
+        </p:spPr>
+        <p:txBody>
+          <a:bodyPr wrap="square" lIns="0" tIns="0" rIns="0" bIns="0" rtlCol="0" anchor="t"/>
+          <a:lstStyle/>
+          <a:p>
+            <a:pPr algn="ctr" indent="0" marL="0">
+              <a:buNone/>
+            </a:pPr>
+            <a:r>
+              <a:rPr lang="en-US" sz="1800" b="1" dirty="0">
+                <a:solidFill>
+                  <a:schemeClr val="tx1"/>
+                </a:solidFill>
+                <a:latin typeface="Calibri" pitchFamily="34" charset="0"/>
+                <a:ea typeface="Calibri" pitchFamily="34" charset="-122"/>
+                <a:cs typeface="Calibri" pitchFamily="34" charset="-120"/>
+              </a:rPr>
+              <a:t>4</a:t>
+            </a:r>
+            <a:endParaRPr lang="en-US" sz="1800" dirty="0"/>
+          </a:p>
+        </p:txBody>
+      </p:sp>
+      <p:sp>
+        <p:nvSpPr>
+          <p:cNvPr id="21" name="Text 19"/>
+          <p:cNvSpPr txBox="1"/>
+          <p:nvPr/>
+        </p:nvSpPr>
+        <p:spPr>
+          <a:xfrm>
+            <a:off x="6903720" y="2148840"/>
+            <a:ext cx="1737360" cy="365760"/>
           </a:xfrm>
           <a:prstGeom prst="rect">
             <a:avLst/>
@@ -8975,13 +9221,13 @@
             <a:r>
               <a:rPr lang="en-US" sz="1700" b="1" dirty="0">
                 <a:solidFill>
-                  <a:schemeClr val="accent2"/>
+                  <a:schemeClr val="tx1"/>
                 </a:solidFill>
                 <a:latin typeface="Cambria" pitchFamily="34" charset="0"/>
                 <a:ea typeface="Cambria" pitchFamily="34" charset="-122"/>
                 <a:cs typeface="Cambria" pitchFamily="34" charset="-120"/>
               </a:rPr>
-              <a:t>Track 2: the L AI model (later)</a:t>
+              <a:t>Later</a:t>
             </a:r>
             <a:endParaRPr lang="en-US" sz="1700" dirty="0"/>
           </a:p>
@@ -8989,14 +9235,14 @@
       </p:sp>
       <p:sp>
         <p:nvSpPr>
-          <p:cNvPr id="8" name="Text 6"/>
+          <p:cNvPr id="22" name="Text 20"/>
           <p:cNvSpPr txBox="1"/>
           <p:nvPr/>
         </p:nvSpPr>
         <p:spPr>
           <a:xfrm>
-            <a:off x="4846320" y="1828800"/>
-            <a:ext cx="3657600" cy="2651760"/>
+            <a:off x="6903720" y="2560320"/>
+            <a:ext cx="1737360" cy="1371600"/>
           </a:xfrm>
           <a:prstGeom prst="rect">
             <a:avLst/>
@@ -9008,15 +9254,11 @@
           <a:bodyPr wrap="square" lIns="0" tIns="0" rIns="0" bIns="0" rtlCol="0" anchor="t"/>
           <a:lstStyle/>
           <a:p>
-            <a:pPr marL="342900" indent="-342900">
-              <a:spcAft>
-                <a:spcPts val="400"/>
-              </a:spcAft>
-              <a:buSzPct val="100000"/>
-              <a:buChar char="•"/>
-            </a:pPr>
-            <a:r>
-              <a:rPr lang="en-US" sz="1200" dirty="0">
+            <a:pPr indent="0" marL="0">
+              <a:buNone/>
+            </a:pPr>
+            <a:r>
+              <a:rPr lang="en-US" sz="1100" dirty="0">
                 <a:solidFill>
                   <a:schemeClr val="tx1"/>
                 </a:solidFill>
@@ -9024,20 +9266,38 @@
                 <a:ea typeface="Calibri" pitchFamily="34" charset="-122"/>
                 <a:cs typeface="Calibri" pitchFamily="34" charset="-120"/>
               </a:rPr>
-              <a:t>Gate 1: measure the model: firing rates, ablations, seeds</a:t>
-            </a:r>
-            <a:endParaRPr lang="en-US" sz="1200" dirty="0"/>
-          </a:p>
-          <a:p>
-            <a:pPr marL="342900" indent="-342900">
-              <a:spcAft>
-                <a:spcPts val="400"/>
-              </a:spcAft>
-              <a:buSzPct val="100000"/>
-              <a:buChar char="•"/>
-            </a:pPr>
-            <a:r>
-              <a:rPr lang="en-US" sz="1200" dirty="0">
+              <a:t>Matrix-free chip for the L language model; ASIC memory for sound and the second look</a:t>
+            </a:r>
+            <a:endParaRPr lang="en-US" sz="1100" dirty="0"/>
+          </a:p>
+        </p:txBody>
+      </p:sp>
+      <p:sp>
+        <p:nvSpPr>
+          <p:cNvPr id="23" name="Text 21"/>
+          <p:cNvSpPr txBox="1"/>
+          <p:nvPr/>
+        </p:nvSpPr>
+        <p:spPr>
+          <a:xfrm>
+            <a:off x="457200" y="4206240"/>
+            <a:ext cx="8229600" cy="457200"/>
+          </a:xfrm>
+          <a:prstGeom prst="rect">
+            <a:avLst/>
+          </a:prstGeom>
+          <a:noFill/>
+          <a:ln/>
+        </p:spPr>
+        <p:txBody>
+          <a:bodyPr wrap="square" lIns="0" tIns="0" rIns="0" bIns="0" rtlCol="0" anchor="t"/>
+          <a:lstStyle/>
+          <a:p>
+            <a:pPr indent="0" marL="0">
+              <a:buNone/>
+            </a:pPr>
+            <a:r>
+              <a:rPr lang="en-US" sz="1400" dirty="0">
                 <a:solidFill>
                   <a:schemeClr val="tx1"/>
                 </a:solidFill>
@@ -9045,87 +9305,9 @@
                 <a:ea typeface="Calibri" pitchFamily="34" charset="-122"/>
                 <a:cs typeface="Calibri" pitchFamily="34" charset="-120"/>
               </a:rPr>
-              <a:t>Gate 2: fused GPU baseline; stop if a GPU is already close</a:t>
-            </a:r>
-            <a:endParaRPr lang="en-US" sz="1200" dirty="0"/>
-          </a:p>
-          <a:p>
-            <a:pPr marL="342900" indent="-342900">
-              <a:spcAft>
-                <a:spcPts val="400"/>
-              </a:spcAft>
-              <a:buSzPct val="100000"/>
-              <a:buChar char="•"/>
-            </a:pPr>
-            <a:r>
-              <a:rPr lang="en-US" sz="1200" dirty="0">
-                <a:solidFill>
-                  <a:schemeClr val="tx1"/>
-                </a:solidFill>
-                <a:latin typeface="Calibri" pitchFamily="34" charset="0"/>
-                <a:ea typeface="Calibri" pitchFamily="34" charset="-122"/>
-                <a:cs typeface="Calibri" pitchFamily="34" charset="-120"/>
-              </a:rPr>
-              <a:t>Gate 3: matrix-free version keeps its quality</a:t>
-            </a:r>
-            <a:endParaRPr lang="en-US" sz="1200" dirty="0"/>
-          </a:p>
-          <a:p>
-            <a:pPr marL="342900" indent="-342900">
-              <a:buSzPct val="100000"/>
-              <a:buChar char="•"/>
-            </a:pPr>
-            <a:r>
-              <a:rPr lang="en-US" sz="1200" dirty="0">
-                <a:solidFill>
-                  <a:schemeClr val="tx1"/>
-                </a:solidFill>
-                <a:latin typeface="Calibri" pitchFamily="34" charset="0"/>
-                <a:ea typeface="Calibri" pitchFamily="34" charset="-122"/>
-                <a:cs typeface="Calibri" pitchFamily="34" charset="-120"/>
-              </a:rPr>
-              <a:t>Then: simulator and FPGA; study memory: can constant-size state and event-driven reads move work from scarce HBM to cheaper DRAM or SRAM? (a question, not a claim)</a:t>
-            </a:r>
-            <a:endParaRPr lang="en-US" sz="1200" dirty="0"/>
-          </a:p>
-        </p:txBody>
-      </p:sp>
-      <p:sp>
-        <p:nvSpPr>
-          <p:cNvPr id="9" name="Text 7"/>
-          <p:cNvSpPr txBox="1"/>
-          <p:nvPr/>
-        </p:nvSpPr>
-        <p:spPr>
-          <a:xfrm>
-            <a:off x="457200" y="4617720"/>
-            <a:ext cx="8229600" cy="274320"/>
-          </a:xfrm>
-          <a:prstGeom prst="rect">
-            <a:avLst/>
-          </a:prstGeom>
-          <a:noFill/>
-          <a:ln/>
-        </p:spPr>
-        <p:txBody>
-          <a:bodyPr wrap="square" lIns="0" tIns="0" rIns="0" bIns="0" rtlCol="0" anchor="t"/>
-          <a:lstStyle/>
-          <a:p>
-            <a:pPr indent="0" marL="0">
-              <a:buNone/>
-            </a:pPr>
-            <a:r>
-              <a:rPr lang="en-US" sz="1100" dirty="0">
-                <a:solidFill>
-                  <a:schemeClr val="accent6"/>
-                </a:solidFill>
-                <a:latin typeface="Calibri" pitchFamily="34" charset="0"/>
-                <a:ea typeface="Calibri" pitchFamily="34" charset="-122"/>
-                <a:cs typeface="Calibri" pitchFamily="34" charset="-120"/>
-              </a:rPr>
-              <a:t>PLAN: the language-model track has small-scale evidence only (9M parameters).</a:t>
-            </a:r>
-            <a:endParaRPr lang="en-US" sz="1100" dirty="0"/>
+              <a:t>Horizon: a provable result within 6 to 8 months, then shrink and attract investors. No fabrication is planned yet.</a:t>
+            </a:r>
+            <a:endParaRPr lang="en-US" sz="1400" dirty="0"/>
           </a:p>
         </p:txBody>
       </p:sp>
@@ -9209,8 +9391,8 @@
         </p:nvSpPr>
         <p:spPr>
           <a:xfrm>
-            <a:off x="548640" y="1371600"/>
-            <a:ext cx="8046720" cy="1280160"/>
+            <a:off x="457200" y="274320"/>
+            <a:ext cx="8229600" cy="822960"/>
           </a:xfrm>
           <a:prstGeom prst="rect">
             <a:avLst/>
@@ -9226,30 +9408,84 @@
               <a:buNone/>
             </a:pPr>
             <a:r>
-              <a:rPr lang="en-US" sz="4000" b="1" dirty="0">
-                <a:solidFill>
-                  <a:schemeClr val="bg1"/>
+              <a:rPr lang="en-US" sz="3000" b="1" dirty="0">
+                <a:solidFill>
+                  <a:schemeClr val="tx1"/>
                 </a:solidFill>
                 <a:latin typeface="Cambria" pitchFamily="34" charset="0"/>
                 <a:ea typeface="Cambria" pitchFamily="34" charset="-122"/>
                 <a:cs typeface="Cambria" pitchFamily="34" charset="-120"/>
               </a:rPr>
-              <a:t>A chip that keeps learning</a:t>
-            </a:r>
-            <a:endParaRPr lang="en-US" sz="4000" dirty="0"/>
-          </a:p>
-        </p:txBody>
-      </p:sp>
-      <p:sp>
-        <p:nvSpPr>
-          <p:cNvPr id="3" name="Text 1"/>
+              <a:t>Two tracks toward the bigger problem</a:t>
+            </a:r>
+            <a:endParaRPr lang="en-US" sz="3000" dirty="0"/>
+          </a:p>
+        </p:txBody>
+      </p:sp>
+      <p:sp>
+        <p:nvSpPr>
+          <p:cNvPr id="3" name="card"/>
+          <p:cNvSpPr/>
+          <p:nvPr/>
+        </p:nvSpPr>
+        <p:spPr>
+          <a:xfrm>
+            <a:off x="457200" y="1280160"/>
+            <a:ext cx="4023360" cy="3291840"/>
+          </a:xfrm>
+          <a:prstGeom prst="roundRect">
+            <a:avLst>
+              <a:gd name="adj" fmla="val 2778"/>
+            </a:avLst>
+          </a:prstGeom>
+          <a:solidFill>
+            <a:schemeClr val="bg2"/>
+          </a:solidFill>
+          <a:ln w="12700">
+            <a:solidFill>
+              <a:schemeClr val="bg2"/>
+            </a:solidFill>
+            <a:prstDash val="solid"/>
+          </a:ln>
+        </p:spPr>
+      </p:sp>
+      <p:sp>
+        <p:nvSpPr>
+          <p:cNvPr id="4" name="card"/>
+          <p:cNvSpPr/>
+          <p:nvPr/>
+        </p:nvSpPr>
+        <p:spPr>
+          <a:xfrm>
+            <a:off x="4663440" y="1280160"/>
+            <a:ext cx="4023360" cy="3291840"/>
+          </a:xfrm>
+          <a:prstGeom prst="roundRect">
+            <a:avLst>
+              <a:gd name="adj" fmla="val 2778"/>
+            </a:avLst>
+          </a:prstGeom>
+          <a:solidFill>
+            <a:schemeClr val="bg2"/>
+          </a:solidFill>
+          <a:ln w="12700">
+            <a:solidFill>
+              <a:schemeClr val="bg2"/>
+            </a:solidFill>
+            <a:prstDash val="solid"/>
+          </a:ln>
+        </p:spPr>
+      </p:sp>
+      <p:sp>
+        <p:nvSpPr>
+          <p:cNvPr id="5" name="Text 3"/>
           <p:cNvSpPr txBox="1"/>
           <p:nvPr/>
         </p:nvSpPr>
         <p:spPr>
           <a:xfrm>
-            <a:off x="548640" y="2834640"/>
-            <a:ext cx="8046720" cy="914400"/>
+            <a:off x="640080" y="1389888"/>
+            <a:ext cx="3657600" cy="365760"/>
           </a:xfrm>
           <a:prstGeom prst="rect">
             <a:avLst/>
@@ -9265,30 +9501,112 @@
               <a:buNone/>
             </a:pPr>
             <a:r>
-              <a:rPr lang="en-US" sz="1800" i="1" dirty="0">
-                <a:solidFill>
-                  <a:schemeClr val="accent1"/>
+              <a:rPr lang="en-US" sz="1700" b="1" dirty="0">
+                <a:solidFill>
+                  <a:schemeClr val="accent3"/>
+                </a:solidFill>
+                <a:latin typeface="Cambria" pitchFamily="34" charset="0"/>
+                <a:ea typeface="Cambria" pitchFamily="34" charset="-122"/>
+                <a:cs typeface="Cambria" pitchFamily="34" charset="-120"/>
+              </a:rPr>
+              <a:t>Track 1: the L chip (hardware)</a:t>
+            </a:r>
+            <a:endParaRPr lang="en-US" sz="1700" dirty="0"/>
+          </a:p>
+        </p:txBody>
+      </p:sp>
+      <p:sp>
+        <p:nvSpPr>
+          <p:cNvPr id="6" name="Text 4"/>
+          <p:cNvSpPr txBox="1"/>
+          <p:nvPr/>
+        </p:nvSpPr>
+        <p:spPr>
+          <a:xfrm>
+            <a:off x="640080" y="1828800"/>
+            <a:ext cx="3657600" cy="2651760"/>
+          </a:xfrm>
+          <a:prstGeom prst="rect">
+            <a:avLst/>
+          </a:prstGeom>
+          <a:noFill/>
+          <a:ln/>
+        </p:spPr>
+        <p:txBody>
+          <a:bodyPr wrap="square" lIns="0" tIns="0" rIns="0" bIns="0" rtlCol="0" anchor="t"/>
+          <a:lstStyle/>
+          <a:p>
+            <a:pPr marL="342900" indent="-342900">
+              <a:spcAft>
+                <a:spcPts val="500"/>
+              </a:spcAft>
+              <a:buSzPct val="100000"/>
+              <a:buChar char="•"/>
+            </a:pPr>
+            <a:r>
+              <a:rPr lang="en-US" sz="1300" dirty="0">
+                <a:solidFill>
+                  <a:schemeClr val="tx1"/>
                 </a:solidFill>
                 <a:latin typeface="Calibri" pitchFamily="34" charset="0"/>
                 <a:ea typeface="Calibri" pitchFamily="34" charset="-122"/>
                 <a:cs typeface="Calibri" pitchFamily="34" charset="-120"/>
               </a:rPr>
-              <a:t>It learns in the field, keeps what it knew, shares what it learned, and needs no multiplier. It is weaker than a trained network in some places, and we have said where.</a:t>
-            </a:r>
-            <a:endParaRPr lang="en-US" sz="1800" dirty="0"/>
-          </a:p>
-        </p:txBody>
-      </p:sp>
-      <p:sp>
-        <p:nvSpPr>
-          <p:cNvPr id="4" name="Text 2"/>
+              <a:t>Now: verified in simulation, bit-exact RTL</a:t>
+            </a:r>
+            <a:endParaRPr lang="en-US" sz="1300" dirty="0"/>
+          </a:p>
+          <a:p>
+            <a:pPr marL="342900" indent="-342900">
+              <a:spcAft>
+                <a:spcPts val="500"/>
+              </a:spcAft>
+              <a:buSzPct val="100000"/>
+              <a:buChar char="•"/>
+            </a:pPr>
+            <a:r>
+              <a:rPr lang="en-US" sz="1300" dirty="0">
+                <a:solidFill>
+                  <a:schemeClr val="tx1"/>
+                </a:solidFill>
+                <a:latin typeface="Calibri" pitchFamily="34" charset="0"/>
+                <a:ea typeface="Calibri" pitchFamily="34" charset="-122"/>
+                <a:cs typeface="Calibri" pitchFamily="34" charset="-120"/>
+              </a:rPr>
+              <a:t>Next: run on the Tang Nano for the first MEASURED numbers</a:t>
+            </a:r>
+            <a:endParaRPr lang="en-US" sz="1300" dirty="0"/>
+          </a:p>
+          <a:p>
+            <a:pPr marL="342900" indent="-342900">
+              <a:buSzPct val="100000"/>
+              <a:buChar char="•"/>
+            </a:pPr>
+            <a:r>
+              <a:rPr lang="en-US" sz="1300" dirty="0">
+                <a:solidFill>
+                  <a:schemeClr val="tx1"/>
+                </a:solidFill>
+                <a:latin typeface="Calibri" pitchFamily="34" charset="0"/>
+                <a:ea typeface="Calibri" pitchFamily="34" charset="-122"/>
+                <a:cs typeface="Calibri" pitchFamily="34" charset="-120"/>
+              </a:rPr>
+              <a:t>Then: harder tests, external memory for sound and the second look</a:t>
+            </a:r>
+            <a:endParaRPr lang="en-US" sz="1300" dirty="0"/>
+          </a:p>
+        </p:txBody>
+      </p:sp>
+      <p:sp>
+        <p:nvSpPr>
+          <p:cNvPr id="7" name="Text 5"/>
           <p:cNvSpPr txBox="1"/>
           <p:nvPr/>
         </p:nvSpPr>
         <p:spPr>
           <a:xfrm>
-            <a:off x="548640" y="4023360"/>
-            <a:ext cx="8046720" cy="365760"/>
+            <a:off x="4846320" y="1389888"/>
+            <a:ext cx="3657600" cy="365760"/>
           </a:xfrm>
           <a:prstGeom prst="rect">
             <a:avLst/>
@@ -9304,17 +9622,1062 @@
               <a:buNone/>
             </a:pPr>
             <a:r>
-              <a:rPr lang="en-US" sz="2200" b="1" dirty="0">
-                <a:solidFill>
-                  <a:schemeClr val="bg1"/>
+              <a:rPr lang="en-US" sz="1700" b="1" dirty="0">
+                <a:solidFill>
+                  <a:schemeClr val="accent2"/>
                 </a:solidFill>
                 <a:latin typeface="Cambria" pitchFamily="34" charset="0"/>
                 <a:ea typeface="Cambria" pitchFamily="34" charset="-122"/>
                 <a:cs typeface="Cambria" pitchFamily="34" charset="-120"/>
               </a:rPr>
-              <a:t>Thank you. Questions?</a:t>
-            </a:r>
-            <a:endParaRPr lang="en-US" sz="2200" dirty="0"/>
+              <a:t>Track 2: the L AI model (later)</a:t>
+            </a:r>
+            <a:endParaRPr lang="en-US" sz="1700" dirty="0"/>
+          </a:p>
+        </p:txBody>
+      </p:sp>
+      <p:sp>
+        <p:nvSpPr>
+          <p:cNvPr id="8" name="Text 6"/>
+          <p:cNvSpPr txBox="1"/>
+          <p:nvPr/>
+        </p:nvSpPr>
+        <p:spPr>
+          <a:xfrm>
+            <a:off x="4846320" y="1828800"/>
+            <a:ext cx="3657600" cy="2651760"/>
+          </a:xfrm>
+          <a:prstGeom prst="rect">
+            <a:avLst/>
+          </a:prstGeom>
+          <a:noFill/>
+          <a:ln/>
+        </p:spPr>
+        <p:txBody>
+          <a:bodyPr wrap="square" lIns="0" tIns="0" rIns="0" bIns="0" rtlCol="0" anchor="t"/>
+          <a:lstStyle/>
+          <a:p>
+            <a:pPr marL="342900" indent="-342900">
+              <a:spcAft>
+                <a:spcPts val="400"/>
+              </a:spcAft>
+              <a:buSzPct val="100000"/>
+              <a:buChar char="•"/>
+            </a:pPr>
+            <a:r>
+              <a:rPr lang="en-US" sz="1200" dirty="0">
+                <a:solidFill>
+                  <a:schemeClr val="tx1"/>
+                </a:solidFill>
+                <a:latin typeface="Calibri" pitchFamily="34" charset="0"/>
+                <a:ea typeface="Calibri" pitchFamily="34" charset="-122"/>
+                <a:cs typeface="Calibri" pitchFamily="34" charset="-120"/>
+              </a:rPr>
+              <a:t>Gate 1: measure the model: firing rates, ablations, seeds</a:t>
+            </a:r>
+            <a:endParaRPr lang="en-US" sz="1200" dirty="0"/>
+          </a:p>
+          <a:p>
+            <a:pPr marL="342900" indent="-342900">
+              <a:spcAft>
+                <a:spcPts val="400"/>
+              </a:spcAft>
+              <a:buSzPct val="100000"/>
+              <a:buChar char="•"/>
+            </a:pPr>
+            <a:r>
+              <a:rPr lang="en-US" sz="1200" dirty="0">
+                <a:solidFill>
+                  <a:schemeClr val="tx1"/>
+                </a:solidFill>
+                <a:latin typeface="Calibri" pitchFamily="34" charset="0"/>
+                <a:ea typeface="Calibri" pitchFamily="34" charset="-122"/>
+                <a:cs typeface="Calibri" pitchFamily="34" charset="-120"/>
+              </a:rPr>
+              <a:t>Gate 2: fused GPU baseline; stop if a GPU is already close</a:t>
+            </a:r>
+            <a:endParaRPr lang="en-US" sz="1200" dirty="0"/>
+          </a:p>
+          <a:p>
+            <a:pPr marL="342900" indent="-342900">
+              <a:spcAft>
+                <a:spcPts val="400"/>
+              </a:spcAft>
+              <a:buSzPct val="100000"/>
+              <a:buChar char="•"/>
+            </a:pPr>
+            <a:r>
+              <a:rPr lang="en-US" sz="1200" dirty="0">
+                <a:solidFill>
+                  <a:schemeClr val="tx1"/>
+                </a:solidFill>
+                <a:latin typeface="Calibri" pitchFamily="34" charset="0"/>
+                <a:ea typeface="Calibri" pitchFamily="34" charset="-122"/>
+                <a:cs typeface="Calibri" pitchFamily="34" charset="-120"/>
+              </a:rPr>
+              <a:t>Gate 3: matrix-free version keeps its quality</a:t>
+            </a:r>
+            <a:endParaRPr lang="en-US" sz="1200" dirty="0"/>
+          </a:p>
+          <a:p>
+            <a:pPr marL="342900" indent="-342900">
+              <a:buSzPct val="100000"/>
+              <a:buChar char="•"/>
+            </a:pPr>
+            <a:r>
+              <a:rPr lang="en-US" sz="1200" dirty="0">
+                <a:solidFill>
+                  <a:schemeClr val="tx1"/>
+                </a:solidFill>
+                <a:latin typeface="Calibri" pitchFamily="34" charset="0"/>
+                <a:ea typeface="Calibri" pitchFamily="34" charset="-122"/>
+                <a:cs typeface="Calibri" pitchFamily="34" charset="-120"/>
+              </a:rPr>
+              <a:t>Then: simulator and FPGA; study memory: can constant-size state and event-driven reads move work from scarce HBM to cheaper DRAM or SRAM? (a question, not a claim)</a:t>
+            </a:r>
+            <a:endParaRPr lang="en-US" sz="1200" dirty="0"/>
+          </a:p>
+        </p:txBody>
+      </p:sp>
+      <p:sp>
+        <p:nvSpPr>
+          <p:cNvPr id="9" name="Text 7"/>
+          <p:cNvSpPr txBox="1"/>
+          <p:nvPr/>
+        </p:nvSpPr>
+        <p:spPr>
+          <a:xfrm>
+            <a:off x="457200" y="4617720"/>
+            <a:ext cx="8229600" cy="274320"/>
+          </a:xfrm>
+          <a:prstGeom prst="rect">
+            <a:avLst/>
+          </a:prstGeom>
+          <a:noFill/>
+          <a:ln/>
+        </p:spPr>
+        <p:txBody>
+          <a:bodyPr wrap="square" lIns="0" tIns="0" rIns="0" bIns="0" rtlCol="0" anchor="t"/>
+          <a:lstStyle/>
+          <a:p>
+            <a:pPr indent="0" marL="0">
+              <a:buNone/>
+            </a:pPr>
+            <a:r>
+              <a:rPr lang="en-US" sz="1100" dirty="0">
+                <a:solidFill>
+                  <a:schemeClr val="accent6"/>
+                </a:solidFill>
+                <a:latin typeface="Calibri" pitchFamily="34" charset="0"/>
+                <a:ea typeface="Calibri" pitchFamily="34" charset="-122"/>
+                <a:cs typeface="Calibri" pitchFamily="34" charset="-120"/>
+              </a:rPr>
+              <a:t>PLAN: the language-model track has small-scale evidence only (9M parameters).</a:t>
+            </a:r>
+            <a:endParaRPr lang="en-US" sz="1100" dirty="0"/>
+          </a:p>
+        </p:txBody>
+      </p:sp>
+      <p:sp>
+        <p:nvSpPr>
+          <p:cNvPr id="25" name="Slide Number Placeholder 0"/>
+          <p:cNvSpPr>
+            <a:spLocks noGrp="1"/>
+          </p:cNvSpPr>
+          <p:nvPr>
+            <p:ph type="sldNum" sz="quarter" idx="4294967295"/>
+          </p:nvPr>
+        </p:nvSpPr>
+        <p:spPr>
+          <a:xfrm>
+            <a:off x="8412480" y="4800600"/>
+            <a:ext cx="800000" cy="300000"/>
+          </a:xfrm>
+          <a:prstGeom prst="rect">
+            <a:avLst/>
+          </a:prstGeom>
+          <a:extLst>
+            <a:ext uri="{C572A759-6A51-4108-AA02-DFA0A04FC94B}">
+              <ma14:wrappingTextBoxFlag xmlns:ma14="http://schemas.microsoft.com/office/mac/drawingml/2011/main" val="0"/>
+            </a:ext>
+          </a:extLst>
+        </p:spPr>
+        <p:txBody>
+          <a:bodyPr/>
+          <a:lstStyle>
+            <a:lvl1pPr>
+              <a:defRPr sz="1000">
+                <a:solidFill>
+                  <a:schemeClr val="accent6"/>
+                </a:solidFill>
+              </a:defRPr>
+            </a:lvl1pPr>
+          </a:lstStyle>
+          <a:p>
+            <a:pPr algn="l"/>
+            <a:fld id="{F7021451-1387-4CA6-816F-3879F97B5CBC}" type="slidenum">
+              <a:rPr b="0" lang="en-US"/>
+              <a:t>18</a:t>
+            </a:fld>
+            <a:endParaRPr lang="en-US"/>
+          </a:p>
+        </p:txBody>
+      </p:sp>
+    </p:spTree>
+  </p:cSld>
+  <p:clrMapOvr>
+    <a:masterClrMapping/>
+  </p:clrMapOvr>
+</p:sld>
+</file>
+
+<file path=ppt/slides/slide19.xml><?xml version="1.0" encoding="utf-8"?>
+<p:sld xmlns:a="http://schemas.openxmlformats.org/drawingml/2006/main" xmlns:r="http://schemas.openxmlformats.org/officeDocument/2006/relationships" xmlns:p="http://schemas.openxmlformats.org/presentationml/2006/main">
+  <p:cSld name="Slide 19">
+    <p:spTree>
+      <p:nvGrpSpPr>
+        <p:cNvPr id="1" name=""/>
+        <p:cNvGrpSpPr/>
+        <p:nvPr/>
+      </p:nvGrpSpPr>
+      <p:grpSpPr>
+        <a:xfrm>
+          <a:off x="0" y="0"/>
+          <a:ext cx="0" cy="0"/>
+          <a:chOff x="0" y="0"/>
+          <a:chExt cx="0" cy="0"/>
+        </a:xfrm>
+      </p:grpSpPr>
+      <p:sp>
+        <p:nvSpPr>
+          <p:cNvPr id="2" name="Text 0"/>
+          <p:cNvSpPr/>
+          <p:nvPr>
+            <p:ph idx="100" type="title" hasCustomPrompt="1"/>
+          </p:nvPr>
+        </p:nvSpPr>
+        <p:spPr>
+          <a:xfrm>
+            <a:off x="457200" y="274320"/>
+            <a:ext cx="8229600" cy="822960"/>
+          </a:xfrm>
+          <a:prstGeom prst="rect">
+            <a:avLst/>
+          </a:prstGeom>
+          <a:noFill/>
+          <a:ln/>
+        </p:spPr>
+        <p:txBody>
+          <a:bodyPr wrap="square" lIns="0" tIns="0" rIns="0" bIns="0" rtlCol="0" anchor="ctr"/>
+          <a:lstStyle/>
+          <a:p>
+            <a:pPr algn="l" indent="0" marL="0">
+              <a:buNone/>
+            </a:pPr>
+            <a:r>
+              <a:rPr lang="en-US" sz="3000" b="1" dirty="0">
+                <a:solidFill>
+                  <a:schemeClr val="tx1"/>
+                </a:solidFill>
+                <a:latin typeface="Cambria" pitchFamily="34" charset="0"/>
+                <a:ea typeface="Cambria" pitchFamily="34" charset="-122"/>
+                <a:cs typeface="Cambria" pitchFamily="34" charset="-120"/>
+              </a:rPr>
+              <a:t>Silicon, node and size: the honest plan</a:t>
+            </a:r>
+            <a:endParaRPr lang="en-US" sz="3000" dirty="0"/>
+          </a:p>
+        </p:txBody>
+      </p:sp>
+      <p:sp>
+        <p:nvSpPr>
+          <p:cNvPr id="3" name="card"/>
+          <p:cNvSpPr/>
+          <p:nvPr/>
+        </p:nvSpPr>
+        <p:spPr>
+          <a:xfrm>
+            <a:off x="457200" y="1188720"/>
+            <a:ext cx="5212080" cy="493776"/>
+          </a:xfrm>
+          <a:prstGeom prst="roundRect">
+            <a:avLst>
+              <a:gd name="adj" fmla="val 18519"/>
+            </a:avLst>
+          </a:prstGeom>
+          <a:solidFill>
+            <a:schemeClr val="accent2"/>
+          </a:solidFill>
+          <a:ln w="12700">
+            <a:solidFill>
+              <a:schemeClr val="accent2"/>
+            </a:solidFill>
+            <a:prstDash val="solid"/>
+          </a:ln>
+        </p:spPr>
+      </p:sp>
+      <p:sp>
+        <p:nvSpPr>
+          <p:cNvPr id="4" name="Text 2"/>
+          <p:cNvSpPr txBox="1"/>
+          <p:nvPr/>
+        </p:nvSpPr>
+        <p:spPr>
+          <a:xfrm>
+            <a:off x="548640" y="1280160"/>
+            <a:ext cx="914400" cy="365760"/>
+          </a:xfrm>
+          <a:prstGeom prst="rect">
+            <a:avLst/>
+          </a:prstGeom>
+          <a:noFill/>
+          <a:ln/>
+        </p:spPr>
+        <p:txBody>
+          <a:bodyPr wrap="square" lIns="0" tIns="0" rIns="0" bIns="0" rtlCol="0" anchor="t"/>
+          <a:lstStyle/>
+          <a:p>
+            <a:pPr indent="0" marL="0">
+              <a:buNone/>
+            </a:pPr>
+            <a:r>
+              <a:rPr lang="en-US" sz="1200" b="1" dirty="0">
+                <a:solidFill>
+                  <a:schemeClr val="bg1"/>
+                </a:solidFill>
+                <a:latin typeface="Calibri" pitchFamily="34" charset="0"/>
+                <a:ea typeface="Calibri" pitchFamily="34" charset="-122"/>
+                <a:cs typeface="Calibri" pitchFamily="34" charset="-120"/>
+              </a:rPr>
+              <a:t>Node</a:t>
+            </a:r>
+            <a:endParaRPr lang="en-US" sz="1200" dirty="0"/>
+          </a:p>
+        </p:txBody>
+      </p:sp>
+      <p:sp>
+        <p:nvSpPr>
+          <p:cNvPr id="5" name="Text 3"/>
+          <p:cNvSpPr txBox="1"/>
+          <p:nvPr/>
+        </p:nvSpPr>
+        <p:spPr>
+          <a:xfrm>
+            <a:off x="1463040" y="1252728"/>
+            <a:ext cx="2377440" cy="411480"/>
+          </a:xfrm>
+          <a:prstGeom prst="rect">
+            <a:avLst/>
+          </a:prstGeom>
+          <a:noFill/>
+          <a:ln/>
+        </p:spPr>
+        <p:txBody>
+          <a:bodyPr wrap="square" lIns="0" tIns="0" rIns="0" bIns="0" rtlCol="0" anchor="t"/>
+          <a:lstStyle/>
+          <a:p>
+            <a:pPr indent="0" marL="0">
+              <a:buNone/>
+            </a:pPr>
+            <a:r>
+              <a:rPr lang="en-US" sz="1000" b="1" dirty="0">
+                <a:solidFill>
+                  <a:schemeClr val="bg1"/>
+                </a:solidFill>
+                <a:latin typeface="Calibri" pitchFamily="34" charset="0"/>
+                <a:ea typeface="Calibri" pitchFamily="34" charset="-122"/>
+                <a:cs typeface="Calibri" pitchFamily="34" charset="-120"/>
+              </a:rPr>
+              <a:t>Who uses it / access</a:t>
+            </a:r>
+            <a:endParaRPr lang="en-US" sz="1000" dirty="0"/>
+          </a:p>
+        </p:txBody>
+      </p:sp>
+      <p:sp>
+        <p:nvSpPr>
+          <p:cNvPr id="6" name="Text 4"/>
+          <p:cNvSpPr txBox="1"/>
+          <p:nvPr/>
+        </p:nvSpPr>
+        <p:spPr>
+          <a:xfrm>
+            <a:off x="3886200" y="1252728"/>
+            <a:ext cx="1737360" cy="411480"/>
+          </a:xfrm>
+          <a:prstGeom prst="rect">
+            <a:avLst/>
+          </a:prstGeom>
+          <a:noFill/>
+          <a:ln/>
+        </p:spPr>
+        <p:txBody>
+          <a:bodyPr wrap="square" lIns="0" tIns="0" rIns="0" bIns="0" rtlCol="0" anchor="t"/>
+          <a:lstStyle/>
+          <a:p>
+            <a:pPr indent="0" marL="0">
+              <a:buNone/>
+            </a:pPr>
+            <a:r>
+              <a:rPr lang="en-US" sz="1000" b="1" dirty="0">
+                <a:solidFill>
+                  <a:schemeClr val="bg1"/>
+                </a:solidFill>
+                <a:latin typeface="Calibri" pitchFamily="34" charset="0"/>
+                <a:ea typeface="Calibri" pitchFamily="34" charset="-122"/>
+                <a:cs typeface="Calibri" pitchFamily="34" charset="-120"/>
+              </a:rPr>
+              <a:t>Cost, ESTIMATED</a:t>
+            </a:r>
+            <a:endParaRPr lang="en-US" sz="1000" dirty="0"/>
+          </a:p>
+        </p:txBody>
+      </p:sp>
+      <p:sp>
+        <p:nvSpPr>
+          <p:cNvPr id="7" name="card"/>
+          <p:cNvSpPr/>
+          <p:nvPr/>
+        </p:nvSpPr>
+        <p:spPr>
+          <a:xfrm>
+            <a:off x="457200" y="1755648"/>
+            <a:ext cx="5212080" cy="493776"/>
+          </a:xfrm>
+          <a:prstGeom prst="roundRect">
+            <a:avLst>
+              <a:gd name="adj" fmla="val 18519"/>
+            </a:avLst>
+          </a:prstGeom>
+          <a:solidFill>
+            <a:schemeClr val="bg2"/>
+          </a:solidFill>
+          <a:ln w="12700">
+            <a:solidFill>
+              <a:schemeClr val="bg2"/>
+            </a:solidFill>
+            <a:prstDash val="solid"/>
+          </a:ln>
+        </p:spPr>
+      </p:sp>
+      <p:sp>
+        <p:nvSpPr>
+          <p:cNvPr id="8" name="Text 6"/>
+          <p:cNvSpPr txBox="1"/>
+          <p:nvPr/>
+        </p:nvSpPr>
+        <p:spPr>
+          <a:xfrm>
+            <a:off x="548640" y="1847088"/>
+            <a:ext cx="914400" cy="365760"/>
+          </a:xfrm>
+          <a:prstGeom prst="rect">
+            <a:avLst/>
+          </a:prstGeom>
+          <a:noFill/>
+          <a:ln/>
+        </p:spPr>
+        <p:txBody>
+          <a:bodyPr wrap="square" lIns="0" tIns="0" rIns="0" bIns="0" rtlCol="0" anchor="t"/>
+          <a:lstStyle/>
+          <a:p>
+            <a:pPr indent="0" marL="0">
+              <a:buNone/>
+            </a:pPr>
+            <a:r>
+              <a:rPr lang="en-US" sz="1200" b="1" dirty="0">
+                <a:solidFill>
+                  <a:schemeClr val="tx1"/>
+                </a:solidFill>
+                <a:latin typeface="Calibri" pitchFamily="34" charset="0"/>
+                <a:ea typeface="Calibri" pitchFamily="34" charset="-122"/>
+                <a:cs typeface="Calibri" pitchFamily="34" charset="-120"/>
+              </a:rPr>
+              <a:t>130 nm</a:t>
+            </a:r>
+            <a:endParaRPr lang="en-US" sz="1200" dirty="0"/>
+          </a:p>
+        </p:txBody>
+      </p:sp>
+      <p:sp>
+        <p:nvSpPr>
+          <p:cNvPr id="9" name="Text 7"/>
+          <p:cNvSpPr txBox="1"/>
+          <p:nvPr/>
+        </p:nvSpPr>
+        <p:spPr>
+          <a:xfrm>
+            <a:off x="1463040" y="1819656"/>
+            <a:ext cx="2377440" cy="411480"/>
+          </a:xfrm>
+          <a:prstGeom prst="rect">
+            <a:avLst/>
+          </a:prstGeom>
+          <a:noFill/>
+          <a:ln/>
+        </p:spPr>
+        <p:txBody>
+          <a:bodyPr wrap="square" lIns="0" tIns="0" rIns="0" bIns="0" rtlCol="0" anchor="t"/>
+          <a:lstStyle/>
+          <a:p>
+            <a:pPr indent="0" marL="0">
+              <a:buNone/>
+            </a:pPr>
+            <a:r>
+              <a:rPr lang="en-US" sz="1000" dirty="0">
+                <a:solidFill>
+                  <a:schemeClr val="tx1"/>
+                </a:solidFill>
+                <a:latin typeface="Calibri" pitchFamily="34" charset="0"/>
+                <a:ea typeface="Calibri" pitchFamily="34" charset="-122"/>
+                <a:cs typeface="Calibri" pitchFamily="34" charset="-120"/>
+              </a:rPr>
+              <a:t>open PDK (SKY130); prototype only, not comparable to a GPU</a:t>
+            </a:r>
+            <a:endParaRPr lang="en-US" sz="1000" dirty="0"/>
+          </a:p>
+        </p:txBody>
+      </p:sp>
+      <p:sp>
+        <p:nvSpPr>
+          <p:cNvPr id="10" name="Text 8"/>
+          <p:cNvSpPr txBox="1"/>
+          <p:nvPr/>
+        </p:nvSpPr>
+        <p:spPr>
+          <a:xfrm>
+            <a:off x="3886200" y="1819656"/>
+            <a:ext cx="1737360" cy="411480"/>
+          </a:xfrm>
+          <a:prstGeom prst="rect">
+            <a:avLst/>
+          </a:prstGeom>
+          <a:noFill/>
+          <a:ln/>
+        </p:spPr>
+        <p:txBody>
+          <a:bodyPr wrap="square" lIns="0" tIns="0" rIns="0" bIns="0" rtlCol="0" anchor="t"/>
+          <a:lstStyle/>
+          <a:p>
+            <a:pPr indent="0" marL="0">
+              <a:buNone/>
+            </a:pPr>
+            <a:r>
+              <a:rPr lang="en-US" sz="1000" dirty="0">
+                <a:solidFill>
+                  <a:schemeClr val="tx1"/>
+                </a:solidFill>
+                <a:latin typeface="Calibri" pitchFamily="34" charset="0"/>
+                <a:ea typeface="Calibri" pitchFamily="34" charset="-122"/>
+                <a:cs typeface="Calibri" pitchFamily="34" charset="-120"/>
+              </a:rPr>
+              <a:t>free flow; shuttle ~$10k-50k</a:t>
+            </a:r>
+            <a:endParaRPr lang="en-US" sz="1000" dirty="0"/>
+          </a:p>
+        </p:txBody>
+      </p:sp>
+      <p:sp>
+        <p:nvSpPr>
+          <p:cNvPr id="11" name="card"/>
+          <p:cNvSpPr/>
+          <p:nvPr/>
+        </p:nvSpPr>
+        <p:spPr>
+          <a:xfrm>
+            <a:off x="457200" y="2322576"/>
+            <a:ext cx="5212080" cy="493776"/>
+          </a:xfrm>
+          <a:prstGeom prst="roundRect">
+            <a:avLst>
+              <a:gd name="adj" fmla="val 18519"/>
+            </a:avLst>
+          </a:prstGeom>
+          <a:solidFill>
+            <a:schemeClr val="bg2"/>
+          </a:solidFill>
+          <a:ln w="12700">
+            <a:solidFill>
+              <a:schemeClr val="bg2"/>
+            </a:solidFill>
+            <a:prstDash val="solid"/>
+          </a:ln>
+        </p:spPr>
+      </p:sp>
+      <p:sp>
+        <p:nvSpPr>
+          <p:cNvPr id="12" name="Text 10"/>
+          <p:cNvSpPr txBox="1"/>
+          <p:nvPr/>
+        </p:nvSpPr>
+        <p:spPr>
+          <a:xfrm>
+            <a:off x="548640" y="2414016"/>
+            <a:ext cx="914400" cy="365760"/>
+          </a:xfrm>
+          <a:prstGeom prst="rect">
+            <a:avLst/>
+          </a:prstGeom>
+          <a:noFill/>
+          <a:ln/>
+        </p:spPr>
+        <p:txBody>
+          <a:bodyPr wrap="square" lIns="0" tIns="0" rIns="0" bIns="0" rtlCol="0" anchor="t"/>
+          <a:lstStyle/>
+          <a:p>
+            <a:pPr indent="0" marL="0">
+              <a:buNone/>
+            </a:pPr>
+            <a:r>
+              <a:rPr lang="en-US" sz="1200" b="1" dirty="0">
+                <a:solidFill>
+                  <a:schemeClr val="tx1"/>
+                </a:solidFill>
+                <a:latin typeface="Calibri" pitchFamily="34" charset="0"/>
+                <a:ea typeface="Calibri" pitchFamily="34" charset="-122"/>
+                <a:cs typeface="Calibri" pitchFamily="34" charset="-120"/>
+              </a:rPr>
+              <a:t>28-65 nm</a:t>
+            </a:r>
+            <a:endParaRPr lang="en-US" sz="1200" dirty="0"/>
+          </a:p>
+        </p:txBody>
+      </p:sp>
+      <p:sp>
+        <p:nvSpPr>
+          <p:cNvPr id="13" name="Text 11"/>
+          <p:cNvSpPr txBox="1"/>
+          <p:nvPr/>
+        </p:nvSpPr>
+        <p:spPr>
+          <a:xfrm>
+            <a:off x="1463040" y="2386584"/>
+            <a:ext cx="2377440" cy="411480"/>
+          </a:xfrm>
+          <a:prstGeom prst="rect">
+            <a:avLst/>
+          </a:prstGeom>
+          <a:noFill/>
+          <a:ln/>
+        </p:spPr>
+        <p:txBody>
+          <a:bodyPr wrap="square" lIns="0" tIns="0" rIns="0" bIns="0" rtlCol="0" anchor="t"/>
+          <a:lstStyle/>
+          <a:p>
+            <a:pPr indent="0" marL="0">
+              <a:buNone/>
+            </a:pPr>
+            <a:r>
+              <a:rPr lang="en-US" sz="1000" dirty="0">
+                <a:solidFill>
+                  <a:schemeClr val="tx1"/>
+                </a:solidFill>
+                <a:latin typeface="Calibri" pitchFamily="34" charset="0"/>
+                <a:ea typeface="Calibri" pitchFamily="34" charset="-122"/>
+                <a:cs typeface="Calibri" pitchFamily="34" charset="-120"/>
+              </a:rPr>
+              <a:t>mature; via a university or Europractice-style programme</a:t>
+            </a:r>
+            <a:endParaRPr lang="en-US" sz="1000" dirty="0"/>
+          </a:p>
+        </p:txBody>
+      </p:sp>
+      <p:sp>
+        <p:nvSpPr>
+          <p:cNvPr id="14" name="Text 12"/>
+          <p:cNvSpPr txBox="1"/>
+          <p:nvPr/>
+        </p:nvSpPr>
+        <p:spPr>
+          <a:xfrm>
+            <a:off x="3886200" y="2386584"/>
+            <a:ext cx="1737360" cy="411480"/>
+          </a:xfrm>
+          <a:prstGeom prst="rect">
+            <a:avLst/>
+          </a:prstGeom>
+          <a:noFill/>
+          <a:ln/>
+        </p:spPr>
+        <p:txBody>
+          <a:bodyPr wrap="square" lIns="0" tIns="0" rIns="0" bIns="0" rtlCol="0" anchor="t"/>
+          <a:lstStyle/>
+          <a:p>
+            <a:pPr indent="0" marL="0">
+              <a:buNone/>
+            </a:pPr>
+            <a:r>
+              <a:rPr lang="en-US" sz="1000" dirty="0">
+                <a:solidFill>
+                  <a:schemeClr val="tx1"/>
+                </a:solidFill>
+                <a:latin typeface="Calibri" pitchFamily="34" charset="0"/>
+                <a:ea typeface="Calibri" pitchFamily="34" charset="-122"/>
+                <a:cs typeface="Calibri" pitchFamily="34" charset="-120"/>
+              </a:rPr>
+              <a:t>shuttle ~$50k-300k</a:t>
+            </a:r>
+            <a:endParaRPr lang="en-US" sz="1000" dirty="0"/>
+          </a:p>
+        </p:txBody>
+      </p:sp>
+      <p:sp>
+        <p:nvSpPr>
+          <p:cNvPr id="15" name="card"/>
+          <p:cNvSpPr/>
+          <p:nvPr/>
+        </p:nvSpPr>
+        <p:spPr>
+          <a:xfrm>
+            <a:off x="457200" y="2889504"/>
+            <a:ext cx="5212080" cy="493776"/>
+          </a:xfrm>
+          <a:prstGeom prst="roundRect">
+            <a:avLst>
+              <a:gd name="adj" fmla="val 18519"/>
+            </a:avLst>
+          </a:prstGeom>
+          <a:solidFill>
+            <a:schemeClr val="bg2"/>
+          </a:solidFill>
+          <a:ln w="12700">
+            <a:solidFill>
+              <a:schemeClr val="bg2"/>
+            </a:solidFill>
+            <a:prstDash val="solid"/>
+          </a:ln>
+        </p:spPr>
+      </p:sp>
+      <p:sp>
+        <p:nvSpPr>
+          <p:cNvPr id="16" name="Text 14"/>
+          <p:cNvSpPr txBox="1"/>
+          <p:nvPr/>
+        </p:nvSpPr>
+        <p:spPr>
+          <a:xfrm>
+            <a:off x="548640" y="2980944"/>
+            <a:ext cx="914400" cy="365760"/>
+          </a:xfrm>
+          <a:prstGeom prst="rect">
+            <a:avLst/>
+          </a:prstGeom>
+          <a:noFill/>
+          <a:ln/>
+        </p:spPr>
+        <p:txBody>
+          <a:bodyPr wrap="square" lIns="0" tIns="0" rIns="0" bIns="0" rtlCol="0" anchor="t"/>
+          <a:lstStyle/>
+          <a:p>
+            <a:pPr indent="0" marL="0">
+              <a:buNone/>
+            </a:pPr>
+            <a:r>
+              <a:rPr lang="en-US" sz="1200" b="1" dirty="0">
+                <a:solidFill>
+                  <a:schemeClr val="tx1"/>
+                </a:solidFill>
+                <a:latin typeface="Calibri" pitchFamily="34" charset="0"/>
+                <a:ea typeface="Calibri" pitchFamily="34" charset="-122"/>
+                <a:cs typeface="Calibri" pitchFamily="34" charset="-120"/>
+              </a:rPr>
+              <a:t>5 nm class</a:t>
+            </a:r>
+            <a:endParaRPr lang="en-US" sz="1200" dirty="0"/>
+          </a:p>
+        </p:txBody>
+      </p:sp>
+      <p:sp>
+        <p:nvSpPr>
+          <p:cNvPr id="17" name="Text 15"/>
+          <p:cNvSpPr txBox="1"/>
+          <p:nvPr/>
+        </p:nvSpPr>
+        <p:spPr>
+          <a:xfrm>
+            <a:off x="1463040" y="2953512"/>
+            <a:ext cx="2377440" cy="411480"/>
+          </a:xfrm>
+          <a:prstGeom prst="rect">
+            <a:avLst/>
+          </a:prstGeom>
+          <a:noFill/>
+          <a:ln/>
+        </p:spPr>
+        <p:txBody>
+          <a:bodyPr wrap="square" lIns="0" tIns="0" rIns="0" bIns="0" rtlCol="0" anchor="t"/>
+          <a:lstStyle/>
+          <a:p>
+            <a:pPr indent="0" marL="0">
+              <a:buNone/>
+            </a:pPr>
+            <a:r>
+              <a:rPr lang="en-US" sz="1000" dirty="0">
+                <a:solidFill>
+                  <a:schemeClr val="tx1"/>
+                </a:solidFill>
+                <a:latin typeface="Calibri" pitchFamily="34" charset="0"/>
+                <a:ea typeface="Calibri" pitchFamily="34" charset="-122"/>
+                <a:cs typeface="Calibri" pitchFamily="34" charset="-120"/>
+              </a:rPr>
+              <a:t>today's data-centre GPUs (TSMC 4N, die up to ~814 mm2)</a:t>
+            </a:r>
+            <a:endParaRPr lang="en-US" sz="1000" dirty="0"/>
+          </a:p>
+        </p:txBody>
+      </p:sp>
+      <p:sp>
+        <p:nvSpPr>
+          <p:cNvPr id="18" name="Text 16"/>
+          <p:cNvSpPr txBox="1"/>
+          <p:nvPr/>
+        </p:nvSpPr>
+        <p:spPr>
+          <a:xfrm>
+            <a:off x="3886200" y="2953512"/>
+            <a:ext cx="1737360" cy="411480"/>
+          </a:xfrm>
+          <a:prstGeom prst="rect">
+            <a:avLst/>
+          </a:prstGeom>
+          <a:noFill/>
+          <a:ln/>
+        </p:spPr>
+        <p:txBody>
+          <a:bodyPr wrap="square" lIns="0" tIns="0" rIns="0" bIns="0" rtlCol="0" anchor="t"/>
+          <a:lstStyle/>
+          <a:p>
+            <a:pPr indent="0" marL="0">
+              <a:buNone/>
+            </a:pPr>
+            <a:r>
+              <a:rPr lang="en-US" sz="1000" dirty="0">
+                <a:solidFill>
+                  <a:schemeClr val="tx1"/>
+                </a:solidFill>
+                <a:latin typeface="Calibri" pitchFamily="34" charset="0"/>
+                <a:ea typeface="Calibri" pitchFamily="34" charset="-122"/>
+                <a:cs typeface="Calibri" pitchFamily="34" charset="-120"/>
+              </a:rPr>
+              <a:t>wafer ~$17k; design tens of $M</a:t>
+            </a:r>
+            <a:endParaRPr lang="en-US" sz="1000" dirty="0"/>
+          </a:p>
+        </p:txBody>
+      </p:sp>
+      <p:sp>
+        <p:nvSpPr>
+          <p:cNvPr id="19" name="card"/>
+          <p:cNvSpPr/>
+          <p:nvPr/>
+        </p:nvSpPr>
+        <p:spPr>
+          <a:xfrm>
+            <a:off x="5852160" y="1188720"/>
+            <a:ext cx="2834640" cy="2194560"/>
+          </a:xfrm>
+          <a:prstGeom prst="roundRect">
+            <a:avLst>
+              <a:gd name="adj" fmla="val 4167"/>
+            </a:avLst>
+          </a:prstGeom>
+          <a:solidFill>
+            <a:schemeClr val="bg2"/>
+          </a:solidFill>
+          <a:ln w="12700">
+            <a:solidFill>
+              <a:schemeClr val="bg2"/>
+            </a:solidFill>
+            <a:prstDash val="solid"/>
+          </a:ln>
+        </p:spPr>
+      </p:sp>
+      <p:sp>
+        <p:nvSpPr>
+          <p:cNvPr id="20" name="Text 18"/>
+          <p:cNvSpPr txBox="1"/>
+          <p:nvPr/>
+        </p:nvSpPr>
+        <p:spPr>
+          <a:xfrm>
+            <a:off x="5989320" y="1280160"/>
+            <a:ext cx="2560320" cy="365760"/>
+          </a:xfrm>
+          <a:prstGeom prst="rect">
+            <a:avLst/>
+          </a:prstGeom>
+          <a:noFill/>
+          <a:ln/>
+        </p:spPr>
+        <p:txBody>
+          <a:bodyPr wrap="square" lIns="0" tIns="0" rIns="0" bIns="0" rtlCol="0" anchor="t"/>
+          <a:lstStyle/>
+          <a:p>
+            <a:pPr indent="0" marL="0">
+              <a:buNone/>
+            </a:pPr>
+            <a:r>
+              <a:rPr lang="en-US" sz="1400" b="1" dirty="0">
+                <a:solidFill>
+                  <a:schemeClr val="accent3"/>
+                </a:solidFill>
+                <a:latin typeface="Cambria" pitchFamily="34" charset="0"/>
+                <a:ea typeface="Cambria" pitchFamily="34" charset="-122"/>
+                <a:cs typeface="Cambria" pitchFamily="34" charset="-120"/>
+              </a:rPr>
+              <a:t>Material: silicon CMOS</a:t>
+            </a:r>
+            <a:endParaRPr lang="en-US" sz="1400" dirty="0"/>
+          </a:p>
+        </p:txBody>
+      </p:sp>
+      <p:sp>
+        <p:nvSpPr>
+          <p:cNvPr id="21" name="Text 19"/>
+          <p:cNvSpPr txBox="1"/>
+          <p:nvPr/>
+        </p:nvSpPr>
+        <p:spPr>
+          <a:xfrm>
+            <a:off x="5989320" y="1645920"/>
+            <a:ext cx="2560320" cy="1737360"/>
+          </a:xfrm>
+          <a:prstGeom prst="rect">
+            <a:avLst/>
+          </a:prstGeom>
+          <a:noFill/>
+          <a:ln/>
+        </p:spPr>
+        <p:txBody>
+          <a:bodyPr wrap="square" lIns="0" tIns="0" rIns="0" bIns="0" rtlCol="0" anchor="t"/>
+          <a:lstStyle/>
+          <a:p>
+            <a:pPr indent="0" marL="0">
+              <a:buNone/>
+            </a:pPr>
+            <a:r>
+              <a:rPr lang="en-US" sz="1000" dirty="0">
+                <a:solidFill>
+                  <a:schemeClr val="tx1"/>
+                </a:solidFill>
+                <a:latin typeface="Calibri" pitchFamily="34" charset="0"/>
+                <a:ea typeface="Calibri" pitchFamily="34" charset="-122"/>
+                <a:cs typeface="Calibri" pitchFamily="34" charset="-120"/>
+              </a:rPr>
+              <a:t>The only practical choice for dense logic: mature, high yield, full tools. Limits: cost at advanced nodes, heat, SRAM not shrinking as fast, supply concentrated in few fabs. GaN, SiC, 2D materials and memristors are not ready for dense logic; non-volatile memory is a later option.</a:t>
+            </a:r>
+            <a:endParaRPr lang="en-US" sz="1000" dirty="0"/>
+          </a:p>
+        </p:txBody>
+      </p:sp>
+      <p:sp>
+        <p:nvSpPr>
+          <p:cNvPr id="22" name="card"/>
+          <p:cNvSpPr/>
+          <p:nvPr/>
+        </p:nvSpPr>
+        <p:spPr>
+          <a:xfrm>
+            <a:off x="457200" y="3611880"/>
+            <a:ext cx="8229600" cy="960120"/>
+          </a:xfrm>
+          <a:prstGeom prst="roundRect">
+            <a:avLst>
+              <a:gd name="adj" fmla="val 9524"/>
+            </a:avLst>
+          </a:prstGeom>
+          <a:solidFill>
+            <a:srgbClr val="FFF4DD"/>
+          </a:solidFill>
+          <a:ln w="12700">
+            <a:solidFill>
+              <a:srgbClr val="FFF4DD"/>
+            </a:solidFill>
+            <a:prstDash val="solid"/>
+          </a:ln>
+        </p:spPr>
+      </p:sp>
+      <p:sp>
+        <p:nvSpPr>
+          <p:cNvPr id="23" name="Text 21"/>
+          <p:cNvSpPr txBox="1"/>
+          <p:nvPr/>
+        </p:nvSpPr>
+        <p:spPr>
+          <a:xfrm>
+            <a:off x="640080" y="3703320"/>
+            <a:ext cx="7863840" cy="822960"/>
+          </a:xfrm>
+          <a:prstGeom prst="rect">
+            <a:avLst/>
+          </a:prstGeom>
+          <a:noFill/>
+          <a:ln/>
+        </p:spPr>
+        <p:txBody>
+          <a:bodyPr wrap="square" lIns="0" tIns="0" rIns="0" bIns="0" rtlCol="0" anchor="t"/>
+          <a:lstStyle/>
+          <a:p>
+            <a:pPr indent="0" marL="0">
+              <a:buNone/>
+            </a:pPr>
+            <a:r>
+              <a:rPr lang="en-US" sz="1200" dirty="0">
+                <a:solidFill>
+                  <a:schemeClr val="tx1"/>
+                </a:solidFill>
+                <a:latin typeface="Calibri" pitchFamily="34" charset="0"/>
+                <a:ea typeface="Calibri" pitchFamily="34" charset="-122"/>
+                <a:cs typeface="Calibri" pitchFamily="34" charset="-120"/>
+              </a:rPr>
+              <a:t>Plan: write the design node-agnostic; compare energy against GPUs at a GPU-class node using published scaling (ESTIMATED, uncertain); prove it on an FPGA; tape out at an accessible mature node when funded. A 5 nm-class chip needs tens of millions of dollars and foundry access we do not have: say so.</a:t>
+            </a:r>
+            <a:endParaRPr lang="en-US" sz="1200" dirty="0"/>
+          </a:p>
+        </p:txBody>
+      </p:sp>
+      <p:sp>
+        <p:nvSpPr>
+          <p:cNvPr id="25" name="Slide Number Placeholder 0"/>
+          <p:cNvSpPr>
+            <a:spLocks noGrp="1"/>
+          </p:cNvSpPr>
+          <p:nvPr>
+            <p:ph type="sldNum" sz="quarter" idx="4294967295"/>
+          </p:nvPr>
+        </p:nvSpPr>
+        <p:spPr>
+          <a:xfrm>
+            <a:off x="8412480" y="4800600"/>
+            <a:ext cx="800000" cy="300000"/>
+          </a:xfrm>
+          <a:prstGeom prst="rect">
+            <a:avLst/>
+          </a:prstGeom>
+          <a:extLst>
+            <a:ext uri="{C572A759-6A51-4108-AA02-DFA0A04FC94B}">
+              <ma14:wrappingTextBoxFlag xmlns:ma14="http://schemas.microsoft.com/office/mac/drawingml/2011/main" val="0"/>
+            </a:ext>
+          </a:extLst>
+        </p:spPr>
+        <p:txBody>
+          <a:bodyPr/>
+          <a:lstStyle>
+            <a:lvl1pPr>
+              <a:defRPr sz="1000">
+                <a:solidFill>
+                  <a:schemeClr val="accent6"/>
+                </a:solidFill>
+              </a:defRPr>
+            </a:lvl1pPr>
+          </a:lstStyle>
+          <a:p>
+            <a:pPr algn="l"/>
+            <a:fld id="{F7021451-1387-4CA6-816F-3879F97B5CBC}" type="slidenum">
+              <a:rPr b="0" lang="en-US"/>
+              <a:t>19</a:t>
+            </a:fld>
+            <a:endParaRPr lang="en-US"/>
           </a:p>
         </p:txBody>
       </p:sp>
@@ -9780,6 +11143,150 @@
               <a:t>2</a:t>
             </a:fld>
             <a:endParaRPr lang="en-US"/>
+          </a:p>
+        </p:txBody>
+      </p:sp>
+    </p:spTree>
+  </p:cSld>
+  <p:clrMapOvr>
+    <a:masterClrMapping/>
+  </p:clrMapOvr>
+</p:sld>
+</file>
+
+<file path=ppt/slides/slide20.xml><?xml version="1.0" encoding="utf-8"?>
+<p:sld xmlns:a="http://schemas.openxmlformats.org/drawingml/2006/main" xmlns:r="http://schemas.openxmlformats.org/officeDocument/2006/relationships" xmlns:p="http://schemas.openxmlformats.org/presentationml/2006/main">
+  <p:cSld name="Slide 20">
+    <p:spTree>
+      <p:nvGrpSpPr>
+        <p:cNvPr id="1" name=""/>
+        <p:cNvGrpSpPr/>
+        <p:nvPr/>
+      </p:nvGrpSpPr>
+      <p:grpSpPr>
+        <a:xfrm>
+          <a:off x="0" y="0"/>
+          <a:ext cx="0" cy="0"/>
+          <a:chOff x="0" y="0"/>
+          <a:chExt cx="0" cy="0"/>
+        </a:xfrm>
+      </p:grpSpPr>
+      <p:sp>
+        <p:nvSpPr>
+          <p:cNvPr id="2" name="Text 0"/>
+          <p:cNvSpPr/>
+          <p:nvPr>
+            <p:ph idx="100" type="title" hasCustomPrompt="1"/>
+          </p:nvPr>
+        </p:nvSpPr>
+        <p:spPr>
+          <a:xfrm>
+            <a:off x="548640" y="1371600"/>
+            <a:ext cx="8046720" cy="1280160"/>
+          </a:xfrm>
+          <a:prstGeom prst="rect">
+            <a:avLst/>
+          </a:prstGeom>
+          <a:noFill/>
+          <a:ln/>
+        </p:spPr>
+        <p:txBody>
+          <a:bodyPr wrap="square" lIns="0" tIns="0" rIns="0" bIns="0" rtlCol="0" anchor="ctr"/>
+          <a:lstStyle/>
+          <a:p>
+            <a:pPr algn="l" indent="0" marL="0">
+              <a:buNone/>
+            </a:pPr>
+            <a:r>
+              <a:rPr lang="en-US" sz="4000" b="1" dirty="0">
+                <a:solidFill>
+                  <a:schemeClr val="bg1"/>
+                </a:solidFill>
+                <a:latin typeface="Cambria" pitchFamily="34" charset="0"/>
+                <a:ea typeface="Cambria" pitchFamily="34" charset="-122"/>
+                <a:cs typeface="Cambria" pitchFamily="34" charset="-120"/>
+              </a:rPr>
+              <a:t>A chip that keeps learning</a:t>
+            </a:r>
+            <a:endParaRPr lang="en-US" sz="4000" dirty="0"/>
+          </a:p>
+        </p:txBody>
+      </p:sp>
+      <p:sp>
+        <p:nvSpPr>
+          <p:cNvPr id="3" name="Text 1"/>
+          <p:cNvSpPr txBox="1"/>
+          <p:nvPr/>
+        </p:nvSpPr>
+        <p:spPr>
+          <a:xfrm>
+            <a:off x="548640" y="2834640"/>
+            <a:ext cx="8046720" cy="914400"/>
+          </a:xfrm>
+          <a:prstGeom prst="rect">
+            <a:avLst/>
+          </a:prstGeom>
+          <a:noFill/>
+          <a:ln/>
+        </p:spPr>
+        <p:txBody>
+          <a:bodyPr wrap="square" lIns="0" tIns="0" rIns="0" bIns="0" rtlCol="0" anchor="t"/>
+          <a:lstStyle/>
+          <a:p>
+            <a:pPr indent="0" marL="0">
+              <a:buNone/>
+            </a:pPr>
+            <a:r>
+              <a:rPr lang="en-US" sz="1800" i="1" dirty="0">
+                <a:solidFill>
+                  <a:schemeClr val="accent1"/>
+                </a:solidFill>
+                <a:latin typeface="Calibri" pitchFamily="34" charset="0"/>
+                <a:ea typeface="Calibri" pitchFamily="34" charset="-122"/>
+                <a:cs typeface="Calibri" pitchFamily="34" charset="-120"/>
+              </a:rPr>
+              <a:t>It learns in the field, keeps what it knew, shares what it learned, and needs no multiplier. It is weaker than a trained network in some places, and we have said where.</a:t>
+            </a:r>
+            <a:endParaRPr lang="en-US" sz="1800" dirty="0"/>
+          </a:p>
+        </p:txBody>
+      </p:sp>
+      <p:sp>
+        <p:nvSpPr>
+          <p:cNvPr id="4" name="Text 2"/>
+          <p:cNvSpPr txBox="1"/>
+          <p:nvPr/>
+        </p:nvSpPr>
+        <p:spPr>
+          <a:xfrm>
+            <a:off x="548640" y="4023360"/>
+            <a:ext cx="8046720" cy="365760"/>
+          </a:xfrm>
+          <a:prstGeom prst="rect">
+            <a:avLst/>
+          </a:prstGeom>
+          <a:noFill/>
+          <a:ln/>
+        </p:spPr>
+        <p:txBody>
+          <a:bodyPr wrap="square" lIns="0" tIns="0" rIns="0" bIns="0" rtlCol="0" anchor="t"/>
+          <a:lstStyle/>
+          <a:p>
+            <a:pPr indent="0" marL="0">
+              <a:buNone/>
+            </a:pPr>
+            <a:r>
+              <a:rPr lang="en-US" sz="2200" b="1" dirty="0">
+                <a:solidFill>
+                  <a:schemeClr val="bg1"/>
+                </a:solidFill>
+                <a:latin typeface="Cambria" pitchFamily="34" charset="0"/>
+                <a:ea typeface="Cambria" pitchFamily="34" charset="-122"/>
+                <a:cs typeface="Cambria" pitchFamily="34" charset="-120"/>
+              </a:rPr>
+              <a:t>Thank you. Questions?</a:t>
+            </a:r>
+            <a:endParaRPr lang="en-US" sz="2200" dirty="0"/>
           </a:p>
         </p:txBody>
       </p:sp>

</xml_diff>